<commit_message>
Add Model Performance: broaden scam classifier + live benchmark
- Broaden the scam classifier to 7 families (digital-arrest, OTP/credential
  phishing, KYC/suspension, lottery, loan/refund, sextortion, payment pressure)
- Add labeled benchmark (backend/benchmark.py) and evaluation harness
  (backend/evaluate.py): precision/recall/F1/accuracy + false-positive rate,
  confusion matrix, per-family recall, honest misclassifications
- Live metrics endpoint GET /api/eval/metrics
- New 'Model Performance' dashboard page (KPIs, confusion matrix, per-family bars)
- Recalibrate scoring so single-signal scams are caught while keeping FPR at 0%
- Result on benchmark: precision 100%, recall 92.3%, F1 96.0%, FPR 0.0%
- Add performance slide to deck and screenshot + section to README
</commit_message>
<xml_diff>
--- a/docs/Prahari_Pitch_Deck.pptx
+++ b/docs/Prahari_Pitch_Deck.pptx
@@ -15,9 +15,10 @@
     <p:sldId id="263" r:id="rId9"/>
     <p:sldId id="264" r:id="rId10"/>
     <p:sldId id="265" r:id="rId11"/>
+    <p:sldId id="266" r:id="rId12"/>
   </p:sldIdLst>
   <p:notesMasterIdLst>
-    <p:notesMasterId r:id="rId12"/>
+    <p:notesMasterId r:id="rId13"/>
   </p:notesMasterIdLst>
   <p:sldSz cx="12188952" cy="6858000"/>
   <p:notesSz cx="6858000" cy="12188952"/>
@@ -850,6 +851,94 @@
             <a:fld id="{F7021451-1387-4CA6-816F-3879F97B5CBC}" type="slidenum">
               <a:rPr lang="en-US"/>
               <a:t>10</a:t>
+            </a:fld>
+            <a:endParaRPr lang="en-US"/>
+          </a:p>
+        </p:txBody>
+      </p:sp>
+    </p:spTree>
+    <p:extLst>
+      <p:ext uri="{BB962C8B-B14F-4D97-AF65-F5344CB8AC3E}">
+        <p14:creationId xmlns:p14="http://schemas.microsoft.com/office/powerpoint/2010/main" val="1024086991"/>
+      </p:ext>
+    </p:extLst>
+  </p:cSld>
+  <p:clrMapOvr>
+    <a:masterClrMapping/>
+  </p:clrMapOvr>
+</p:notes>
+</file>
+
+<file path=ppt/notesSlides/notesSlide11.xml><?xml version="1.0" encoding="utf-8"?>
+<p:notes xmlns:a="http://schemas.openxmlformats.org/drawingml/2006/main" xmlns:r="http://schemas.openxmlformats.org/officeDocument/2006/relationships" xmlns:p="http://schemas.openxmlformats.org/presentationml/2006/main">
+  <p:cSld>
+    <p:spTree>
+      <p:nvGrpSpPr>
+        <p:cNvPr id="1" name=""/>
+        <p:cNvGrpSpPr/>
+        <p:nvPr/>
+      </p:nvGrpSpPr>
+      <p:grpSpPr>
+        <a:xfrm>
+          <a:off x="0" y="0"/>
+          <a:ext cx="0" cy="0"/>
+          <a:chOff x="0" y="0"/>
+          <a:chExt cx="0" cy="0"/>
+        </a:xfrm>
+      </p:grpSpPr>
+      <p:sp>
+        <p:nvSpPr>
+          <p:cNvPr id="2" name="Slide Image Placeholder 1"/>
+          <p:cNvSpPr>
+            <a:spLocks noGrp="1" noRot="1" noChangeAspect="1"/>
+          </p:cNvSpPr>
+          <p:nvPr>
+            <p:ph type="sldImg"/>
+          </p:nvPr>
+        </p:nvSpPr>
+        <p:spPr/>
+      </p:sp>
+      <p:sp>
+        <p:nvSpPr>
+          <p:cNvPr id="3" name="Notes Placeholder 2"/>
+          <p:cNvSpPr>
+            <a:spLocks noGrp="1"/>
+          </p:cNvSpPr>
+          <p:nvPr>
+            <p:ph type="body" idx="1"/>
+          </p:nvPr>
+        </p:nvSpPr>
+        <p:spPr/>
+        <p:txBody>
+          <a:bodyPr/>
+          <a:lstStyle/>
+          <a:p>
+            <a:r>
+              <a:rPr lang="en-US" dirty="0"/>
+              <a:t/>
+            </a:r>
+            <a:endParaRPr lang="en-US" dirty="0"/>
+          </a:p>
+        </p:txBody>
+      </p:sp>
+      <p:sp>
+        <p:nvSpPr>
+          <p:cNvPr id="4" name="Slide Number Placeholder 3"/>
+          <p:cNvSpPr>
+            <a:spLocks noGrp="1"/>
+          </p:cNvSpPr>
+          <p:nvPr>
+            <p:ph type="sldNum" sz="quarter" idx="10"/>
+          </p:nvPr>
+        </p:nvSpPr>
+        <p:spPr/>
+        <p:txBody>
+          <a:bodyPr/>
+          <a:lstStyle/>
+          <a:p>
+            <a:fld id="{F7021451-1387-4CA6-816F-3879F97B5CBC}" type="slidenum">
+              <a:rPr lang="en-US"/>
+              <a:t>11</a:t>
             </a:fld>
             <a:endParaRPr lang="en-US"/>
           </a:p>
@@ -2353,6 +2442,534 @@
       </p:grpSpPr>
       <p:sp>
         <p:nvSpPr>
+          <p:cNvPr id="2" name="Text 0"/>
+          <p:cNvSpPr/>
+          <p:nvPr/>
+        </p:nvSpPr>
+        <p:spPr>
+          <a:xfrm>
+            <a:off x="548640" y="457200"/>
+            <a:ext cx="10972800" cy="640080"/>
+          </a:xfrm>
+          <a:prstGeom prst="rect">
+            <a:avLst/>
+          </a:prstGeom>
+          <a:noFill/>
+          <a:ln/>
+        </p:spPr>
+        <p:txBody>
+          <a:bodyPr wrap="square" rtlCol="0" anchor="ctr"/>
+          <a:lstStyle/>
+          <a:p>
+            <a:pPr indent="0" marL="0">
+              <a:buNone/>
+            </a:pPr>
+            <a:r>
+              <a:rPr lang="en-US" sz="2800" b="1" dirty="0">
+                <a:solidFill>
+                  <a:srgbClr val="E6EDF6"/>
+                </a:solidFill>
+                <a:latin typeface="Cambria" pitchFamily="34" charset="0"/>
+                <a:ea typeface="Cambria" pitchFamily="34" charset="-122"/>
+                <a:cs typeface="Cambria" pitchFamily="34" charset="-120"/>
+              </a:rPr>
+              <a:t>Built today · production tomorrow</a:t>
+            </a:r>
+            <a:endParaRPr lang="en-US" sz="2800" dirty="0"/>
+          </a:p>
+        </p:txBody>
+      </p:sp>
+      <p:sp>
+        <p:nvSpPr>
+          <p:cNvPr id="3" name="Shape 1"/>
+          <p:cNvSpPr/>
+          <p:nvPr/>
+        </p:nvSpPr>
+        <p:spPr>
+          <a:xfrm>
+            <a:off x="548640" y="1463040"/>
+            <a:ext cx="5486400" cy="4114800"/>
+          </a:xfrm>
+          <a:prstGeom prst="roundRect">
+            <a:avLst>
+              <a:gd name="adj" fmla="val 1778"/>
+            </a:avLst>
+          </a:prstGeom>
+          <a:solidFill>
+            <a:srgbClr val="121826"/>
+          </a:solidFill>
+          <a:ln w="12700">
+            <a:solidFill>
+              <a:srgbClr val="1F2A3D"/>
+            </a:solidFill>
+            <a:prstDash val="solid"/>
+          </a:ln>
+          <a:effectLst>
+            <a:outerShdw sx="100000" sy="100000" kx="0" ky="0" algn="bl" rotWithShape="0" blurRad="88900" dist="38100" dir="5400000">
+              <a:srgbClr val="000000">
+                <a:alpha val="35000"/>
+              </a:srgbClr>
+            </a:outerShdw>
+          </a:effectLst>
+        </p:spPr>
+      </p:sp>
+      <p:sp>
+        <p:nvSpPr>
+          <p:cNvPr id="4" name="Text 2"/>
+          <p:cNvSpPr/>
+          <p:nvPr/>
+        </p:nvSpPr>
+        <p:spPr>
+          <a:xfrm>
+            <a:off x="777240" y="1645920"/>
+            <a:ext cx="5029200" cy="365760"/>
+          </a:xfrm>
+          <a:prstGeom prst="rect">
+            <a:avLst/>
+          </a:prstGeom>
+          <a:noFill/>
+          <a:ln/>
+        </p:spPr>
+        <p:txBody>
+          <a:bodyPr wrap="square" rtlCol="0" anchor="ctr"/>
+          <a:lstStyle/>
+          <a:p>
+            <a:pPr indent="0" marL="0">
+              <a:buNone/>
+            </a:pPr>
+            <a:r>
+              <a:rPr lang="en-US" sz="1600" b="1" dirty="0">
+                <a:solidFill>
+                  <a:srgbClr val="2ECC71"/>
+                </a:solidFill>
+                <a:latin typeface="Cambria" pitchFamily="34" charset="0"/>
+                <a:ea typeface="Cambria" pitchFamily="34" charset="-122"/>
+                <a:cs typeface="Cambria" pitchFamily="34" charset="-120"/>
+              </a:rPr>
+              <a:t>Working prototype (this build)</a:t>
+            </a:r>
+            <a:endParaRPr lang="en-US" sz="1600" dirty="0"/>
+          </a:p>
+        </p:txBody>
+      </p:sp>
+      <p:sp>
+        <p:nvSpPr>
+          <p:cNvPr id="5" name="Text 3"/>
+          <p:cNvSpPr/>
+          <p:nvPr/>
+        </p:nvSpPr>
+        <p:spPr>
+          <a:xfrm>
+            <a:off x="777240" y="2148840"/>
+            <a:ext cx="5029200" cy="3108960"/>
+          </a:xfrm>
+          <a:prstGeom prst="rect">
+            <a:avLst/>
+          </a:prstGeom>
+          <a:noFill/>
+          <a:ln/>
+        </p:spPr>
+        <p:txBody>
+          <a:bodyPr wrap="square" rtlCol="0" anchor="ctr"/>
+          <a:lstStyle/>
+          <a:p>
+            <a:pPr marL="342900" indent="-342900">
+              <a:spcAft>
+                <a:spcPts val="1000"/>
+              </a:spcAft>
+              <a:buSzPct val="100000"/>
+              <a:buChar char="•"/>
+            </a:pPr>
+            <a:r>
+              <a:rPr lang="en-US" sz="1300" dirty="0">
+                <a:solidFill>
+                  <a:srgbClr val="E6EDF6"/>
+                </a:solidFill>
+                <a:latin typeface="Calibri" pitchFamily="34" charset="0"/>
+                <a:ea typeface="Calibri" pitchFamily="34" charset="-122"/>
+                <a:cs typeface="Calibri" pitchFamily="34" charset="-120"/>
+              </a:rPr>
+              <a:t>FastAPI backend, 5 live modules, one command-centre UI.</a:t>
+            </a:r>
+            <a:endParaRPr lang="en-US" sz="1300" dirty="0"/>
+          </a:p>
+          <a:p>
+            <a:pPr marL="342900" indent="-342900">
+              <a:spcAft>
+                <a:spcPts val="1000"/>
+              </a:spcAft>
+              <a:buSzPct val="100000"/>
+              <a:buChar char="•"/>
+            </a:pPr>
+            <a:r>
+              <a:rPr lang="en-US" sz="1300" dirty="0">
+                <a:solidFill>
+                  <a:srgbClr val="E6EDF6"/>
+                </a:solidFill>
+                <a:latin typeface="Calibri" pitchFamily="34" charset="0"/>
+                <a:ea typeface="Calibri" pitchFamily="34" charset="-122"/>
+                <a:cs typeface="Calibri" pitchFamily="34" charset="-120"/>
+              </a:rPr>
+              <a:t>Explainable scam scorer + 7-feature note forensics (PIL/numpy).</a:t>
+            </a:r>
+            <a:endParaRPr lang="en-US" sz="1300" dirty="0"/>
+          </a:p>
+          <a:p>
+            <a:pPr marL="342900" indent="-342900">
+              <a:spcAft>
+                <a:spcPts val="1000"/>
+              </a:spcAft>
+              <a:buSzPct val="100000"/>
+              <a:buChar char="•"/>
+            </a:pPr>
+            <a:r>
+              <a:rPr lang="en-US" sz="1300" dirty="0">
+                <a:solidFill>
+                  <a:srgbClr val="E6EDF6"/>
+                </a:solidFill>
+                <a:latin typeface="Calibri" pitchFamily="34" charset="0"/>
+                <a:ea typeface="Calibri" pitchFamily="34" charset="-122"/>
+                <a:cs typeface="Calibri" pitchFamily="34" charset="-120"/>
+              </a:rPr>
+              <a:t>networkx graph engine with hashed intelligence packages.</a:t>
+            </a:r>
+            <a:endParaRPr lang="en-US" sz="1300" dirty="0"/>
+          </a:p>
+          <a:p>
+            <a:pPr marL="342900" indent="-342900">
+              <a:spcAft>
+                <a:spcPts val="1000"/>
+              </a:spcAft>
+              <a:buSzPct val="100000"/>
+              <a:buChar char="•"/>
+            </a:pPr>
+            <a:r>
+              <a:rPr lang="en-US" sz="1300" dirty="0">
+                <a:solidFill>
+                  <a:srgbClr val="E6EDF6"/>
+                </a:solidFill>
+                <a:latin typeface="Calibri" pitchFamily="34" charset="0"/>
+                <a:ea typeface="Calibri" pitchFamily="34" charset="-122"/>
+                <a:cs typeface="Calibri" pitchFamily="34" charset="-120"/>
+              </a:rPr>
+              <a:t>Leaflet command map + multilingual citizen chatbot.</a:t>
+            </a:r>
+            <a:endParaRPr lang="en-US" sz="1300" dirty="0"/>
+          </a:p>
+        </p:txBody>
+      </p:sp>
+      <p:sp>
+        <p:nvSpPr>
+          <p:cNvPr id="6" name="Shape 4"/>
+          <p:cNvSpPr/>
+          <p:nvPr/>
+        </p:nvSpPr>
+        <p:spPr>
+          <a:xfrm>
+            <a:off x="6263640" y="1463040"/>
+            <a:ext cx="5349240" cy="4114800"/>
+          </a:xfrm>
+          <a:prstGeom prst="roundRect">
+            <a:avLst>
+              <a:gd name="adj" fmla="val 1778"/>
+            </a:avLst>
+          </a:prstGeom>
+          <a:solidFill>
+            <a:srgbClr val="0F1420"/>
+          </a:solidFill>
+          <a:ln w="12700">
+            <a:solidFill>
+              <a:srgbClr val="1F2A3D"/>
+            </a:solidFill>
+            <a:prstDash val="solid"/>
+          </a:ln>
+          <a:effectLst>
+            <a:outerShdw sx="100000" sy="100000" kx="0" ky="0" algn="bl" rotWithShape="0" blurRad="88900" dist="38100" dir="5400000">
+              <a:srgbClr val="000000">
+                <a:alpha val="35000"/>
+              </a:srgbClr>
+            </a:outerShdw>
+          </a:effectLst>
+        </p:spPr>
+      </p:sp>
+      <p:sp>
+        <p:nvSpPr>
+          <p:cNvPr id="7" name="Text 5"/>
+          <p:cNvSpPr/>
+          <p:nvPr/>
+        </p:nvSpPr>
+        <p:spPr>
+          <a:xfrm>
+            <a:off x="6492240" y="1645920"/>
+            <a:ext cx="4937760" cy="365760"/>
+          </a:xfrm>
+          <a:prstGeom prst="rect">
+            <a:avLst/>
+          </a:prstGeom>
+          <a:noFill/>
+          <a:ln/>
+        </p:spPr>
+        <p:txBody>
+          <a:bodyPr wrap="square" rtlCol="0" anchor="ctr"/>
+          <a:lstStyle/>
+          <a:p>
+            <a:pPr indent="0" marL="0">
+              <a:buNone/>
+            </a:pPr>
+            <a:r>
+              <a:rPr lang="en-US" sz="1600" b="1" dirty="0">
+                <a:solidFill>
+                  <a:srgbClr val="3EA6FF"/>
+                </a:solidFill>
+                <a:latin typeface="Cambria" pitchFamily="34" charset="0"/>
+                <a:ea typeface="Cambria" pitchFamily="34" charset="-122"/>
+                <a:cs typeface="Cambria" pitchFamily="34" charset="-120"/>
+              </a:rPr>
+              <a:t>Production roadmap</a:t>
+            </a:r>
+            <a:endParaRPr lang="en-US" sz="1600" dirty="0"/>
+          </a:p>
+        </p:txBody>
+      </p:sp>
+      <p:sp>
+        <p:nvSpPr>
+          <p:cNvPr id="8" name="Text 6"/>
+          <p:cNvSpPr/>
+          <p:nvPr/>
+        </p:nvSpPr>
+        <p:spPr>
+          <a:xfrm>
+            <a:off x="6492240" y="2148840"/>
+            <a:ext cx="4937760" cy="3200400"/>
+          </a:xfrm>
+          <a:prstGeom prst="rect">
+            <a:avLst/>
+          </a:prstGeom>
+          <a:noFill/>
+          <a:ln/>
+        </p:spPr>
+        <p:txBody>
+          <a:bodyPr wrap="square" rtlCol="0" anchor="ctr"/>
+          <a:lstStyle/>
+          <a:p>
+            <a:pPr marL="342900" indent="-342900">
+              <a:spcAft>
+                <a:spcPts val="1000"/>
+              </a:spcAft>
+              <a:buSzPct val="100000"/>
+              <a:buChar char="•"/>
+            </a:pPr>
+            <a:r>
+              <a:rPr lang="en-US" sz="1300" dirty="0">
+                <a:solidFill>
+                  <a:srgbClr val="E6EDF6"/>
+                </a:solidFill>
+                <a:latin typeface="Calibri" pitchFamily="34" charset="0"/>
+                <a:ea typeface="Calibri" pitchFamily="34" charset="-122"/>
+                <a:cs typeface="Calibri" pitchFamily="34" charset="-120"/>
+              </a:rPr>
+              <a:t>Swap heuristics for fine-tuned models: transformer scam classifier, CNN/ViT per security ROI.</a:t>
+            </a:r>
+            <a:endParaRPr lang="en-US" sz="1300" dirty="0"/>
+          </a:p>
+          <a:p>
+            <a:pPr marL="342900" indent="-342900">
+              <a:spcAft>
+                <a:spcPts val="1000"/>
+              </a:spcAft>
+              <a:buSzPct val="100000"/>
+              <a:buChar char="•"/>
+            </a:pPr>
+            <a:r>
+              <a:rPr lang="en-US" sz="1300" dirty="0">
+                <a:solidFill>
+                  <a:srgbClr val="E6EDF6"/>
+                </a:solidFill>
+                <a:latin typeface="Calibri" pitchFamily="34" charset="0"/>
+                <a:ea typeface="Calibri" pitchFamily="34" charset="-122"/>
+                <a:cs typeface="Calibri" pitchFamily="34" charset="-120"/>
+              </a:rPr>
+              <a:t>Speech-AI front-end for live synthetic-voice detection.</a:t>
+            </a:r>
+            <a:endParaRPr lang="en-US" sz="1300" dirty="0"/>
+          </a:p>
+          <a:p>
+            <a:pPr marL="342900" indent="-342900">
+              <a:spcAft>
+                <a:spcPts val="1000"/>
+              </a:spcAft>
+              <a:buSzPct val="100000"/>
+              <a:buChar char="•"/>
+            </a:pPr>
+            <a:r>
+              <a:rPr lang="en-US" sz="1300" dirty="0">
+                <a:solidFill>
+                  <a:srgbClr val="E6EDF6"/>
+                </a:solidFill>
+                <a:latin typeface="Calibri" pitchFamily="34" charset="0"/>
+                <a:ea typeface="Calibri" pitchFamily="34" charset="-122"/>
+                <a:cs typeface="Calibri" pitchFamily="34" charset="-120"/>
+              </a:rPr>
+              <a:t>IndicTrans + LLM for full 12-language NLG.</a:t>
+            </a:r>
+            <a:endParaRPr lang="en-US" sz="1300" dirty="0"/>
+          </a:p>
+          <a:p>
+            <a:pPr marL="342900" indent="-342900">
+              <a:spcAft>
+                <a:spcPts val="1000"/>
+              </a:spcAft>
+              <a:buSzPct val="100000"/>
+              <a:buChar char="•"/>
+            </a:pPr>
+            <a:r>
+              <a:rPr lang="en-US" sz="1300" dirty="0">
+                <a:solidFill>
+                  <a:srgbClr val="E6EDF6"/>
+                </a:solidFill>
+                <a:latin typeface="Calibri" pitchFamily="34" charset="0"/>
+                <a:ea typeface="Calibri" pitchFamily="34" charset="-122"/>
+                <a:cs typeface="Calibri" pitchFamily="34" charset="-120"/>
+              </a:rPr>
+              <a:t>Real connectors: TSP CDR, NPCI/UPI, bank STR, NCRP/1930, I4C.</a:t>
+            </a:r>
+            <a:endParaRPr lang="en-US" sz="1300" dirty="0"/>
+          </a:p>
+          <a:p>
+            <a:pPr marL="342900" indent="-342900">
+              <a:spcAft>
+                <a:spcPts val="1000"/>
+              </a:spcAft>
+              <a:buSzPct val="100000"/>
+              <a:buChar char="•"/>
+            </a:pPr>
+            <a:r>
+              <a:rPr lang="en-US" sz="1300" dirty="0">
+                <a:solidFill>
+                  <a:srgbClr val="E6EDF6"/>
+                </a:solidFill>
+                <a:latin typeface="Calibri" pitchFamily="34" charset="0"/>
+                <a:ea typeface="Calibri" pitchFamily="34" charset="-122"/>
+                <a:cs typeface="Calibri" pitchFamily="34" charset="-120"/>
+              </a:rPr>
+              <a:t>PII tokenisation at ingest; signed append-only audit ledger.</a:t>
+            </a:r>
+            <a:endParaRPr lang="en-US" sz="1300" dirty="0"/>
+          </a:p>
+        </p:txBody>
+      </p:sp>
+      <p:sp>
+        <p:nvSpPr>
+          <p:cNvPr id="9" name="Text 7"/>
+          <p:cNvSpPr/>
+          <p:nvPr/>
+        </p:nvSpPr>
+        <p:spPr>
+          <a:xfrm>
+            <a:off x="457200" y="6473952"/>
+            <a:ext cx="7315200" cy="274320"/>
+          </a:xfrm>
+          <a:prstGeom prst="rect">
+            <a:avLst/>
+          </a:prstGeom>
+          <a:noFill/>
+          <a:ln/>
+        </p:spPr>
+        <p:txBody>
+          <a:bodyPr wrap="square" rtlCol="0" anchor="ctr"/>
+          <a:lstStyle/>
+          <a:p>
+            <a:pPr indent="0" marL="0">
+              <a:buNone/>
+            </a:pPr>
+            <a:r>
+              <a:rPr lang="en-US" sz="900" dirty="0">
+                <a:solidFill>
+                  <a:srgbClr val="8C9BB5"/>
+                </a:solidFill>
+                <a:latin typeface="Calibri" pitchFamily="34" charset="0"/>
+                <a:ea typeface="Calibri" pitchFamily="34" charset="-122"/>
+                <a:cs typeface="Calibri" pitchFamily="34" charset="-120"/>
+              </a:rPr>
+              <a:t>PRAHARI · Digital Public Safety Intelligence</a:t>
+            </a:r>
+            <a:endParaRPr lang="en-US" sz="900" dirty="0"/>
+          </a:p>
+        </p:txBody>
+      </p:sp>
+      <p:sp>
+        <p:nvSpPr>
+          <p:cNvPr id="10" name="Text 8"/>
+          <p:cNvSpPr/>
+          <p:nvPr/>
+        </p:nvSpPr>
+        <p:spPr>
+          <a:xfrm>
+            <a:off x="11274552" y="6473952"/>
+            <a:ext cx="457200" cy="274320"/>
+          </a:xfrm>
+          <a:prstGeom prst="rect">
+            <a:avLst/>
+          </a:prstGeom>
+          <a:noFill/>
+          <a:ln/>
+        </p:spPr>
+        <p:txBody>
+          <a:bodyPr wrap="square" rtlCol="0" anchor="ctr"/>
+          <a:lstStyle/>
+          <a:p>
+            <a:pPr algn="r" indent="0" marL="0">
+              <a:buNone/>
+            </a:pPr>
+            <a:r>
+              <a:rPr lang="en-US" sz="900" dirty="0">
+                <a:solidFill>
+                  <a:srgbClr val="8C9BB5"/>
+                </a:solidFill>
+                <a:latin typeface="Calibri" pitchFamily="34" charset="0"/>
+                <a:ea typeface="Calibri" pitchFamily="34" charset="-122"/>
+                <a:cs typeface="Calibri" pitchFamily="34" charset="-120"/>
+              </a:rPr>
+              <a:t>10</a:t>
+            </a:r>
+            <a:endParaRPr lang="en-US" sz="900" dirty="0"/>
+          </a:p>
+        </p:txBody>
+      </p:sp>
+    </p:spTree>
+  </p:cSld>
+  <p:clrMapOvr>
+    <a:masterClrMapping/>
+  </p:clrMapOvr>
+</p:sld>
+</file>
+
+<file path=ppt/slides/slide11.xml><?xml version="1.0" encoding="utf-8"?>
+<p:sld xmlns:a="http://schemas.openxmlformats.org/drawingml/2006/main" xmlns:r="http://schemas.openxmlformats.org/officeDocument/2006/relationships" xmlns:p="http://schemas.openxmlformats.org/presentationml/2006/main">
+  <p:cSld name="Slide 11">
+    <p:bg>
+      <p:bgPr>
+        <a:solidFill>
+          <a:srgbClr val="0A0E17"/>
+        </a:solidFill>
+      </p:bgPr>
+    </p:bg>
+    <p:spTree>
+      <p:nvGrpSpPr>
+        <p:cNvPr id="1" name=""/>
+        <p:cNvGrpSpPr/>
+        <p:nvPr/>
+      </p:nvGrpSpPr>
+      <p:grpSpPr>
+        <a:xfrm>
+          <a:off x="0" y="0"/>
+          <a:ext cx="0" cy="0"/>
+          <a:chOff x="0" y="0"/>
+          <a:chExt cx="0" cy="0"/>
+        </a:xfrm>
+      </p:grpSpPr>
+      <p:sp>
+        <p:nvSpPr>
           <p:cNvPr id="2" name="Shape 0"/>
           <p:cNvSpPr/>
           <p:nvPr/>
@@ -4493,7 +5110,7 @@
       </p:sp>
       <p:pic>
         <p:nvPicPr>
-          <p:cNvPr id="3" name="Image 0" descr="/Users/swapnalatha/Desktop/AI for Digital Public Safety- Defeating Counterfeiting, Fraud &amp; Digital Arrest Scams/prahari/docs/architecture.png">    </p:cNvPr>
+          <p:cNvPr id="3" name="Image 0" descr="/Users/swapnalatha/Desktop/AI for Digital Public Safety- Defeating Counterfeiting, Fraud &amp; Digital Arrest Scams/docs/architecture.png">    </p:cNvPr>
           <p:cNvPicPr>
             <a:picLocks noChangeAspect="1"/>
           </p:cNvPicPr>
@@ -7772,7 +8389,7 @@
                 <a:ea typeface="Cambria" pitchFamily="34" charset="-122"/>
                 <a:cs typeface="Cambria" pitchFamily="34" charset="-120"/>
               </a:rPr>
-              <a:t>Impact &amp; alignment to judging criteria</a:t>
+              <a:t>Measured performance — not just a demo</a:t>
             </a:r>
             <a:endParaRPr lang="en-US" sz="2800" dirty="0"/>
           </a:p>
@@ -7780,18 +8397,57 @@
       </p:sp>
       <p:sp>
         <p:nvSpPr>
-          <p:cNvPr id="3" name="Shape 1"/>
-          <p:cNvSpPr/>
-          <p:nvPr/>
-        </p:nvSpPr>
-        <p:spPr>
-          <a:xfrm>
-            <a:off x="548640" y="1463040"/>
-            <a:ext cx="11064240" cy="731520"/>
+          <p:cNvPr id="3" name="Text 1"/>
+          <p:cNvSpPr/>
+          <p:nvPr/>
+        </p:nvSpPr>
+        <p:spPr>
+          <a:xfrm>
+            <a:off x="548640" y="1051560"/>
+            <a:ext cx="10972800" cy="365760"/>
+          </a:xfrm>
+          <a:prstGeom prst="rect">
+            <a:avLst/>
+          </a:prstGeom>
+          <a:noFill/>
+          <a:ln/>
+        </p:spPr>
+        <p:txBody>
+          <a:bodyPr wrap="square" rtlCol="0" anchor="ctr"/>
+          <a:lstStyle/>
+          <a:p>
+            <a:pPr indent="0" marL="0">
+              <a:buNone/>
+            </a:pPr>
+            <a:r>
+              <a:rPr lang="en-US" sz="1300" i="1" dirty="0">
+                <a:solidFill>
+                  <a:srgbClr val="3EA6FF"/>
+                </a:solidFill>
+                <a:latin typeface="Calibri" pitchFamily="34" charset="0"/>
+                <a:ea typeface="Calibri" pitchFamily="34" charset="-122"/>
+                <a:cs typeface="Calibri" pitchFamily="34" charset="-120"/>
+              </a:rPr>
+              <a:t>Scam classifier benchmarked live against realistic scam + benign messages (incl. hard negatives). Computed on every run — nothing pre-baked.</a:t>
+            </a:r>
+            <a:endParaRPr lang="en-US" sz="1300" dirty="0"/>
+          </a:p>
+        </p:txBody>
+      </p:sp>
+      <p:sp>
+        <p:nvSpPr>
+          <p:cNvPr id="4" name="Shape 2"/>
+          <p:cNvSpPr/>
+          <p:nvPr/>
+        </p:nvSpPr>
+        <p:spPr>
+          <a:xfrm>
+            <a:off x="548640" y="1600200"/>
+            <a:ext cx="2057400" cy="1371600"/>
           </a:xfrm>
           <a:prstGeom prst="roundRect">
             <a:avLst>
-              <a:gd name="adj" fmla="val 10000"/>
+              <a:gd name="adj" fmla="val 5333"/>
             </a:avLst>
           </a:prstGeom>
           <a:solidFill>
@@ -7814,96 +8470,773 @@
       </p:sp>
       <p:sp>
         <p:nvSpPr>
-          <p:cNvPr id="4" name="Text 2"/>
-          <p:cNvSpPr/>
-          <p:nvPr/>
-        </p:nvSpPr>
-        <p:spPr>
-          <a:xfrm>
-            <a:off x="777240" y="1463040"/>
-            <a:ext cx="3291840" cy="731520"/>
-          </a:xfrm>
-          <a:prstGeom prst="rect">
-            <a:avLst/>
-          </a:prstGeom>
-          <a:noFill/>
-          <a:ln/>
-        </p:spPr>
-        <p:txBody>
-          <a:bodyPr wrap="square" rtlCol="0" anchor="ctr"/>
-          <a:lstStyle/>
-          <a:p>
-            <a:pPr indent="0" marL="0">
-              <a:buNone/>
-            </a:pPr>
-            <a:r>
-              <a:rPr lang="en-US" sz="1450" b="1" dirty="0">
-                <a:solidFill>
-                  <a:srgbClr val="3EA6FF"/>
+          <p:cNvPr id="5" name="Text 3"/>
+          <p:cNvSpPr/>
+          <p:nvPr/>
+        </p:nvSpPr>
+        <p:spPr>
+          <a:xfrm>
+            <a:off x="548640" y="1783080"/>
+            <a:ext cx="2057400" cy="640080"/>
+          </a:xfrm>
+          <a:prstGeom prst="rect">
+            <a:avLst/>
+          </a:prstGeom>
+          <a:noFill/>
+          <a:ln/>
+        </p:spPr>
+        <p:txBody>
+          <a:bodyPr wrap="square" rtlCol="0" anchor="ctr"/>
+          <a:lstStyle/>
+          <a:p>
+            <a:pPr algn="ctr" indent="0" marL="0">
+              <a:buNone/>
+            </a:pPr>
+            <a:r>
+              <a:rPr lang="en-US" sz="3000" b="1" dirty="0">
+                <a:solidFill>
+                  <a:srgbClr val="2ECC71"/>
                 </a:solidFill>
                 <a:latin typeface="Cambria" pitchFamily="34" charset="0"/>
                 <a:ea typeface="Cambria" pitchFamily="34" charset="-122"/>
                 <a:cs typeface="Cambria" pitchFamily="34" charset="-120"/>
               </a:rPr>
-              <a:t>Innovation (25%)</a:t>
-            </a:r>
-            <a:endParaRPr lang="en-US" sz="1450" dirty="0"/>
-          </a:p>
-        </p:txBody>
-      </p:sp>
-      <p:sp>
-        <p:nvSpPr>
-          <p:cNvPr id="5" name="Text 3"/>
-          <p:cNvSpPr/>
-          <p:nvPr/>
-        </p:nvSpPr>
-        <p:spPr>
-          <a:xfrm>
-            <a:off x="4114800" y="1463040"/>
-            <a:ext cx="7315200" cy="731520"/>
-          </a:xfrm>
-          <a:prstGeom prst="rect">
-            <a:avLst/>
-          </a:prstGeom>
-          <a:noFill/>
-          <a:ln/>
-        </p:spPr>
-        <p:txBody>
-          <a:bodyPr wrap="square" rtlCol="0" anchor="ctr"/>
-          <a:lstStyle/>
-          <a:p>
-            <a:pPr indent="0" marL="0">
-              <a:buNone/>
-            </a:pPr>
-            <a:r>
-              <a:rPr lang="en-US" sz="1300" dirty="0">
-                <a:solidFill>
-                  <a:srgbClr val="E6EDF6"/>
-                </a:solidFill>
-                <a:latin typeface="Calibri" pitchFamily="34" charset="0"/>
-                <a:ea typeface="Calibri" pitchFamily="34" charset="-122"/>
-                <a:cs typeface="Calibri" pitchFamily="34" charset="-120"/>
-              </a:rPr>
-              <a:t>Kill-chain scam modelling + lead-time KPI + cross-domain entity fusion.</a:t>
-            </a:r>
-            <a:endParaRPr lang="en-US" sz="1300" dirty="0"/>
-          </a:p>
-        </p:txBody>
-      </p:sp>
-      <p:sp>
-        <p:nvSpPr>
-          <p:cNvPr id="6" name="Shape 4"/>
-          <p:cNvSpPr/>
-          <p:nvPr/>
-        </p:nvSpPr>
-        <p:spPr>
-          <a:xfrm>
-            <a:off x="548640" y="2304288"/>
-            <a:ext cx="11064240" cy="731520"/>
+              <a:t>100%</a:t>
+            </a:r>
+            <a:endParaRPr lang="en-US" sz="3000" dirty="0"/>
+          </a:p>
+        </p:txBody>
+      </p:sp>
+      <p:sp>
+        <p:nvSpPr>
+          <p:cNvPr id="6" name="Text 4"/>
+          <p:cNvSpPr/>
+          <p:nvPr/>
+        </p:nvSpPr>
+        <p:spPr>
+          <a:xfrm>
+            <a:off x="548640" y="2423160"/>
+            <a:ext cx="2057400" cy="365760"/>
+          </a:xfrm>
+          <a:prstGeom prst="rect">
+            <a:avLst/>
+          </a:prstGeom>
+          <a:noFill/>
+          <a:ln/>
+        </p:spPr>
+        <p:txBody>
+          <a:bodyPr wrap="square" rtlCol="0" anchor="ctr"/>
+          <a:lstStyle/>
+          <a:p>
+            <a:pPr algn="ctr" indent="0" marL="0">
+              <a:buNone/>
+            </a:pPr>
+            <a:r>
+              <a:rPr lang="en-US" sz="1150" dirty="0">
+                <a:solidFill>
+                  <a:srgbClr val="8C9BB5"/>
+                </a:solidFill>
+                <a:latin typeface="Calibri" pitchFamily="34" charset="0"/>
+                <a:ea typeface="Calibri" pitchFamily="34" charset="-122"/>
+                <a:cs typeface="Calibri" pitchFamily="34" charset="-120"/>
+              </a:rPr>
+              <a:t>Precision</a:t>
+            </a:r>
+            <a:endParaRPr lang="en-US" sz="1150" dirty="0"/>
+          </a:p>
+        </p:txBody>
+      </p:sp>
+      <p:sp>
+        <p:nvSpPr>
+          <p:cNvPr id="7" name="Shape 5"/>
+          <p:cNvSpPr/>
+          <p:nvPr/>
+        </p:nvSpPr>
+        <p:spPr>
+          <a:xfrm>
+            <a:off x="2788920" y="1600200"/>
+            <a:ext cx="2057400" cy="1371600"/>
           </a:xfrm>
           <a:prstGeom prst="roundRect">
             <a:avLst>
-              <a:gd name="adj" fmla="val 10000"/>
+              <a:gd name="adj" fmla="val 5333"/>
+            </a:avLst>
+          </a:prstGeom>
+          <a:solidFill>
+            <a:srgbClr val="121826"/>
+          </a:solidFill>
+          <a:ln w="12700">
+            <a:solidFill>
+              <a:srgbClr val="1F2A3D"/>
+            </a:solidFill>
+            <a:prstDash val="solid"/>
+          </a:ln>
+          <a:effectLst>
+            <a:outerShdw sx="100000" sy="100000" kx="0" ky="0" algn="bl" rotWithShape="0" blurRad="88900" dist="38100" dir="5400000">
+              <a:srgbClr val="000000">
+                <a:alpha val="35000"/>
+              </a:srgbClr>
+            </a:outerShdw>
+          </a:effectLst>
+        </p:spPr>
+      </p:sp>
+      <p:sp>
+        <p:nvSpPr>
+          <p:cNvPr id="8" name="Text 6"/>
+          <p:cNvSpPr/>
+          <p:nvPr/>
+        </p:nvSpPr>
+        <p:spPr>
+          <a:xfrm>
+            <a:off x="2788920" y="1783080"/>
+            <a:ext cx="2057400" cy="640080"/>
+          </a:xfrm>
+          <a:prstGeom prst="rect">
+            <a:avLst/>
+          </a:prstGeom>
+          <a:noFill/>
+          <a:ln/>
+        </p:spPr>
+        <p:txBody>
+          <a:bodyPr wrap="square" rtlCol="0" anchor="ctr"/>
+          <a:lstStyle/>
+          <a:p>
+            <a:pPr algn="ctr" indent="0" marL="0">
+              <a:buNone/>
+            </a:pPr>
+            <a:r>
+              <a:rPr lang="en-US" sz="3000" b="1" dirty="0">
+                <a:solidFill>
+                  <a:srgbClr val="2ECC71"/>
+                </a:solidFill>
+                <a:latin typeface="Cambria" pitchFamily="34" charset="0"/>
+                <a:ea typeface="Cambria" pitchFamily="34" charset="-122"/>
+                <a:cs typeface="Cambria" pitchFamily="34" charset="-120"/>
+              </a:rPr>
+              <a:t>92.3%</a:t>
+            </a:r>
+            <a:endParaRPr lang="en-US" sz="3000" dirty="0"/>
+          </a:p>
+        </p:txBody>
+      </p:sp>
+      <p:sp>
+        <p:nvSpPr>
+          <p:cNvPr id="9" name="Text 7"/>
+          <p:cNvSpPr/>
+          <p:nvPr/>
+        </p:nvSpPr>
+        <p:spPr>
+          <a:xfrm>
+            <a:off x="2788920" y="2423160"/>
+            <a:ext cx="2057400" cy="365760"/>
+          </a:xfrm>
+          <a:prstGeom prst="rect">
+            <a:avLst/>
+          </a:prstGeom>
+          <a:noFill/>
+          <a:ln/>
+        </p:spPr>
+        <p:txBody>
+          <a:bodyPr wrap="square" rtlCol="0" anchor="ctr"/>
+          <a:lstStyle/>
+          <a:p>
+            <a:pPr algn="ctr" indent="0" marL="0">
+              <a:buNone/>
+            </a:pPr>
+            <a:r>
+              <a:rPr lang="en-US" sz="1150" dirty="0">
+                <a:solidFill>
+                  <a:srgbClr val="8C9BB5"/>
+                </a:solidFill>
+                <a:latin typeface="Calibri" pitchFamily="34" charset="0"/>
+                <a:ea typeface="Calibri" pitchFamily="34" charset="-122"/>
+                <a:cs typeface="Calibri" pitchFamily="34" charset="-120"/>
+              </a:rPr>
+              <a:t>Recall</a:t>
+            </a:r>
+            <a:endParaRPr lang="en-US" sz="1150" dirty="0"/>
+          </a:p>
+        </p:txBody>
+      </p:sp>
+      <p:sp>
+        <p:nvSpPr>
+          <p:cNvPr id="10" name="Shape 8"/>
+          <p:cNvSpPr/>
+          <p:nvPr/>
+        </p:nvSpPr>
+        <p:spPr>
+          <a:xfrm>
+            <a:off x="5029200" y="1600200"/>
+            <a:ext cx="2057400" cy="1371600"/>
+          </a:xfrm>
+          <a:prstGeom prst="roundRect">
+            <a:avLst>
+              <a:gd name="adj" fmla="val 5333"/>
+            </a:avLst>
+          </a:prstGeom>
+          <a:solidFill>
+            <a:srgbClr val="121826"/>
+          </a:solidFill>
+          <a:ln w="12700">
+            <a:solidFill>
+              <a:srgbClr val="1F2A3D"/>
+            </a:solidFill>
+            <a:prstDash val="solid"/>
+          </a:ln>
+          <a:effectLst>
+            <a:outerShdw sx="100000" sy="100000" kx="0" ky="0" algn="bl" rotWithShape="0" blurRad="88900" dist="38100" dir="5400000">
+              <a:srgbClr val="000000">
+                <a:alpha val="35000"/>
+              </a:srgbClr>
+            </a:outerShdw>
+          </a:effectLst>
+        </p:spPr>
+      </p:sp>
+      <p:sp>
+        <p:nvSpPr>
+          <p:cNvPr id="11" name="Text 9"/>
+          <p:cNvSpPr/>
+          <p:nvPr/>
+        </p:nvSpPr>
+        <p:spPr>
+          <a:xfrm>
+            <a:off x="5029200" y="1783080"/>
+            <a:ext cx="2057400" cy="640080"/>
+          </a:xfrm>
+          <a:prstGeom prst="rect">
+            <a:avLst/>
+          </a:prstGeom>
+          <a:noFill/>
+          <a:ln/>
+        </p:spPr>
+        <p:txBody>
+          <a:bodyPr wrap="square" rtlCol="0" anchor="ctr"/>
+          <a:lstStyle/>
+          <a:p>
+            <a:pPr algn="ctr" indent="0" marL="0">
+              <a:buNone/>
+            </a:pPr>
+            <a:r>
+              <a:rPr lang="en-US" sz="3000" b="1" dirty="0">
+                <a:solidFill>
+                  <a:srgbClr val="2ECC71"/>
+                </a:solidFill>
+                <a:latin typeface="Cambria" pitchFamily="34" charset="0"/>
+                <a:ea typeface="Cambria" pitchFamily="34" charset="-122"/>
+                <a:cs typeface="Cambria" pitchFamily="34" charset="-120"/>
+              </a:rPr>
+              <a:t>96.0%</a:t>
+            </a:r>
+            <a:endParaRPr lang="en-US" sz="3000" dirty="0"/>
+          </a:p>
+        </p:txBody>
+      </p:sp>
+      <p:sp>
+        <p:nvSpPr>
+          <p:cNvPr id="12" name="Text 10"/>
+          <p:cNvSpPr/>
+          <p:nvPr/>
+        </p:nvSpPr>
+        <p:spPr>
+          <a:xfrm>
+            <a:off x="5029200" y="2423160"/>
+            <a:ext cx="2057400" cy="365760"/>
+          </a:xfrm>
+          <a:prstGeom prst="rect">
+            <a:avLst/>
+          </a:prstGeom>
+          <a:noFill/>
+          <a:ln/>
+        </p:spPr>
+        <p:txBody>
+          <a:bodyPr wrap="square" rtlCol="0" anchor="ctr"/>
+          <a:lstStyle/>
+          <a:p>
+            <a:pPr algn="ctr" indent="0" marL="0">
+              <a:buNone/>
+            </a:pPr>
+            <a:r>
+              <a:rPr lang="en-US" sz="1150" dirty="0">
+                <a:solidFill>
+                  <a:srgbClr val="8C9BB5"/>
+                </a:solidFill>
+                <a:latin typeface="Calibri" pitchFamily="34" charset="0"/>
+                <a:ea typeface="Calibri" pitchFamily="34" charset="-122"/>
+                <a:cs typeface="Calibri" pitchFamily="34" charset="-120"/>
+              </a:rPr>
+              <a:t>F1 score</a:t>
+            </a:r>
+            <a:endParaRPr lang="en-US" sz="1150" dirty="0"/>
+          </a:p>
+        </p:txBody>
+      </p:sp>
+      <p:sp>
+        <p:nvSpPr>
+          <p:cNvPr id="13" name="Shape 11"/>
+          <p:cNvSpPr/>
+          <p:nvPr/>
+        </p:nvSpPr>
+        <p:spPr>
+          <a:xfrm>
+            <a:off x="7269480" y="1600200"/>
+            <a:ext cx="2057400" cy="1371600"/>
+          </a:xfrm>
+          <a:prstGeom prst="roundRect">
+            <a:avLst>
+              <a:gd name="adj" fmla="val 5333"/>
+            </a:avLst>
+          </a:prstGeom>
+          <a:solidFill>
+            <a:srgbClr val="121826"/>
+          </a:solidFill>
+          <a:ln w="12700">
+            <a:solidFill>
+              <a:srgbClr val="1F2A3D"/>
+            </a:solidFill>
+            <a:prstDash val="solid"/>
+          </a:ln>
+          <a:effectLst>
+            <a:outerShdw sx="100000" sy="100000" kx="0" ky="0" algn="bl" rotWithShape="0" blurRad="88900" dist="38100" dir="5400000">
+              <a:srgbClr val="000000">
+                <a:alpha val="35000"/>
+              </a:srgbClr>
+            </a:outerShdw>
+          </a:effectLst>
+        </p:spPr>
+      </p:sp>
+      <p:sp>
+        <p:nvSpPr>
+          <p:cNvPr id="14" name="Text 12"/>
+          <p:cNvSpPr/>
+          <p:nvPr/>
+        </p:nvSpPr>
+        <p:spPr>
+          <a:xfrm>
+            <a:off x="7269480" y="1783080"/>
+            <a:ext cx="2057400" cy="640080"/>
+          </a:xfrm>
+          <a:prstGeom prst="rect">
+            <a:avLst/>
+          </a:prstGeom>
+          <a:noFill/>
+          <a:ln/>
+        </p:spPr>
+        <p:txBody>
+          <a:bodyPr wrap="square" rtlCol="0" anchor="ctr"/>
+          <a:lstStyle/>
+          <a:p>
+            <a:pPr algn="ctr" indent="0" marL="0">
+              <a:buNone/>
+            </a:pPr>
+            <a:r>
+              <a:rPr lang="en-US" sz="3000" b="1" dirty="0">
+                <a:solidFill>
+                  <a:srgbClr val="2ECC71"/>
+                </a:solidFill>
+                <a:latin typeface="Cambria" pitchFamily="34" charset="0"/>
+                <a:ea typeface="Cambria" pitchFamily="34" charset="-122"/>
+                <a:cs typeface="Cambria" pitchFamily="34" charset="-120"/>
+              </a:rPr>
+              <a:t>95.7%</a:t>
+            </a:r>
+            <a:endParaRPr lang="en-US" sz="3000" dirty="0"/>
+          </a:p>
+        </p:txBody>
+      </p:sp>
+      <p:sp>
+        <p:nvSpPr>
+          <p:cNvPr id="15" name="Text 13"/>
+          <p:cNvSpPr/>
+          <p:nvPr/>
+        </p:nvSpPr>
+        <p:spPr>
+          <a:xfrm>
+            <a:off x="7269480" y="2423160"/>
+            <a:ext cx="2057400" cy="365760"/>
+          </a:xfrm>
+          <a:prstGeom prst="rect">
+            <a:avLst/>
+          </a:prstGeom>
+          <a:noFill/>
+          <a:ln/>
+        </p:spPr>
+        <p:txBody>
+          <a:bodyPr wrap="square" rtlCol="0" anchor="ctr"/>
+          <a:lstStyle/>
+          <a:p>
+            <a:pPr algn="ctr" indent="0" marL="0">
+              <a:buNone/>
+            </a:pPr>
+            <a:r>
+              <a:rPr lang="en-US" sz="1150" dirty="0">
+                <a:solidFill>
+                  <a:srgbClr val="8C9BB5"/>
+                </a:solidFill>
+                <a:latin typeface="Calibri" pitchFamily="34" charset="0"/>
+                <a:ea typeface="Calibri" pitchFamily="34" charset="-122"/>
+                <a:cs typeface="Calibri" pitchFamily="34" charset="-120"/>
+              </a:rPr>
+              <a:t>Accuracy</a:t>
+            </a:r>
+            <a:endParaRPr lang="en-US" sz="1150" dirty="0"/>
+          </a:p>
+        </p:txBody>
+      </p:sp>
+      <p:sp>
+        <p:nvSpPr>
+          <p:cNvPr id="16" name="Shape 14"/>
+          <p:cNvSpPr/>
+          <p:nvPr/>
+        </p:nvSpPr>
+        <p:spPr>
+          <a:xfrm>
+            <a:off x="9509760" y="1600200"/>
+            <a:ext cx="2057400" cy="1371600"/>
+          </a:xfrm>
+          <a:prstGeom prst="roundRect">
+            <a:avLst>
+              <a:gd name="adj" fmla="val 5333"/>
+            </a:avLst>
+          </a:prstGeom>
+          <a:solidFill>
+            <a:srgbClr val="121826"/>
+          </a:solidFill>
+          <a:ln w="12700">
+            <a:solidFill>
+              <a:srgbClr val="1F2A3D"/>
+            </a:solidFill>
+            <a:prstDash val="solid"/>
+          </a:ln>
+          <a:effectLst>
+            <a:outerShdw sx="100000" sy="100000" kx="0" ky="0" algn="bl" rotWithShape="0" blurRad="88900" dist="38100" dir="5400000">
+              <a:srgbClr val="000000">
+                <a:alpha val="35000"/>
+              </a:srgbClr>
+            </a:outerShdw>
+          </a:effectLst>
+        </p:spPr>
+      </p:sp>
+      <p:sp>
+        <p:nvSpPr>
+          <p:cNvPr id="17" name="Text 15"/>
+          <p:cNvSpPr/>
+          <p:nvPr/>
+        </p:nvSpPr>
+        <p:spPr>
+          <a:xfrm>
+            <a:off x="9509760" y="1783080"/>
+            <a:ext cx="2057400" cy="640080"/>
+          </a:xfrm>
+          <a:prstGeom prst="rect">
+            <a:avLst/>
+          </a:prstGeom>
+          <a:noFill/>
+          <a:ln/>
+        </p:spPr>
+        <p:txBody>
+          <a:bodyPr wrap="square" rtlCol="0" anchor="ctr"/>
+          <a:lstStyle/>
+          <a:p>
+            <a:pPr algn="ctr" indent="0" marL="0">
+              <a:buNone/>
+            </a:pPr>
+            <a:r>
+              <a:rPr lang="en-US" sz="3000" b="1" dirty="0">
+                <a:solidFill>
+                  <a:srgbClr val="2ECC71"/>
+                </a:solidFill>
+                <a:latin typeface="Cambria" pitchFamily="34" charset="0"/>
+                <a:ea typeface="Cambria" pitchFamily="34" charset="-122"/>
+                <a:cs typeface="Cambria" pitchFamily="34" charset="-120"/>
+              </a:rPr>
+              <a:t>0.0%</a:t>
+            </a:r>
+            <a:endParaRPr lang="en-US" sz="3000" dirty="0"/>
+          </a:p>
+        </p:txBody>
+      </p:sp>
+      <p:sp>
+        <p:nvSpPr>
+          <p:cNvPr id="18" name="Text 16"/>
+          <p:cNvSpPr/>
+          <p:nvPr/>
+        </p:nvSpPr>
+        <p:spPr>
+          <a:xfrm>
+            <a:off x="9509760" y="2423160"/>
+            <a:ext cx="2057400" cy="365760"/>
+          </a:xfrm>
+          <a:prstGeom prst="rect">
+            <a:avLst/>
+          </a:prstGeom>
+          <a:noFill/>
+          <a:ln/>
+        </p:spPr>
+        <p:txBody>
+          <a:bodyPr wrap="square" rtlCol="0" anchor="ctr"/>
+          <a:lstStyle/>
+          <a:p>
+            <a:pPr algn="ctr" indent="0" marL="0">
+              <a:buNone/>
+            </a:pPr>
+            <a:r>
+              <a:rPr lang="en-US" sz="1150" dirty="0">
+                <a:solidFill>
+                  <a:srgbClr val="8C9BB5"/>
+                </a:solidFill>
+                <a:latin typeface="Calibri" pitchFamily="34" charset="0"/>
+                <a:ea typeface="Calibri" pitchFamily="34" charset="-122"/>
+                <a:cs typeface="Calibri" pitchFamily="34" charset="-120"/>
+              </a:rPr>
+              <a:t>False-positive rate</a:t>
+            </a:r>
+            <a:endParaRPr lang="en-US" sz="1150" dirty="0"/>
+          </a:p>
+        </p:txBody>
+      </p:sp>
+      <p:sp>
+        <p:nvSpPr>
+          <p:cNvPr id="19" name="Shape 17"/>
+          <p:cNvSpPr/>
+          <p:nvPr/>
+        </p:nvSpPr>
+        <p:spPr>
+          <a:xfrm>
+            <a:off x="548640" y="3246120"/>
+            <a:ext cx="5486400" cy="2514600"/>
+          </a:xfrm>
+          <a:prstGeom prst="roundRect">
+            <a:avLst>
+              <a:gd name="adj" fmla="val 2909"/>
+            </a:avLst>
+          </a:prstGeom>
+          <a:solidFill>
+            <a:srgbClr val="121826"/>
+          </a:solidFill>
+          <a:ln w="12700">
+            <a:solidFill>
+              <a:srgbClr val="1F2A3D"/>
+            </a:solidFill>
+            <a:prstDash val="solid"/>
+          </a:ln>
+          <a:effectLst>
+            <a:outerShdw sx="100000" sy="100000" kx="0" ky="0" algn="bl" rotWithShape="0" blurRad="88900" dist="38100" dir="5400000">
+              <a:srgbClr val="000000">
+                <a:alpha val="35000"/>
+              </a:srgbClr>
+            </a:outerShdw>
+          </a:effectLst>
+        </p:spPr>
+      </p:sp>
+      <p:sp>
+        <p:nvSpPr>
+          <p:cNvPr id="20" name="Text 18"/>
+          <p:cNvSpPr/>
+          <p:nvPr/>
+        </p:nvSpPr>
+        <p:spPr>
+          <a:xfrm>
+            <a:off x="777240" y="3401568"/>
+            <a:ext cx="5029200" cy="365760"/>
+          </a:xfrm>
+          <a:prstGeom prst="rect">
+            <a:avLst/>
+          </a:prstGeom>
+          <a:noFill/>
+          <a:ln/>
+        </p:spPr>
+        <p:txBody>
+          <a:bodyPr wrap="square" rtlCol="0" anchor="ctr"/>
+          <a:lstStyle/>
+          <a:p>
+            <a:pPr indent="0" marL="0">
+              <a:buNone/>
+            </a:pPr>
+            <a:r>
+              <a:rPr lang="en-US" sz="1400" b="1" dirty="0">
+                <a:solidFill>
+                  <a:srgbClr val="3EA6FF"/>
+                </a:solidFill>
+                <a:latin typeface="Cambria" pitchFamily="34" charset="0"/>
+                <a:ea typeface="Cambria" pitchFamily="34" charset="-122"/>
+                <a:cs typeface="Cambria" pitchFamily="34" charset="-120"/>
+              </a:rPr>
+              <a:t>Confusion matrix (46 messages)</a:t>
+            </a:r>
+            <a:endParaRPr lang="en-US" sz="1400" dirty="0"/>
+          </a:p>
+        </p:txBody>
+      </p:sp>
+      <p:sp>
+        <p:nvSpPr>
+          <p:cNvPr id="21" name="Text 19"/>
+          <p:cNvSpPr/>
+          <p:nvPr/>
+        </p:nvSpPr>
+        <p:spPr>
+          <a:xfrm>
+            <a:off x="777240" y="3886200"/>
+            <a:ext cx="1005840" cy="777240"/>
+          </a:xfrm>
+          <a:prstGeom prst="rect">
+            <a:avLst/>
+          </a:prstGeom>
+          <a:noFill/>
+          <a:ln/>
+        </p:spPr>
+        <p:txBody>
+          <a:bodyPr wrap="square" rtlCol="0" anchor="ctr"/>
+          <a:lstStyle/>
+          <a:p>
+            <a:pPr indent="0" marL="0">
+              <a:buNone/>
+            </a:pPr>
+            <a:r>
+              <a:rPr lang="en-US" sz="900" dirty="0">
+                <a:solidFill>
+                  <a:srgbClr val="8C9BB5"/>
+                </a:solidFill>
+                <a:latin typeface="Calibri" pitchFamily="34" charset="0"/>
+                <a:ea typeface="Calibri" pitchFamily="34" charset="-122"/>
+                <a:cs typeface="Calibri" pitchFamily="34" charset="-120"/>
+              </a:rPr>
+              <a:t>Actual SCAM</a:t>
+            </a:r>
+            <a:endParaRPr lang="en-US" sz="900" dirty="0"/>
+          </a:p>
+        </p:txBody>
+      </p:sp>
+      <p:sp>
+        <p:nvSpPr>
+          <p:cNvPr id="22" name="Text 20"/>
+          <p:cNvSpPr/>
+          <p:nvPr/>
+        </p:nvSpPr>
+        <p:spPr>
+          <a:xfrm>
+            <a:off x="777240" y="4846320"/>
+            <a:ext cx="1005840" cy="777240"/>
+          </a:xfrm>
+          <a:prstGeom prst="rect">
+            <a:avLst/>
+          </a:prstGeom>
+          <a:noFill/>
+          <a:ln/>
+        </p:spPr>
+        <p:txBody>
+          <a:bodyPr wrap="square" rtlCol="0" anchor="ctr"/>
+          <a:lstStyle/>
+          <a:p>
+            <a:pPr indent="0" marL="0">
+              <a:buNone/>
+            </a:pPr>
+            <a:r>
+              <a:rPr lang="en-US" sz="900" dirty="0">
+                <a:solidFill>
+                  <a:srgbClr val="8C9BB5"/>
+                </a:solidFill>
+                <a:latin typeface="Calibri" pitchFamily="34" charset="0"/>
+                <a:ea typeface="Calibri" pitchFamily="34" charset="-122"/>
+                <a:cs typeface="Calibri" pitchFamily="34" charset="-120"/>
+              </a:rPr>
+              <a:t>Actual BENIGN</a:t>
+            </a:r>
+            <a:endParaRPr lang="en-US" sz="900" dirty="0"/>
+          </a:p>
+        </p:txBody>
+      </p:sp>
+      <p:sp>
+        <p:nvSpPr>
+          <p:cNvPr id="23" name="Text 21"/>
+          <p:cNvSpPr/>
+          <p:nvPr/>
+        </p:nvSpPr>
+        <p:spPr>
+          <a:xfrm>
+            <a:off x="1828800" y="3657600"/>
+            <a:ext cx="1828800" cy="228600"/>
+          </a:xfrm>
+          <a:prstGeom prst="rect">
+            <a:avLst/>
+          </a:prstGeom>
+          <a:noFill/>
+          <a:ln/>
+        </p:spPr>
+        <p:txBody>
+          <a:bodyPr wrap="square" rtlCol="0" anchor="ctr"/>
+          <a:lstStyle/>
+          <a:p>
+            <a:pPr algn="ctr" indent="0" marL="0">
+              <a:buNone/>
+            </a:pPr>
+            <a:r>
+              <a:rPr lang="en-US" sz="900" dirty="0">
+                <a:solidFill>
+                  <a:srgbClr val="8C9BB5"/>
+                </a:solidFill>
+                <a:latin typeface="Calibri" pitchFamily="34" charset="0"/>
+                <a:ea typeface="Calibri" pitchFamily="34" charset="-122"/>
+                <a:cs typeface="Calibri" pitchFamily="34" charset="-120"/>
+              </a:rPr>
+              <a:t>Pred. SCAM</a:t>
+            </a:r>
+            <a:endParaRPr lang="en-US" sz="900" dirty="0"/>
+          </a:p>
+        </p:txBody>
+      </p:sp>
+      <p:sp>
+        <p:nvSpPr>
+          <p:cNvPr id="24" name="Text 22"/>
+          <p:cNvSpPr/>
+          <p:nvPr/>
+        </p:nvSpPr>
+        <p:spPr>
+          <a:xfrm>
+            <a:off x="3794760" y="3657600"/>
+            <a:ext cx="1828800" cy="228600"/>
+          </a:xfrm>
+          <a:prstGeom prst="rect">
+            <a:avLst/>
+          </a:prstGeom>
+          <a:noFill/>
+          <a:ln/>
+        </p:spPr>
+        <p:txBody>
+          <a:bodyPr wrap="square" rtlCol="0" anchor="ctr"/>
+          <a:lstStyle/>
+          <a:p>
+            <a:pPr algn="ctr" indent="0" marL="0">
+              <a:buNone/>
+            </a:pPr>
+            <a:r>
+              <a:rPr lang="en-US" sz="900" dirty="0">
+                <a:solidFill>
+                  <a:srgbClr val="8C9BB5"/>
+                </a:solidFill>
+                <a:latin typeface="Calibri" pitchFamily="34" charset="0"/>
+                <a:ea typeface="Calibri" pitchFamily="34" charset="-122"/>
+                <a:cs typeface="Calibri" pitchFamily="34" charset="-120"/>
+              </a:rPr>
+              <a:t>Pred. BENIGN</a:t>
+            </a:r>
+            <a:endParaRPr lang="en-US" sz="900" dirty="0"/>
+          </a:p>
+        </p:txBody>
+      </p:sp>
+      <p:sp>
+        <p:nvSpPr>
+          <p:cNvPr id="25" name="Shape 23"/>
+          <p:cNvSpPr/>
+          <p:nvPr/>
+        </p:nvSpPr>
+        <p:spPr>
+          <a:xfrm>
+            <a:off x="1828800" y="3886200"/>
+            <a:ext cx="1828800" cy="777240"/>
+          </a:xfrm>
+          <a:prstGeom prst="roundRect">
+            <a:avLst>
+              <a:gd name="adj" fmla="val 9412"/>
             </a:avLst>
           </a:prstGeom>
           <a:solidFill>
@@ -7926,208 +9259,71 @@
       </p:sp>
       <p:sp>
         <p:nvSpPr>
-          <p:cNvPr id="7" name="Text 5"/>
-          <p:cNvSpPr/>
-          <p:nvPr/>
-        </p:nvSpPr>
-        <p:spPr>
-          <a:xfrm>
-            <a:off x="777240" y="2304288"/>
-            <a:ext cx="3291840" cy="731520"/>
-          </a:xfrm>
-          <a:prstGeom prst="rect">
-            <a:avLst/>
-          </a:prstGeom>
-          <a:noFill/>
-          <a:ln/>
-        </p:spPr>
-        <p:txBody>
-          <a:bodyPr wrap="square" rtlCol="0" anchor="ctr"/>
-          <a:lstStyle/>
-          <a:p>
-            <a:pPr indent="0" marL="0">
-              <a:buNone/>
-            </a:pPr>
-            <a:r>
-              <a:rPr lang="en-US" sz="1450" b="1" dirty="0">
-                <a:solidFill>
-                  <a:srgbClr val="3EA6FF"/>
-                </a:solidFill>
-                <a:latin typeface="Cambria" pitchFamily="34" charset="0"/>
-                <a:ea typeface="Cambria" pitchFamily="34" charset="-122"/>
-                <a:cs typeface="Cambria" pitchFamily="34" charset="-120"/>
-              </a:rPr>
-              <a:t>Business Impact (25%)</a:t>
-            </a:r>
-            <a:endParaRPr lang="en-US" sz="1450" dirty="0"/>
-          </a:p>
-        </p:txBody>
-      </p:sp>
-      <p:sp>
-        <p:nvSpPr>
-          <p:cNvPr id="8" name="Text 6"/>
-          <p:cNvSpPr/>
-          <p:nvPr/>
-        </p:nvSpPr>
-        <p:spPr>
-          <a:xfrm>
-            <a:off x="4114800" y="2304288"/>
-            <a:ext cx="7315200" cy="731520"/>
-          </a:xfrm>
-          <a:prstGeom prst="rect">
-            <a:avLst/>
-          </a:prstGeom>
-          <a:noFill/>
-          <a:ln/>
-        </p:spPr>
-        <p:txBody>
-          <a:bodyPr wrap="square" rtlCol="0" anchor="ctr"/>
-          <a:lstStyle/>
-          <a:p>
-            <a:pPr indent="0" marL="0">
-              <a:buNone/>
-            </a:pPr>
-            <a:r>
-              <a:rPr lang="en-US" sz="1300" dirty="0">
-                <a:solidFill>
-                  <a:srgbClr val="E6EDF6"/>
-                </a:solidFill>
-                <a:latin typeface="Calibri" pitchFamily="34" charset="0"/>
-                <a:ea typeface="Calibri" pitchFamily="34" charset="-122"/>
-                <a:cs typeface="Calibri" pitchFamily="34" charset="-120"/>
-              </a:rPr>
-              <a:t>Targets a ₹1,776 Cr/yr loss vector; protects banks, telcos, citizens &amp; courts.</a:t>
-            </a:r>
-            <a:endParaRPr lang="en-US" sz="1300" dirty="0"/>
-          </a:p>
-        </p:txBody>
-      </p:sp>
-      <p:sp>
-        <p:nvSpPr>
-          <p:cNvPr id="9" name="Shape 7"/>
-          <p:cNvSpPr/>
-          <p:nvPr/>
-        </p:nvSpPr>
-        <p:spPr>
-          <a:xfrm>
-            <a:off x="548640" y="3145536"/>
-            <a:ext cx="11064240" cy="731520"/>
+          <p:cNvPr id="26" name="Text 24"/>
+          <p:cNvSpPr/>
+          <p:nvPr/>
+        </p:nvSpPr>
+        <p:spPr>
+          <a:xfrm>
+            <a:off x="1828800" y="3886200"/>
+            <a:ext cx="1828800" cy="777240"/>
+          </a:xfrm>
+          <a:prstGeom prst="rect">
+            <a:avLst/>
+          </a:prstGeom>
+          <a:noFill/>
+          <a:ln/>
+        </p:spPr>
+        <p:txBody>
+          <a:bodyPr wrap="square" rtlCol="0" anchor="ctr"/>
+          <a:lstStyle/>
+          <a:p>
+            <a:pPr algn="ctr" indent="0" marL="0">
+              <a:buNone/>
+            </a:pPr>
+            <a:r>
+              <a:rPr lang="en-US" sz="1800" b="1" dirty="0">
+                <a:solidFill>
+                  <a:srgbClr val="2ECC71"/>
+                </a:solidFill>
+                <a:latin typeface="Calibri" pitchFamily="34" charset="0"/>
+                <a:ea typeface="Calibri" pitchFamily="34" charset="-122"/>
+                <a:cs typeface="Calibri" pitchFamily="34" charset="-120"/>
+              </a:rPr>
+              <a:t>24  </a:t>
+            </a:r>
+            <a:pPr algn="ctr" indent="0" marL="0">
+              <a:buNone/>
+            </a:pPr>
+            <a:r>
+              <a:rPr lang="en-US" sz="1000" dirty="0">
+                <a:solidFill>
+                  <a:srgbClr val="8C9BB5"/>
+                </a:solidFill>
+                <a:latin typeface="Calibri" pitchFamily="34" charset="0"/>
+                <a:ea typeface="Calibri" pitchFamily="34" charset="-122"/>
+                <a:cs typeface="Calibri" pitchFamily="34" charset="-120"/>
+              </a:rPr>
+              <a:t>true positive</a:t>
+            </a:r>
+            <a:endParaRPr lang="en-US" sz="1800" dirty="0"/>
+          </a:p>
+        </p:txBody>
+      </p:sp>
+      <p:sp>
+        <p:nvSpPr>
+          <p:cNvPr id="27" name="Shape 25"/>
+          <p:cNvSpPr/>
+          <p:nvPr/>
+        </p:nvSpPr>
+        <p:spPr>
+          <a:xfrm>
+            <a:off x="3794760" y="3886200"/>
+            <a:ext cx="1828800" cy="777240"/>
           </a:xfrm>
           <a:prstGeom prst="roundRect">
             <a:avLst>
-              <a:gd name="adj" fmla="val 10000"/>
-            </a:avLst>
-          </a:prstGeom>
-          <a:solidFill>
-            <a:srgbClr val="121826"/>
-          </a:solidFill>
-          <a:ln w="12700">
-            <a:solidFill>
-              <a:srgbClr val="1F2A3D"/>
-            </a:solidFill>
-            <a:prstDash val="solid"/>
-          </a:ln>
-          <a:effectLst>
-            <a:outerShdw sx="100000" sy="100000" kx="0" ky="0" algn="bl" rotWithShape="0" blurRad="88900" dist="38100" dir="5400000">
-              <a:srgbClr val="000000">
-                <a:alpha val="35000"/>
-              </a:srgbClr>
-            </a:outerShdw>
-          </a:effectLst>
-        </p:spPr>
-      </p:sp>
-      <p:sp>
-        <p:nvSpPr>
-          <p:cNvPr id="10" name="Text 8"/>
-          <p:cNvSpPr/>
-          <p:nvPr/>
-        </p:nvSpPr>
-        <p:spPr>
-          <a:xfrm>
-            <a:off x="777240" y="3145536"/>
-            <a:ext cx="3291840" cy="731520"/>
-          </a:xfrm>
-          <a:prstGeom prst="rect">
-            <a:avLst/>
-          </a:prstGeom>
-          <a:noFill/>
-          <a:ln/>
-        </p:spPr>
-        <p:txBody>
-          <a:bodyPr wrap="square" rtlCol="0" anchor="ctr"/>
-          <a:lstStyle/>
-          <a:p>
-            <a:pPr indent="0" marL="0">
-              <a:buNone/>
-            </a:pPr>
-            <a:r>
-              <a:rPr lang="en-US" sz="1450" b="1" dirty="0">
-                <a:solidFill>
-                  <a:srgbClr val="3EA6FF"/>
-                </a:solidFill>
-                <a:latin typeface="Cambria" pitchFamily="34" charset="0"/>
-                <a:ea typeface="Cambria" pitchFamily="34" charset="-122"/>
-                <a:cs typeface="Cambria" pitchFamily="34" charset="-120"/>
-              </a:rPr>
-              <a:t>Technical Excellence (20%)</a:t>
-            </a:r>
-            <a:endParaRPr lang="en-US" sz="1450" dirty="0"/>
-          </a:p>
-        </p:txBody>
-      </p:sp>
-      <p:sp>
-        <p:nvSpPr>
-          <p:cNvPr id="11" name="Text 9"/>
-          <p:cNvSpPr/>
-          <p:nvPr/>
-        </p:nvSpPr>
-        <p:spPr>
-          <a:xfrm>
-            <a:off x="4114800" y="3145536"/>
-            <a:ext cx="7315200" cy="731520"/>
-          </a:xfrm>
-          <a:prstGeom prst="rect">
-            <a:avLst/>
-          </a:prstGeom>
-          <a:noFill/>
-          <a:ln/>
-        </p:spPr>
-        <p:txBody>
-          <a:bodyPr wrap="square" rtlCol="0" anchor="ctr"/>
-          <a:lstStyle/>
-          <a:p>
-            <a:pPr indent="0" marL="0">
-              <a:buNone/>
-            </a:pPr>
-            <a:r>
-              <a:rPr lang="en-US" sz="1300" dirty="0">
-                <a:solidFill>
-                  <a:srgbClr val="E6EDF6"/>
-                </a:solidFill>
-                <a:latin typeface="Calibri" pitchFamily="34" charset="0"/>
-                <a:ea typeface="Calibri" pitchFamily="34" charset="-122"/>
-                <a:cs typeface="Calibri" pitchFamily="34" charset="-120"/>
-              </a:rPr>
-              <a:t>Graph AI, image forensics, explainable NLP, geospatial — in one API.</a:t>
-            </a:r>
-            <a:endParaRPr lang="en-US" sz="1300" dirty="0"/>
-          </a:p>
-        </p:txBody>
-      </p:sp>
-      <p:sp>
-        <p:nvSpPr>
-          <p:cNvPr id="12" name="Shape 10"/>
-          <p:cNvSpPr/>
-          <p:nvPr/>
-        </p:nvSpPr>
-        <p:spPr>
-          <a:xfrm>
-            <a:off x="548640" y="3986784"/>
-            <a:ext cx="11064240" cy="731520"/>
-          </a:xfrm>
-          <a:prstGeom prst="roundRect">
-            <a:avLst>
-              <a:gd name="adj" fmla="val 10000"/>
+              <a:gd name="adj" fmla="val 9412"/>
             </a:avLst>
           </a:prstGeom>
           <a:solidFill>
@@ -8150,100 +9346,75 @@
       </p:sp>
       <p:sp>
         <p:nvSpPr>
-          <p:cNvPr id="13" name="Text 11"/>
-          <p:cNvSpPr/>
-          <p:nvPr/>
-        </p:nvSpPr>
-        <p:spPr>
-          <a:xfrm>
-            <a:off x="777240" y="3986784"/>
-            <a:ext cx="3291840" cy="731520"/>
-          </a:xfrm>
-          <a:prstGeom prst="rect">
-            <a:avLst/>
-          </a:prstGeom>
-          <a:noFill/>
-          <a:ln/>
-        </p:spPr>
-        <p:txBody>
-          <a:bodyPr wrap="square" rtlCol="0" anchor="ctr"/>
-          <a:lstStyle/>
-          <a:p>
-            <a:pPr indent="0" marL="0">
-              <a:buNone/>
-            </a:pPr>
-            <a:r>
-              <a:rPr lang="en-US" sz="1450" b="1" dirty="0">
-                <a:solidFill>
-                  <a:srgbClr val="3EA6FF"/>
-                </a:solidFill>
-                <a:latin typeface="Cambria" pitchFamily="34" charset="0"/>
-                <a:ea typeface="Cambria" pitchFamily="34" charset="-122"/>
-                <a:cs typeface="Cambria" pitchFamily="34" charset="-120"/>
-              </a:rPr>
-              <a:t>Scalability (15%)</a:t>
-            </a:r>
-            <a:endParaRPr lang="en-US" sz="1450" dirty="0"/>
-          </a:p>
-        </p:txBody>
-      </p:sp>
-      <p:sp>
-        <p:nvSpPr>
-          <p:cNvPr id="14" name="Text 12"/>
-          <p:cNvSpPr/>
-          <p:nvPr/>
-        </p:nvSpPr>
-        <p:spPr>
-          <a:xfrm>
-            <a:off x="4114800" y="3986784"/>
-            <a:ext cx="7315200" cy="731520"/>
-          </a:xfrm>
-          <a:prstGeom prst="rect">
-            <a:avLst/>
-          </a:prstGeom>
-          <a:noFill/>
-          <a:ln/>
-        </p:spPr>
-        <p:txBody>
-          <a:bodyPr wrap="square" rtlCol="0" anchor="ctr"/>
-          <a:lstStyle/>
-          <a:p>
-            <a:pPr indent="0" marL="0">
-              <a:buNone/>
-            </a:pPr>
-            <a:r>
-              <a:rPr lang="en-US" sz="1300" dirty="0">
-                <a:solidFill>
-                  <a:srgbClr val="E6EDF6"/>
-                </a:solidFill>
-                <a:latin typeface="Calibri" pitchFamily="34" charset="0"/>
-                <a:ea typeface="Calibri" pitchFamily="34" charset="-122"/>
-                <a:cs typeface="Calibri" pitchFamily="34" charset="-120"/>
-              </a:rPr>
-              <a:t>Stateless services; add scam templates without retraining; per-module scale-out.</a:t>
-            </a:r>
-            <a:endParaRPr lang="en-US" sz="1300" dirty="0"/>
-          </a:p>
-        </p:txBody>
-      </p:sp>
-      <p:sp>
-        <p:nvSpPr>
-          <p:cNvPr id="15" name="Shape 13"/>
-          <p:cNvSpPr/>
-          <p:nvPr/>
-        </p:nvSpPr>
-        <p:spPr>
-          <a:xfrm>
-            <a:off x="548640" y="4828032"/>
-            <a:ext cx="11064240" cy="731520"/>
+          <p:cNvPr id="28" name="Text 26"/>
+          <p:cNvSpPr/>
+          <p:nvPr/>
+        </p:nvSpPr>
+        <p:spPr>
+          <a:xfrm>
+            <a:off x="3794760" y="3886200"/>
+            <a:ext cx="1828800" cy="777240"/>
+          </a:xfrm>
+          <a:prstGeom prst="rect">
+            <a:avLst/>
+          </a:prstGeom>
+          <a:noFill/>
+          <a:ln/>
+        </p:spPr>
+        <p:txBody>
+          <a:bodyPr wrap="square" rtlCol="0" anchor="ctr"/>
+          <a:lstStyle/>
+          <a:p>
+            <a:pPr algn="ctr" indent="0" marL="0">
+              <a:buNone/>
+            </a:pPr>
+            <a:r>
+              <a:rPr lang="en-US" sz="1800" b="1" dirty="0">
+                <a:solidFill>
+                  <a:srgbClr val="FF4D57"/>
+                </a:solidFill>
+                <a:latin typeface="Calibri" pitchFamily="34" charset="0"/>
+                <a:ea typeface="Calibri" pitchFamily="34" charset="-122"/>
+                <a:cs typeface="Calibri" pitchFamily="34" charset="-120"/>
+              </a:rPr>
+              <a:t>2  </a:t>
+            </a:r>
+            <a:pPr algn="ctr" indent="0" marL="0">
+              <a:buNone/>
+            </a:pPr>
+            <a:r>
+              <a:rPr lang="en-US" sz="1000" dirty="0">
+                <a:solidFill>
+                  <a:srgbClr val="8C9BB5"/>
+                </a:solidFill>
+                <a:latin typeface="Calibri" pitchFamily="34" charset="0"/>
+                <a:ea typeface="Calibri" pitchFamily="34" charset="-122"/>
+                <a:cs typeface="Calibri" pitchFamily="34" charset="-120"/>
+              </a:rPr>
+              <a:t>false negative</a:t>
+            </a:r>
+            <a:endParaRPr lang="en-US" sz="1800" dirty="0"/>
+          </a:p>
+        </p:txBody>
+      </p:sp>
+      <p:sp>
+        <p:nvSpPr>
+          <p:cNvPr id="29" name="Shape 27"/>
+          <p:cNvSpPr/>
+          <p:nvPr/>
+        </p:nvSpPr>
+        <p:spPr>
+          <a:xfrm>
+            <a:off x="1828800" y="4846320"/>
+            <a:ext cx="1828800" cy="777240"/>
           </a:xfrm>
           <a:prstGeom prst="roundRect">
             <a:avLst>
-              <a:gd name="adj" fmla="val 10000"/>
+              <a:gd name="adj" fmla="val 9412"/>
             </a:avLst>
           </a:prstGeom>
           <a:solidFill>
-            <a:srgbClr val="121826"/>
+            <a:srgbClr val="0F1420"/>
           </a:solidFill>
           <a:ln w="12700">
             <a:solidFill>
@@ -8262,14 +9433,188 @@
       </p:sp>
       <p:sp>
         <p:nvSpPr>
-          <p:cNvPr id="16" name="Text 14"/>
-          <p:cNvSpPr/>
-          <p:nvPr/>
-        </p:nvSpPr>
-        <p:spPr>
-          <a:xfrm>
-            <a:off x="777240" y="4828032"/>
-            <a:ext cx="3291840" cy="731520"/>
+          <p:cNvPr id="30" name="Text 28"/>
+          <p:cNvSpPr/>
+          <p:nvPr/>
+        </p:nvSpPr>
+        <p:spPr>
+          <a:xfrm>
+            <a:off x="1828800" y="4846320"/>
+            <a:ext cx="1828800" cy="777240"/>
+          </a:xfrm>
+          <a:prstGeom prst="rect">
+            <a:avLst/>
+          </a:prstGeom>
+          <a:noFill/>
+          <a:ln/>
+        </p:spPr>
+        <p:txBody>
+          <a:bodyPr wrap="square" rtlCol="0" anchor="ctr"/>
+          <a:lstStyle/>
+          <a:p>
+            <a:pPr algn="ctr" indent="0" marL="0">
+              <a:buNone/>
+            </a:pPr>
+            <a:r>
+              <a:rPr lang="en-US" sz="1800" b="1" dirty="0">
+                <a:solidFill>
+                  <a:srgbClr val="FF4D57"/>
+                </a:solidFill>
+                <a:latin typeface="Calibri" pitchFamily="34" charset="0"/>
+                <a:ea typeface="Calibri" pitchFamily="34" charset="-122"/>
+                <a:cs typeface="Calibri" pitchFamily="34" charset="-120"/>
+              </a:rPr>
+              <a:t>0  </a:t>
+            </a:r>
+            <a:pPr algn="ctr" indent="0" marL="0">
+              <a:buNone/>
+            </a:pPr>
+            <a:r>
+              <a:rPr lang="en-US" sz="1000" dirty="0">
+                <a:solidFill>
+                  <a:srgbClr val="8C9BB5"/>
+                </a:solidFill>
+                <a:latin typeface="Calibri" pitchFamily="34" charset="0"/>
+                <a:ea typeface="Calibri" pitchFamily="34" charset="-122"/>
+                <a:cs typeface="Calibri" pitchFamily="34" charset="-120"/>
+              </a:rPr>
+              <a:t>false positive</a:t>
+            </a:r>
+            <a:endParaRPr lang="en-US" sz="1800" dirty="0"/>
+          </a:p>
+        </p:txBody>
+      </p:sp>
+      <p:sp>
+        <p:nvSpPr>
+          <p:cNvPr id="31" name="Shape 29"/>
+          <p:cNvSpPr/>
+          <p:nvPr/>
+        </p:nvSpPr>
+        <p:spPr>
+          <a:xfrm>
+            <a:off x="3794760" y="4846320"/>
+            <a:ext cx="1828800" cy="777240"/>
+          </a:xfrm>
+          <a:prstGeom prst="roundRect">
+            <a:avLst>
+              <a:gd name="adj" fmla="val 9412"/>
+            </a:avLst>
+          </a:prstGeom>
+          <a:solidFill>
+            <a:srgbClr val="0F1420"/>
+          </a:solidFill>
+          <a:ln w="12700">
+            <a:solidFill>
+              <a:srgbClr val="1F2A3D"/>
+            </a:solidFill>
+            <a:prstDash val="solid"/>
+          </a:ln>
+          <a:effectLst>
+            <a:outerShdw sx="100000" sy="100000" kx="0" ky="0" algn="bl" rotWithShape="0" blurRad="88900" dist="38100" dir="5400000">
+              <a:srgbClr val="000000">
+                <a:alpha val="35000"/>
+              </a:srgbClr>
+            </a:outerShdw>
+          </a:effectLst>
+        </p:spPr>
+      </p:sp>
+      <p:sp>
+        <p:nvSpPr>
+          <p:cNvPr id="32" name="Text 30"/>
+          <p:cNvSpPr/>
+          <p:nvPr/>
+        </p:nvSpPr>
+        <p:spPr>
+          <a:xfrm>
+            <a:off x="3794760" y="4846320"/>
+            <a:ext cx="1828800" cy="777240"/>
+          </a:xfrm>
+          <a:prstGeom prst="rect">
+            <a:avLst/>
+          </a:prstGeom>
+          <a:noFill/>
+          <a:ln/>
+        </p:spPr>
+        <p:txBody>
+          <a:bodyPr wrap="square" rtlCol="0" anchor="ctr"/>
+          <a:lstStyle/>
+          <a:p>
+            <a:pPr algn="ctr" indent="0" marL="0">
+              <a:buNone/>
+            </a:pPr>
+            <a:r>
+              <a:rPr lang="en-US" sz="1800" b="1" dirty="0">
+                <a:solidFill>
+                  <a:srgbClr val="2ECC71"/>
+                </a:solidFill>
+                <a:latin typeface="Calibri" pitchFamily="34" charset="0"/>
+                <a:ea typeface="Calibri" pitchFamily="34" charset="-122"/>
+                <a:cs typeface="Calibri" pitchFamily="34" charset="-120"/>
+              </a:rPr>
+              <a:t>20  </a:t>
+            </a:r>
+            <a:pPr algn="ctr" indent="0" marL="0">
+              <a:buNone/>
+            </a:pPr>
+            <a:r>
+              <a:rPr lang="en-US" sz="1000" dirty="0">
+                <a:solidFill>
+                  <a:srgbClr val="8C9BB5"/>
+                </a:solidFill>
+                <a:latin typeface="Calibri" pitchFamily="34" charset="0"/>
+                <a:ea typeface="Calibri" pitchFamily="34" charset="-122"/>
+                <a:cs typeface="Calibri" pitchFamily="34" charset="-120"/>
+              </a:rPr>
+              <a:t>true negative</a:t>
+            </a:r>
+            <a:endParaRPr lang="en-US" sz="1800" dirty="0"/>
+          </a:p>
+        </p:txBody>
+      </p:sp>
+      <p:sp>
+        <p:nvSpPr>
+          <p:cNvPr id="33" name="Shape 31"/>
+          <p:cNvSpPr/>
+          <p:nvPr/>
+        </p:nvSpPr>
+        <p:spPr>
+          <a:xfrm>
+            <a:off x="6263640" y="3246120"/>
+            <a:ext cx="5349240" cy="2514600"/>
+          </a:xfrm>
+          <a:prstGeom prst="roundRect">
+            <a:avLst>
+              <a:gd name="adj" fmla="val 2909"/>
+            </a:avLst>
+          </a:prstGeom>
+          <a:solidFill>
+            <a:srgbClr val="0F1420"/>
+          </a:solidFill>
+          <a:ln w="12700">
+            <a:solidFill>
+              <a:srgbClr val="1F2A3D"/>
+            </a:solidFill>
+            <a:prstDash val="solid"/>
+          </a:ln>
+          <a:effectLst>
+            <a:outerShdw sx="100000" sy="100000" kx="0" ky="0" algn="bl" rotWithShape="0" blurRad="88900" dist="38100" dir="5400000">
+              <a:srgbClr val="000000">
+                <a:alpha val="35000"/>
+              </a:srgbClr>
+            </a:outerShdw>
+          </a:effectLst>
+        </p:spPr>
+      </p:sp>
+      <p:sp>
+        <p:nvSpPr>
+          <p:cNvPr id="34" name="Text 32"/>
+          <p:cNvSpPr/>
+          <p:nvPr/>
+        </p:nvSpPr>
+        <p:spPr>
+          <a:xfrm>
+            <a:off x="6492240" y="3401568"/>
+            <a:ext cx="4937760" cy="365760"/>
           </a:xfrm>
           <a:prstGeom prst="rect">
             <a:avLst/>
@@ -8285,7 +9630,7 @@
               <a:buNone/>
             </a:pPr>
             <a:r>
-              <a:rPr lang="en-US" sz="1450" b="1" dirty="0">
+              <a:rPr lang="en-US" sz="1400" b="1" dirty="0">
                 <a:solidFill>
                   <a:srgbClr val="3EA6FF"/>
                 </a:solidFill>
@@ -8293,38 +9638,42 @@
                 <a:ea typeface="Cambria" pitchFamily="34" charset="-122"/>
                 <a:cs typeface="Cambria" pitchFamily="34" charset="-120"/>
               </a:rPr>
-              <a:t>User Experience (15%)</a:t>
-            </a:r>
-            <a:endParaRPr lang="en-US" sz="1450" dirty="0"/>
-          </a:p>
-        </p:txBody>
-      </p:sp>
-      <p:sp>
-        <p:nvSpPr>
-          <p:cNvPr id="17" name="Text 15"/>
-          <p:cNvSpPr/>
-          <p:nvPr/>
-        </p:nvSpPr>
-        <p:spPr>
-          <a:xfrm>
-            <a:off x="4114800" y="4828032"/>
-            <a:ext cx="7315200" cy="731520"/>
-          </a:xfrm>
-          <a:prstGeom prst="rect">
-            <a:avLst/>
-          </a:prstGeom>
-          <a:noFill/>
-          <a:ln/>
-        </p:spPr>
-        <p:txBody>
-          <a:bodyPr wrap="square" rtlCol="0" anchor="ctr"/>
-          <a:lstStyle/>
-          <a:p>
-            <a:pPr indent="0" marL="0">
-              <a:buNone/>
-            </a:pPr>
-            <a:r>
-              <a:rPr lang="en-US" sz="1300" dirty="0">
+              <a:t>What the numbers prove</a:t>
+            </a:r>
+            <a:endParaRPr lang="en-US" sz="1400" dirty="0"/>
+          </a:p>
+        </p:txBody>
+      </p:sp>
+      <p:sp>
+        <p:nvSpPr>
+          <p:cNvPr id="35" name="Text 33"/>
+          <p:cNvSpPr/>
+          <p:nvPr/>
+        </p:nvSpPr>
+        <p:spPr>
+          <a:xfrm>
+            <a:off x="6492240" y="3840480"/>
+            <a:ext cx="4937760" cy="1828800"/>
+          </a:xfrm>
+          <a:prstGeom prst="rect">
+            <a:avLst/>
+          </a:prstGeom>
+          <a:noFill/>
+          <a:ln/>
+        </p:spPr>
+        <p:txBody>
+          <a:bodyPr wrap="square" rtlCol="0" anchor="ctr"/>
+          <a:lstStyle/>
+          <a:p>
+            <a:pPr marL="342900" indent="-342900">
+              <a:spcAft>
+                <a:spcPts val="900"/>
+              </a:spcAft>
+              <a:buSzPct val="100000"/>
+              <a:buChar char="•"/>
+            </a:pPr>
+            <a:r>
+              <a:rPr lang="en-US" sz="1250" dirty="0">
                 <a:solidFill>
                   <a:srgbClr val="E6EDF6"/>
                 </a:solidFill>
@@ -8332,15 +9681,78 @@
                 <a:ea typeface="Calibri" pitchFamily="34" charset="-122"/>
                 <a:cs typeface="Calibri" pitchFamily="34" charset="-120"/>
               </a:rPr>
-              <a:t>Command-centre dashboard + 12-language citizen chatbot on WhatsApp/IVR/app.</a:t>
-            </a:r>
-            <a:endParaRPr lang="en-US" sz="1300" dirty="0"/>
-          </a:p>
-        </p:txBody>
-      </p:sp>
-      <p:sp>
-        <p:nvSpPr>
-          <p:cNvPr id="18" name="Text 16"/>
+              <a:t>Zero false positives on benign traffic — the evaluation's hardest bar for a citizen-facing tool.</a:t>
+            </a:r>
+            <a:endParaRPr lang="en-US" sz="1250" dirty="0"/>
+          </a:p>
+          <a:p>
+            <a:pPr marL="342900" indent="-342900">
+              <a:spcAft>
+                <a:spcPts val="900"/>
+              </a:spcAft>
+              <a:buSzPct val="100000"/>
+              <a:buChar char="•"/>
+            </a:pPr>
+            <a:r>
+              <a:rPr lang="en-US" sz="1250" dirty="0">
+                <a:solidFill>
+                  <a:srgbClr val="E6EDF6"/>
+                </a:solidFill>
+                <a:latin typeface="Calibri" pitchFamily="34" charset="0"/>
+                <a:ea typeface="Calibri" pitchFamily="34" charset="-122"/>
+                <a:cs typeface="Calibri" pitchFamily="34" charset="-120"/>
+              </a:rPr>
+              <a:t>Covers 7 scam families, not just digital-arrest.</a:t>
+            </a:r>
+            <a:endParaRPr lang="en-US" sz="1250" dirty="0"/>
+          </a:p>
+          <a:p>
+            <a:pPr marL="342900" indent="-342900">
+              <a:spcAft>
+                <a:spcPts val="900"/>
+              </a:spcAft>
+              <a:buSzPct val="100000"/>
+              <a:buChar char="•"/>
+            </a:pPr>
+            <a:r>
+              <a:rPr lang="en-US" sz="1250" dirty="0">
+                <a:solidFill>
+                  <a:srgbClr val="E6EDF6"/>
+                </a:solidFill>
+                <a:latin typeface="Calibri" pitchFamily="34" charset="0"/>
+                <a:ea typeface="Calibri" pitchFamily="34" charset="-122"/>
+                <a:cs typeface="Calibri" pitchFamily="34" charset="-120"/>
+              </a:rPr>
+              <a:t>Only misses are deliberately vague messages — shown openly, no cherry-picking.</a:t>
+            </a:r>
+            <a:endParaRPr lang="en-US" sz="1250" dirty="0"/>
+          </a:p>
+          <a:p>
+            <a:pPr marL="342900" indent="-342900">
+              <a:spcAft>
+                <a:spcPts val="900"/>
+              </a:spcAft>
+              <a:buSzPct val="100000"/>
+              <a:buChar char="•"/>
+            </a:pPr>
+            <a:r>
+              <a:rPr lang="en-US" sz="1250" dirty="0">
+                <a:solidFill>
+                  <a:srgbClr val="E6EDF6"/>
+                </a:solidFill>
+                <a:latin typeface="Calibri" pitchFamily="34" charset="0"/>
+                <a:ea typeface="Calibri" pitchFamily="34" charset="-122"/>
+                <a:cs typeface="Calibri" pitchFamily="34" charset="-120"/>
+              </a:rPr>
+              <a:t>Glass-box: every score traces to a matched phrase (court-admissible).</a:t>
+            </a:r>
+            <a:endParaRPr lang="en-US" sz="1250" dirty="0"/>
+          </a:p>
+        </p:txBody>
+      </p:sp>
+      <p:sp>
+        <p:nvSpPr>
+          <p:cNvPr id="36" name="Text 34"/>
           <p:cNvSpPr/>
           <p:nvPr/>
         </p:nvSpPr>
@@ -8379,7 +9791,7 @@
       </p:sp>
       <p:sp>
         <p:nvSpPr>
-          <p:cNvPr id="19" name="Text 17"/>
+          <p:cNvPr id="37" name="Text 35"/>
           <p:cNvSpPr/>
           <p:nvPr/>
         </p:nvSpPr>
@@ -8481,7 +9893,7 @@
                 <a:ea typeface="Cambria" pitchFamily="34" charset="-122"/>
                 <a:cs typeface="Cambria" pitchFamily="34" charset="-120"/>
               </a:rPr>
-              <a:t>Built today · production tomorrow</a:t>
+              <a:t>Impact &amp; alignment to judging criteria</a:t>
             </a:r>
             <a:endParaRPr lang="en-US" sz="2800" dirty="0"/>
           </a:p>
@@ -8496,11 +9908,11 @@
         <p:spPr>
           <a:xfrm>
             <a:off x="548640" y="1463040"/>
-            <a:ext cx="5486400" cy="4114800"/>
+            <a:ext cx="11064240" cy="731520"/>
           </a:xfrm>
           <a:prstGeom prst="roundRect">
             <a:avLst>
-              <a:gd name="adj" fmla="val 1778"/>
+              <a:gd name="adj" fmla="val 10000"/>
             </a:avLst>
           </a:prstGeom>
           <a:solidFill>
@@ -8529,8 +9941,8 @@
         </p:nvSpPr>
         <p:spPr>
           <a:xfrm>
-            <a:off x="777240" y="1645920"/>
-            <a:ext cx="5029200" cy="365760"/>
+            <a:off x="777240" y="1463040"/>
+            <a:ext cx="3291840" cy="731520"/>
           </a:xfrm>
           <a:prstGeom prst="rect">
             <a:avLst/>
@@ -8546,17 +9958,17 @@
               <a:buNone/>
             </a:pPr>
             <a:r>
-              <a:rPr lang="en-US" sz="1600" b="1" dirty="0">
-                <a:solidFill>
-                  <a:srgbClr val="2ECC71"/>
+              <a:rPr lang="en-US" sz="1450" b="1" dirty="0">
+                <a:solidFill>
+                  <a:srgbClr val="3EA6FF"/>
                 </a:solidFill>
                 <a:latin typeface="Cambria" pitchFamily="34" charset="0"/>
                 <a:ea typeface="Cambria" pitchFamily="34" charset="-122"/>
                 <a:cs typeface="Cambria" pitchFamily="34" charset="-120"/>
               </a:rPr>
-              <a:t>Working prototype (this build)</a:t>
-            </a:r>
-            <a:endParaRPr lang="en-US" sz="1600" dirty="0"/>
+              <a:t>Innovation (25%)</a:t>
+            </a:r>
+            <a:endParaRPr lang="en-US" sz="1450" dirty="0"/>
           </a:p>
         </p:txBody>
       </p:sp>
@@ -8568,25 +9980,21 @@
         </p:nvSpPr>
         <p:spPr>
           <a:xfrm>
-            <a:off x="777240" y="2148840"/>
-            <a:ext cx="5029200" cy="3108960"/>
-          </a:xfrm>
-          <a:prstGeom prst="rect">
-            <a:avLst/>
-          </a:prstGeom>
-          <a:noFill/>
-          <a:ln/>
-        </p:spPr>
-        <p:txBody>
-          <a:bodyPr wrap="square" rtlCol="0" anchor="ctr"/>
-          <a:lstStyle/>
-          <a:p>
-            <a:pPr marL="342900" indent="-342900">
-              <a:spcAft>
-                <a:spcPts val="1000"/>
-              </a:spcAft>
-              <a:buSzPct val="100000"/>
-              <a:buChar char="•"/>
+            <a:off x="4114800" y="1463040"/>
+            <a:ext cx="7315200" cy="731520"/>
+          </a:xfrm>
+          <a:prstGeom prst="rect">
+            <a:avLst/>
+          </a:prstGeom>
+          <a:noFill/>
+          <a:ln/>
+        </p:spPr>
+        <p:txBody>
+          <a:bodyPr wrap="square" rtlCol="0" anchor="ctr"/>
+          <a:lstStyle/>
+          <a:p>
+            <a:pPr indent="0" marL="0">
+              <a:buNone/>
             </a:pPr>
             <a:r>
               <a:rPr lang="en-US" sz="1300" dirty="0">
@@ -8597,73 +10005,10 @@
                 <a:ea typeface="Calibri" pitchFamily="34" charset="-122"/>
                 <a:cs typeface="Calibri" pitchFamily="34" charset="-120"/>
               </a:rPr>
-              <a:t>FastAPI backend, 5 live modules, one command-centre UI.</a:t>
+              <a:t>Kill-chain scam modelling + lead-time KPI + cross-domain entity fusion.</a:t>
             </a:r>
             <a:endParaRPr lang="en-US" sz="1300" dirty="0"/>
           </a:p>
-          <a:p>
-            <a:pPr marL="342900" indent="-342900">
-              <a:spcAft>
-                <a:spcPts val="1000"/>
-              </a:spcAft>
-              <a:buSzPct val="100000"/>
-              <a:buChar char="•"/>
-            </a:pPr>
-            <a:r>
-              <a:rPr lang="en-US" sz="1300" dirty="0">
-                <a:solidFill>
-                  <a:srgbClr val="E6EDF6"/>
-                </a:solidFill>
-                <a:latin typeface="Calibri" pitchFamily="34" charset="0"/>
-                <a:ea typeface="Calibri" pitchFamily="34" charset="-122"/>
-                <a:cs typeface="Calibri" pitchFamily="34" charset="-120"/>
-              </a:rPr>
-              <a:t>Explainable scam scorer + 7-feature note forensics (PIL/numpy).</a:t>
-            </a:r>
-            <a:endParaRPr lang="en-US" sz="1300" dirty="0"/>
-          </a:p>
-          <a:p>
-            <a:pPr marL="342900" indent="-342900">
-              <a:spcAft>
-                <a:spcPts val="1000"/>
-              </a:spcAft>
-              <a:buSzPct val="100000"/>
-              <a:buChar char="•"/>
-            </a:pPr>
-            <a:r>
-              <a:rPr lang="en-US" sz="1300" dirty="0">
-                <a:solidFill>
-                  <a:srgbClr val="E6EDF6"/>
-                </a:solidFill>
-                <a:latin typeface="Calibri" pitchFamily="34" charset="0"/>
-                <a:ea typeface="Calibri" pitchFamily="34" charset="-122"/>
-                <a:cs typeface="Calibri" pitchFamily="34" charset="-120"/>
-              </a:rPr>
-              <a:t>networkx graph engine with hashed intelligence packages.</a:t>
-            </a:r>
-            <a:endParaRPr lang="en-US" sz="1300" dirty="0"/>
-          </a:p>
-          <a:p>
-            <a:pPr marL="342900" indent="-342900">
-              <a:spcAft>
-                <a:spcPts val="1000"/>
-              </a:spcAft>
-              <a:buSzPct val="100000"/>
-              <a:buChar char="•"/>
-            </a:pPr>
-            <a:r>
-              <a:rPr lang="en-US" sz="1300" dirty="0">
-                <a:solidFill>
-                  <a:srgbClr val="E6EDF6"/>
-                </a:solidFill>
-                <a:latin typeface="Calibri" pitchFamily="34" charset="0"/>
-                <a:ea typeface="Calibri" pitchFamily="34" charset="-122"/>
-                <a:cs typeface="Calibri" pitchFamily="34" charset="-120"/>
-              </a:rPr>
-              <a:t>Leaflet command map + multilingual citizen chatbot.</a:t>
-            </a:r>
-            <a:endParaRPr lang="en-US" sz="1300" dirty="0"/>
-          </a:p>
         </p:txBody>
       </p:sp>
       <p:sp>
@@ -8674,12 +10019,12 @@
         </p:nvSpPr>
         <p:spPr>
           <a:xfrm>
-            <a:off x="6263640" y="1463040"/>
-            <a:ext cx="5349240" cy="4114800"/>
+            <a:off x="548640" y="2304288"/>
+            <a:ext cx="11064240" cy="731520"/>
           </a:xfrm>
           <a:prstGeom prst="roundRect">
             <a:avLst>
-              <a:gd name="adj" fmla="val 1778"/>
+              <a:gd name="adj" fmla="val 10000"/>
             </a:avLst>
           </a:prstGeom>
           <a:solidFill>
@@ -8708,8 +10053,8 @@
         </p:nvSpPr>
         <p:spPr>
           <a:xfrm>
-            <a:off x="6492240" y="1645920"/>
-            <a:ext cx="4937760" cy="365760"/>
+            <a:off x="777240" y="2304288"/>
+            <a:ext cx="3291840" cy="731520"/>
           </a:xfrm>
           <a:prstGeom prst="rect">
             <a:avLst/>
@@ -8725,7 +10070,7 @@
               <a:buNone/>
             </a:pPr>
             <a:r>
-              <a:rPr lang="en-US" sz="1600" b="1" dirty="0">
+              <a:rPr lang="en-US" sz="1450" b="1" dirty="0">
                 <a:solidFill>
                   <a:srgbClr val="3EA6FF"/>
                 </a:solidFill>
@@ -8733,9 +10078,9 @@
                 <a:ea typeface="Cambria" pitchFamily="34" charset="-122"/>
                 <a:cs typeface="Cambria" pitchFamily="34" charset="-120"/>
               </a:rPr>
-              <a:t>Production roadmap</a:t>
-            </a:r>
-            <a:endParaRPr lang="en-US" sz="1600" dirty="0"/>
+              <a:t>Business Impact (25%)</a:t>
+            </a:r>
+            <a:endParaRPr lang="en-US" sz="1450" dirty="0"/>
           </a:p>
         </p:txBody>
       </p:sp>
@@ -8747,25 +10092,21 @@
         </p:nvSpPr>
         <p:spPr>
           <a:xfrm>
-            <a:off x="6492240" y="2148840"/>
-            <a:ext cx="4937760" cy="3200400"/>
-          </a:xfrm>
-          <a:prstGeom prst="rect">
-            <a:avLst/>
-          </a:prstGeom>
-          <a:noFill/>
-          <a:ln/>
-        </p:spPr>
-        <p:txBody>
-          <a:bodyPr wrap="square" rtlCol="0" anchor="ctr"/>
-          <a:lstStyle/>
-          <a:p>
-            <a:pPr marL="342900" indent="-342900">
-              <a:spcAft>
-                <a:spcPts val="1000"/>
-              </a:spcAft>
-              <a:buSzPct val="100000"/>
-              <a:buChar char="•"/>
+            <a:off x="4114800" y="2304288"/>
+            <a:ext cx="7315200" cy="731520"/>
+          </a:xfrm>
+          <a:prstGeom prst="rect">
+            <a:avLst/>
+          </a:prstGeom>
+          <a:noFill/>
+          <a:ln/>
+        </p:spPr>
+        <p:txBody>
+          <a:bodyPr wrap="square" rtlCol="0" anchor="ctr"/>
+          <a:lstStyle/>
+          <a:p>
+            <a:pPr indent="0" marL="0">
+              <a:buNone/>
             </a:pPr>
             <a:r>
               <a:rPr lang="en-US" sz="1300" dirty="0">
@@ -8776,17 +10117,108 @@
                 <a:ea typeface="Calibri" pitchFamily="34" charset="-122"/>
                 <a:cs typeface="Calibri" pitchFamily="34" charset="-120"/>
               </a:rPr>
-              <a:t>Swap heuristics for fine-tuned models: transformer scam classifier, CNN/ViT per security ROI.</a:t>
+              <a:t>Targets a ₹1,776 Cr/yr loss vector; protects banks, telcos, citizens &amp; courts.</a:t>
             </a:r>
             <a:endParaRPr lang="en-US" sz="1300" dirty="0"/>
           </a:p>
-          <a:p>
-            <a:pPr marL="342900" indent="-342900">
-              <a:spcAft>
-                <a:spcPts val="1000"/>
-              </a:spcAft>
-              <a:buSzPct val="100000"/>
-              <a:buChar char="•"/>
+        </p:txBody>
+      </p:sp>
+      <p:sp>
+        <p:nvSpPr>
+          <p:cNvPr id="9" name="Shape 7"/>
+          <p:cNvSpPr/>
+          <p:nvPr/>
+        </p:nvSpPr>
+        <p:spPr>
+          <a:xfrm>
+            <a:off x="548640" y="3145536"/>
+            <a:ext cx="11064240" cy="731520"/>
+          </a:xfrm>
+          <a:prstGeom prst="roundRect">
+            <a:avLst>
+              <a:gd name="adj" fmla="val 10000"/>
+            </a:avLst>
+          </a:prstGeom>
+          <a:solidFill>
+            <a:srgbClr val="121826"/>
+          </a:solidFill>
+          <a:ln w="12700">
+            <a:solidFill>
+              <a:srgbClr val="1F2A3D"/>
+            </a:solidFill>
+            <a:prstDash val="solid"/>
+          </a:ln>
+          <a:effectLst>
+            <a:outerShdw sx="100000" sy="100000" kx="0" ky="0" algn="bl" rotWithShape="0" blurRad="88900" dist="38100" dir="5400000">
+              <a:srgbClr val="000000">
+                <a:alpha val="35000"/>
+              </a:srgbClr>
+            </a:outerShdw>
+          </a:effectLst>
+        </p:spPr>
+      </p:sp>
+      <p:sp>
+        <p:nvSpPr>
+          <p:cNvPr id="10" name="Text 8"/>
+          <p:cNvSpPr/>
+          <p:nvPr/>
+        </p:nvSpPr>
+        <p:spPr>
+          <a:xfrm>
+            <a:off x="777240" y="3145536"/>
+            <a:ext cx="3291840" cy="731520"/>
+          </a:xfrm>
+          <a:prstGeom prst="rect">
+            <a:avLst/>
+          </a:prstGeom>
+          <a:noFill/>
+          <a:ln/>
+        </p:spPr>
+        <p:txBody>
+          <a:bodyPr wrap="square" rtlCol="0" anchor="ctr"/>
+          <a:lstStyle/>
+          <a:p>
+            <a:pPr indent="0" marL="0">
+              <a:buNone/>
+            </a:pPr>
+            <a:r>
+              <a:rPr lang="en-US" sz="1450" b="1" dirty="0">
+                <a:solidFill>
+                  <a:srgbClr val="3EA6FF"/>
+                </a:solidFill>
+                <a:latin typeface="Cambria" pitchFamily="34" charset="0"/>
+                <a:ea typeface="Cambria" pitchFamily="34" charset="-122"/>
+                <a:cs typeface="Cambria" pitchFamily="34" charset="-120"/>
+              </a:rPr>
+              <a:t>Technical Excellence (20%)</a:t>
+            </a:r>
+            <a:endParaRPr lang="en-US" sz="1450" dirty="0"/>
+          </a:p>
+        </p:txBody>
+      </p:sp>
+      <p:sp>
+        <p:nvSpPr>
+          <p:cNvPr id="11" name="Text 9"/>
+          <p:cNvSpPr/>
+          <p:nvPr/>
+        </p:nvSpPr>
+        <p:spPr>
+          <a:xfrm>
+            <a:off x="4114800" y="3145536"/>
+            <a:ext cx="7315200" cy="731520"/>
+          </a:xfrm>
+          <a:prstGeom prst="rect">
+            <a:avLst/>
+          </a:prstGeom>
+          <a:noFill/>
+          <a:ln/>
+        </p:spPr>
+        <p:txBody>
+          <a:bodyPr wrap="square" rtlCol="0" anchor="ctr"/>
+          <a:lstStyle/>
+          <a:p>
+            <a:pPr indent="0" marL="0">
+              <a:buNone/>
             </a:pPr>
             <a:r>
               <a:rPr lang="en-US" sz="1300" dirty="0">
@@ -8797,17 +10229,108 @@
                 <a:ea typeface="Calibri" pitchFamily="34" charset="-122"/>
                 <a:cs typeface="Calibri" pitchFamily="34" charset="-120"/>
               </a:rPr>
-              <a:t>Speech-AI front-end for live synthetic-voice detection.</a:t>
+              <a:t>Graph AI, image forensics, explainable NLP, geospatial — in one API.</a:t>
             </a:r>
             <a:endParaRPr lang="en-US" sz="1300" dirty="0"/>
           </a:p>
-          <a:p>
-            <a:pPr marL="342900" indent="-342900">
-              <a:spcAft>
-                <a:spcPts val="1000"/>
-              </a:spcAft>
-              <a:buSzPct val="100000"/>
-              <a:buChar char="•"/>
+        </p:txBody>
+      </p:sp>
+      <p:sp>
+        <p:nvSpPr>
+          <p:cNvPr id="12" name="Shape 10"/>
+          <p:cNvSpPr/>
+          <p:nvPr/>
+        </p:nvSpPr>
+        <p:spPr>
+          <a:xfrm>
+            <a:off x="548640" y="3986784"/>
+            <a:ext cx="11064240" cy="731520"/>
+          </a:xfrm>
+          <a:prstGeom prst="roundRect">
+            <a:avLst>
+              <a:gd name="adj" fmla="val 10000"/>
+            </a:avLst>
+          </a:prstGeom>
+          <a:solidFill>
+            <a:srgbClr val="0F1420"/>
+          </a:solidFill>
+          <a:ln w="12700">
+            <a:solidFill>
+              <a:srgbClr val="1F2A3D"/>
+            </a:solidFill>
+            <a:prstDash val="solid"/>
+          </a:ln>
+          <a:effectLst>
+            <a:outerShdw sx="100000" sy="100000" kx="0" ky="0" algn="bl" rotWithShape="0" blurRad="88900" dist="38100" dir="5400000">
+              <a:srgbClr val="000000">
+                <a:alpha val="35000"/>
+              </a:srgbClr>
+            </a:outerShdw>
+          </a:effectLst>
+        </p:spPr>
+      </p:sp>
+      <p:sp>
+        <p:nvSpPr>
+          <p:cNvPr id="13" name="Text 11"/>
+          <p:cNvSpPr/>
+          <p:nvPr/>
+        </p:nvSpPr>
+        <p:spPr>
+          <a:xfrm>
+            <a:off x="777240" y="3986784"/>
+            <a:ext cx="3291840" cy="731520"/>
+          </a:xfrm>
+          <a:prstGeom prst="rect">
+            <a:avLst/>
+          </a:prstGeom>
+          <a:noFill/>
+          <a:ln/>
+        </p:spPr>
+        <p:txBody>
+          <a:bodyPr wrap="square" rtlCol="0" anchor="ctr"/>
+          <a:lstStyle/>
+          <a:p>
+            <a:pPr indent="0" marL="0">
+              <a:buNone/>
+            </a:pPr>
+            <a:r>
+              <a:rPr lang="en-US" sz="1450" b="1" dirty="0">
+                <a:solidFill>
+                  <a:srgbClr val="3EA6FF"/>
+                </a:solidFill>
+                <a:latin typeface="Cambria" pitchFamily="34" charset="0"/>
+                <a:ea typeface="Cambria" pitchFamily="34" charset="-122"/>
+                <a:cs typeface="Cambria" pitchFamily="34" charset="-120"/>
+              </a:rPr>
+              <a:t>Scalability (15%)</a:t>
+            </a:r>
+            <a:endParaRPr lang="en-US" sz="1450" dirty="0"/>
+          </a:p>
+        </p:txBody>
+      </p:sp>
+      <p:sp>
+        <p:nvSpPr>
+          <p:cNvPr id="14" name="Text 12"/>
+          <p:cNvSpPr/>
+          <p:nvPr/>
+        </p:nvSpPr>
+        <p:spPr>
+          <a:xfrm>
+            <a:off x="4114800" y="3986784"/>
+            <a:ext cx="7315200" cy="731520"/>
+          </a:xfrm>
+          <a:prstGeom prst="rect">
+            <a:avLst/>
+          </a:prstGeom>
+          <a:noFill/>
+          <a:ln/>
+        </p:spPr>
+        <p:txBody>
+          <a:bodyPr wrap="square" rtlCol="0" anchor="ctr"/>
+          <a:lstStyle/>
+          <a:p>
+            <a:pPr indent="0" marL="0">
+              <a:buNone/>
             </a:pPr>
             <a:r>
               <a:rPr lang="en-US" sz="1300" dirty="0">
@@ -8818,17 +10341,108 @@
                 <a:ea typeface="Calibri" pitchFamily="34" charset="-122"/>
                 <a:cs typeface="Calibri" pitchFamily="34" charset="-120"/>
               </a:rPr>
-              <a:t>IndicTrans + LLM for full 12-language NLG.</a:t>
+              <a:t>Stateless services; add scam templates without retraining; per-module scale-out.</a:t>
             </a:r>
             <a:endParaRPr lang="en-US" sz="1300" dirty="0"/>
           </a:p>
-          <a:p>
-            <a:pPr marL="342900" indent="-342900">
-              <a:spcAft>
-                <a:spcPts val="1000"/>
-              </a:spcAft>
-              <a:buSzPct val="100000"/>
-              <a:buChar char="•"/>
+        </p:txBody>
+      </p:sp>
+      <p:sp>
+        <p:nvSpPr>
+          <p:cNvPr id="15" name="Shape 13"/>
+          <p:cNvSpPr/>
+          <p:nvPr/>
+        </p:nvSpPr>
+        <p:spPr>
+          <a:xfrm>
+            <a:off x="548640" y="4828032"/>
+            <a:ext cx="11064240" cy="731520"/>
+          </a:xfrm>
+          <a:prstGeom prst="roundRect">
+            <a:avLst>
+              <a:gd name="adj" fmla="val 10000"/>
+            </a:avLst>
+          </a:prstGeom>
+          <a:solidFill>
+            <a:srgbClr val="121826"/>
+          </a:solidFill>
+          <a:ln w="12700">
+            <a:solidFill>
+              <a:srgbClr val="1F2A3D"/>
+            </a:solidFill>
+            <a:prstDash val="solid"/>
+          </a:ln>
+          <a:effectLst>
+            <a:outerShdw sx="100000" sy="100000" kx="0" ky="0" algn="bl" rotWithShape="0" blurRad="88900" dist="38100" dir="5400000">
+              <a:srgbClr val="000000">
+                <a:alpha val="35000"/>
+              </a:srgbClr>
+            </a:outerShdw>
+          </a:effectLst>
+        </p:spPr>
+      </p:sp>
+      <p:sp>
+        <p:nvSpPr>
+          <p:cNvPr id="16" name="Text 14"/>
+          <p:cNvSpPr/>
+          <p:nvPr/>
+        </p:nvSpPr>
+        <p:spPr>
+          <a:xfrm>
+            <a:off x="777240" y="4828032"/>
+            <a:ext cx="3291840" cy="731520"/>
+          </a:xfrm>
+          <a:prstGeom prst="rect">
+            <a:avLst/>
+          </a:prstGeom>
+          <a:noFill/>
+          <a:ln/>
+        </p:spPr>
+        <p:txBody>
+          <a:bodyPr wrap="square" rtlCol="0" anchor="ctr"/>
+          <a:lstStyle/>
+          <a:p>
+            <a:pPr indent="0" marL="0">
+              <a:buNone/>
+            </a:pPr>
+            <a:r>
+              <a:rPr lang="en-US" sz="1450" b="1" dirty="0">
+                <a:solidFill>
+                  <a:srgbClr val="3EA6FF"/>
+                </a:solidFill>
+                <a:latin typeface="Cambria" pitchFamily="34" charset="0"/>
+                <a:ea typeface="Cambria" pitchFamily="34" charset="-122"/>
+                <a:cs typeface="Cambria" pitchFamily="34" charset="-120"/>
+              </a:rPr>
+              <a:t>User Experience (15%)</a:t>
+            </a:r>
+            <a:endParaRPr lang="en-US" sz="1450" dirty="0"/>
+          </a:p>
+        </p:txBody>
+      </p:sp>
+      <p:sp>
+        <p:nvSpPr>
+          <p:cNvPr id="17" name="Text 15"/>
+          <p:cNvSpPr/>
+          <p:nvPr/>
+        </p:nvSpPr>
+        <p:spPr>
+          <a:xfrm>
+            <a:off x="4114800" y="4828032"/>
+            <a:ext cx="7315200" cy="731520"/>
+          </a:xfrm>
+          <a:prstGeom prst="rect">
+            <a:avLst/>
+          </a:prstGeom>
+          <a:noFill/>
+          <a:ln/>
+        </p:spPr>
+        <p:txBody>
+          <a:bodyPr wrap="square" rtlCol="0" anchor="ctr"/>
+          <a:lstStyle/>
+          <a:p>
+            <a:pPr indent="0" marL="0">
+              <a:buNone/>
             </a:pPr>
             <a:r>
               <a:rPr lang="en-US" sz="1300" dirty="0">
@@ -8839,36 +10453,15 @@
                 <a:ea typeface="Calibri" pitchFamily="34" charset="-122"/>
                 <a:cs typeface="Calibri" pitchFamily="34" charset="-120"/>
               </a:rPr>
-              <a:t>Real connectors: TSP CDR, NPCI/UPI, bank STR, NCRP/1930, I4C.</a:t>
+              <a:t>Command-centre dashboard + 12-language citizen chatbot on WhatsApp/IVR/app.</a:t>
             </a:r>
             <a:endParaRPr lang="en-US" sz="1300" dirty="0"/>
           </a:p>
-          <a:p>
-            <a:pPr marL="342900" indent="-342900">
-              <a:spcAft>
-                <a:spcPts val="1000"/>
-              </a:spcAft>
-              <a:buSzPct val="100000"/>
-              <a:buChar char="•"/>
-            </a:pPr>
-            <a:r>
-              <a:rPr lang="en-US" sz="1300" dirty="0">
-                <a:solidFill>
-                  <a:srgbClr val="E6EDF6"/>
-                </a:solidFill>
-                <a:latin typeface="Calibri" pitchFamily="34" charset="0"/>
-                <a:ea typeface="Calibri" pitchFamily="34" charset="-122"/>
-                <a:cs typeface="Calibri" pitchFamily="34" charset="-120"/>
-              </a:rPr>
-              <a:t>PII tokenisation at ingest; signed append-only audit ledger.</a:t>
-            </a:r>
-            <a:endParaRPr lang="en-US" sz="1300" dirty="0"/>
-          </a:p>
-        </p:txBody>
-      </p:sp>
-      <p:sp>
-        <p:nvSpPr>
-          <p:cNvPr id="9" name="Text 7"/>
+        </p:txBody>
+      </p:sp>
+      <p:sp>
+        <p:nvSpPr>
+          <p:cNvPr id="18" name="Text 16"/>
           <p:cNvSpPr/>
           <p:nvPr/>
         </p:nvSpPr>
@@ -8907,7 +10500,7 @@
       </p:sp>
       <p:sp>
         <p:nvSpPr>
-          <p:cNvPr id="10" name="Text 8"/>
+          <p:cNvPr id="19" name="Text 17"/>
           <p:cNvSpPr/>
           <p:nvPr/>
         </p:nvSpPr>

</xml_diff>

<commit_message>
Add counterfeit accuracy benchmark across denominations
- Calibrate per-denomination colour baselines from genuine RBI notes
- Make scorer robust to real scans: crop to note region, mask white background
- Add genuine reference notes (Wikimedia Commons) for ₹10–₹500 + fetch script
- Add counterfeit_eval.py + GET /api/eval/counterfeit (per-denomination accuracy)
- Extend Model Performance page with counterfeit accuracy (KPIs + per-denom table)
- Demo now uses a real note (₹500 → GENUINE); add accuracy screenshot + README/deck
- Result: 100% genuine-acceptance, 0% false-rejection across 6 denominations (12 notes)
</commit_message>
<xml_diff>
--- a/docs/Prahari_Pitch_Deck.pptx
+++ b/docs/Prahari_Pitch_Deck.pptx
@@ -9758,6 +9758,59 @@
         </p:nvSpPr>
         <p:spPr>
           <a:xfrm>
+            <a:off x="548640" y="5897880"/>
+            <a:ext cx="11064240" cy="411480"/>
+          </a:xfrm>
+          <a:prstGeom prst="rect">
+            <a:avLst/>
+          </a:prstGeom>
+          <a:noFill/>
+          <a:ln/>
+        </p:spPr>
+        <p:txBody>
+          <a:bodyPr wrap="square" rtlCol="0" anchor="ctr"/>
+          <a:lstStyle/>
+          <a:p>
+            <a:pPr algn="ctr" indent="0" marL="0">
+              <a:buNone/>
+            </a:pPr>
+            <a:r>
+              <a:rPr lang="en-US" sz="1250" b="1" dirty="0">
+                <a:solidFill>
+                  <a:srgbClr val="F5A623"/>
+                </a:solidFill>
+                <a:latin typeface="Calibri" pitchFamily="34" charset="0"/>
+                <a:ea typeface="Calibri" pitchFamily="34" charset="-122"/>
+                <a:cs typeface="Calibri" pitchFamily="34" charset="-120"/>
+              </a:rPr>
+              <a:t>Counterfeit agent:  </a:t>
+            </a:r>
+            <a:pPr algn="ctr" indent="0" marL="0">
+              <a:buNone/>
+            </a:pPr>
+            <a:r>
+              <a:rPr lang="en-US" sz="1250" dirty="0">
+                <a:solidFill>
+                  <a:srgbClr val="E6EDF6"/>
+                </a:solidFill>
+                <a:latin typeface="Calibri" pitchFamily="34" charset="0"/>
+                <a:ea typeface="Calibri" pitchFamily="34" charset="-122"/>
+                <a:cs typeface="Calibri" pitchFamily="34" charset="-120"/>
+              </a:rPr>
+              <a:t>100% genuine-acceptance · 0% false-rejection across all 6 denominations (12 genuine RBI notes) · synthetic fake detected.</a:t>
+            </a:r>
+            <a:endParaRPr lang="en-US" sz="1250" dirty="0"/>
+          </a:p>
+        </p:txBody>
+      </p:sp>
+      <p:sp>
+        <p:nvSpPr>
+          <p:cNvPr id="37" name="Text 35"/>
+          <p:cNvSpPr/>
+          <p:nvPr/>
+        </p:nvSpPr>
+        <p:spPr>
+          <a:xfrm>
             <a:off x="457200" y="6473952"/>
             <a:ext cx="7315200" cy="274320"/>
           </a:xfrm>
@@ -9791,7 +9844,7 @@
       </p:sp>
       <p:sp>
         <p:nvSpPr>
-          <p:cNvPr id="37" name="Text 35"/>
+          <p:cNvPr id="38" name="Text 36"/>
           <p:cNvSpPr/>
           <p:nvPr/>
         </p:nvSpPr>

</xml_diff>

<commit_message>
Add ₹2000 + extra note features, graph community detection, OCR intake, audit ledger
Counterfeit:
- Add ₹2000 denomination; 2 new security features (watermark window, colour-shift numeral) → 9 features
- 100% genuine-acceptance / 0% false-rejection across 7 denominations (14 genuine notes)

Fraud graph:
- Real community detection (Clauset-Newman-Moore modularity); report modularity Q + per-campaign cells

Citizen Shield:
- Screenshot upload → on-device OCR (RapidOCR/ONNX) → scam assessment

Legal admissibility:
- Tamper-evident hash-chained audit ledger (model version, input SHA-256, verdict) + /api/audit/recent
- Exact per-signal contribution attribution on scam verdicts (additive model = true Shapley values)

UI: contribution bars, fraud cells/modularity, counterfeit accuracy, OCR upload, audit ledger panel
Docs: README + deck updated; screenshots refreshed (+audit ledger)
</commit_message>
<xml_diff>
--- a/docs/Prahari_Pitch_Deck.pptx
+++ b/docs/Prahari_Pitch_Deck.pptx
@@ -2575,13 +2575,13 @@
           <a:p>
             <a:pPr marL="342900" indent="-342900">
               <a:spcAft>
-                <a:spcPts val="1000"/>
+                <a:spcPts val="700"/>
               </a:spcAft>
               <a:buSzPct val="100000"/>
               <a:buChar char="•"/>
             </a:pPr>
             <a:r>
-              <a:rPr lang="en-US" sz="1300" dirty="0">
+              <a:rPr lang="en-US" sz="1250" dirty="0">
                 <a:solidFill>
                   <a:srgbClr val="E6EDF6"/>
                 </a:solidFill>
@@ -2591,18 +2591,18 @@
               </a:rPr>
               <a:t>FastAPI backend, 5 live modules, one command-centre UI.</a:t>
             </a:r>
-            <a:endParaRPr lang="en-US" sz="1300" dirty="0"/>
+            <a:endParaRPr lang="en-US" sz="1250" dirty="0"/>
           </a:p>
           <a:p>
             <a:pPr marL="342900" indent="-342900">
               <a:spcAft>
-                <a:spcPts val="1000"/>
+                <a:spcPts val="700"/>
               </a:spcAft>
               <a:buSzPct val="100000"/>
               <a:buChar char="•"/>
             </a:pPr>
             <a:r>
-              <a:rPr lang="en-US" sz="1300" dirty="0">
+              <a:rPr lang="en-US" sz="1250" dirty="0">
                 <a:solidFill>
                   <a:srgbClr val="E6EDF6"/>
                 </a:solidFill>
@@ -2610,20 +2610,20 @@
                 <a:ea typeface="Calibri" pitchFamily="34" charset="-122"/>
                 <a:cs typeface="Calibri" pitchFamily="34" charset="-120"/>
               </a:rPr>
-              <a:t>Explainable scam scorer + 7-feature note forensics (PIL/numpy).</a:t>
-            </a:r>
-            <a:endParaRPr lang="en-US" sz="1300" dirty="0"/>
+              <a:t>Explainable scam scorer (7 families) with exact per-signal attribution.</a:t>
+            </a:r>
+            <a:endParaRPr lang="en-US" sz="1250" dirty="0"/>
           </a:p>
           <a:p>
             <a:pPr marL="342900" indent="-342900">
               <a:spcAft>
-                <a:spcPts val="1000"/>
+                <a:spcPts val="700"/>
               </a:spcAft>
               <a:buSzPct val="100000"/>
               <a:buChar char="•"/>
             </a:pPr>
             <a:r>
-              <a:rPr lang="en-US" sz="1300" dirty="0">
+              <a:rPr lang="en-US" sz="1250" dirty="0">
                 <a:solidFill>
                   <a:srgbClr val="E6EDF6"/>
                 </a:solidFill>
@@ -2631,20 +2631,20 @@
                 <a:ea typeface="Calibri" pitchFamily="34" charset="-122"/>
                 <a:cs typeface="Calibri" pitchFamily="34" charset="-120"/>
               </a:rPr>
-              <a:t>networkx graph engine with hashed intelligence packages.</a:t>
-            </a:r>
-            <a:endParaRPr lang="en-US" sz="1300" dirty="0"/>
+              <a:t>9-feature note forensics across ₹10–₹2000, calibrated on genuine notes.</a:t>
+            </a:r>
+            <a:endParaRPr lang="en-US" sz="1250" dirty="0"/>
           </a:p>
           <a:p>
             <a:pPr marL="342900" indent="-342900">
               <a:spcAft>
-                <a:spcPts val="1000"/>
+                <a:spcPts val="700"/>
               </a:spcAft>
               <a:buSzPct val="100000"/>
               <a:buChar char="•"/>
             </a:pPr>
             <a:r>
-              <a:rPr lang="en-US" sz="1300" dirty="0">
+              <a:rPr lang="en-US" sz="1250" dirty="0">
                 <a:solidFill>
                   <a:srgbClr val="E6EDF6"/>
                 </a:solidFill>
@@ -2652,9 +2652,51 @@
                 <a:ea typeface="Calibri" pitchFamily="34" charset="-122"/>
                 <a:cs typeface="Calibri" pitchFamily="34" charset="-120"/>
               </a:rPr>
-              <a:t>Leaflet command map + multilingual citizen chatbot.</a:t>
-            </a:r>
-            <a:endParaRPr lang="en-US" sz="1300" dirty="0"/>
+              <a:t>Graph community detection (modularity) + lead-time KPI.</a:t>
+            </a:r>
+            <a:endParaRPr lang="en-US" sz="1250" dirty="0"/>
+          </a:p>
+          <a:p>
+            <a:pPr marL="342900" indent="-342900">
+              <a:spcAft>
+                <a:spcPts val="700"/>
+              </a:spcAft>
+              <a:buSzPct val="100000"/>
+              <a:buChar char="•"/>
+            </a:pPr>
+            <a:r>
+              <a:rPr lang="en-US" sz="1250" dirty="0">
+                <a:solidFill>
+                  <a:srgbClr val="E6EDF6"/>
+                </a:solidFill>
+                <a:latin typeface="Calibri" pitchFamily="34" charset="0"/>
+                <a:ea typeface="Calibri" pitchFamily="34" charset="-122"/>
+                <a:cs typeface="Calibri" pitchFamily="34" charset="-120"/>
+              </a:rPr>
+              <a:t>On-device OCR screenshot intake + 12-language citizen chatbot.</a:t>
+            </a:r>
+            <a:endParaRPr lang="en-US" sz="1250" dirty="0"/>
+          </a:p>
+          <a:p>
+            <a:pPr marL="342900" indent="-342900">
+              <a:spcAft>
+                <a:spcPts val="700"/>
+              </a:spcAft>
+              <a:buSzPct val="100000"/>
+              <a:buChar char="•"/>
+            </a:pPr>
+            <a:r>
+              <a:rPr lang="en-US" sz="1250" dirty="0">
+                <a:solidFill>
+                  <a:srgbClr val="E6EDF6"/>
+                </a:solidFill>
+                <a:latin typeface="Calibri" pitchFamily="34" charset="0"/>
+                <a:ea typeface="Calibri" pitchFamily="34" charset="-122"/>
+                <a:cs typeface="Calibri" pitchFamily="34" charset="-120"/>
+              </a:rPr>
+              <a:t>Tamper-evident hash-chained audit ledger for admissibility.</a:t>
+            </a:r>
+            <a:endParaRPr lang="en-US" sz="1250" dirty="0"/>
           </a:p>
         </p:txBody>
       </p:sp>

</xml_diff>

<commit_message>
Add Indian datasets: synthetic scam corpus, UPI fraud graph, NCRB geo, Kaggle scaffold
Scam detection:
- Synthetic Indian scam corpus (backend/scam_corpus.py, schema call_text/label/agency_claimed/risk)
- 12 categories incl investment/job/romance/UPI collect-request; +classifier groups
- Fix malformed UPI regex (was flagging benign UPI receipts) → FPR back to 0%
- Combined benchmark: 92 messages, precision 100%, recall 96.9%, F1 98.4%, FPR 0%

Fraud graph (Indian context):
- UPI IDs, Paytm/GPay wallets, bank accounts, crypto exits; upi_transfer edges
- Money-handle aware campaign intelligence; frontend legend/colours updated
- Kaggle PaySim scaffold (sample_data/fetch_kaggle.py + backend/kaggle_fraud.py)

Geospatial:
- Real NCRB 'Crime in India 2022' state cybercrime stats (sample_data CSV) + loader
- State bars + proportional map markers in the geo view

Docs: README data-sources table + metrics; deck updated; screenshots refreshed (+NCRB)
</commit_message>
<xml_diff>
--- a/docs/Prahari_Pitch_Deck.pptx
+++ b/docs/Prahari_Pitch_Deck.pptx
@@ -2610,7 +2610,7 @@
                 <a:ea typeface="Calibri" pitchFamily="34" charset="-122"/>
                 <a:cs typeface="Calibri" pitchFamily="34" charset="-120"/>
               </a:rPr>
-              <a:t>Explainable scam scorer (7 families) with exact per-signal attribution.</a:t>
+              <a:t>Explainable scam scorer (12 categories) with exact per-signal attribution.</a:t>
             </a:r>
             <a:endParaRPr lang="en-US" sz="1250" dirty="0"/>
           </a:p>
@@ -2652,7 +2652,28 @@
                 <a:ea typeface="Calibri" pitchFamily="34" charset="-122"/>
                 <a:cs typeface="Calibri" pitchFamily="34" charset="-120"/>
               </a:rPr>
-              <a:t>Graph community detection (modularity) + lead-time KPI.</a:t>
+              <a:t>Indian-context graph (UPI/wallet/crypto) + modularity community detection + lead-time.</a:t>
+            </a:r>
+            <a:endParaRPr lang="en-US" sz="1250" dirty="0"/>
+          </a:p>
+          <a:p>
+            <a:pPr marL="342900" indent="-342900">
+              <a:spcAft>
+                <a:spcPts val="700"/>
+              </a:spcAft>
+              <a:buSzPct val="100000"/>
+              <a:buChar char="•"/>
+            </a:pPr>
+            <a:r>
+              <a:rPr lang="en-US" sz="1250" dirty="0">
+                <a:solidFill>
+                  <a:srgbClr val="E6EDF6"/>
+                </a:solidFill>
+                <a:latin typeface="Calibri" pitchFamily="34" charset="0"/>
+                <a:ea typeface="Calibri" pitchFamily="34" charset="-122"/>
+                <a:cs typeface="Calibri" pitchFamily="34" charset="-120"/>
+              </a:rPr>
+              <a:t>Real NCRB state cybercrime data on the geospatial layer.</a:t>
             </a:r>
             <a:endParaRPr lang="en-US" sz="1250" dirty="0"/>
           </a:p>
@@ -8655,7 +8676,7 @@
                 <a:ea typeface="Cambria" pitchFamily="34" charset="-122"/>
                 <a:cs typeface="Cambria" pitchFamily="34" charset="-120"/>
               </a:rPr>
-              <a:t>92.3%</a:t>
+              <a:t>96.9%</a:t>
             </a:r>
             <a:endParaRPr lang="en-US" sz="3000" dirty="0"/>
           </a:p>
@@ -8767,7 +8788,7 @@
                 <a:ea typeface="Cambria" pitchFamily="34" charset="-122"/>
                 <a:cs typeface="Cambria" pitchFamily="34" charset="-120"/>
               </a:rPr>
-              <a:t>96.0%</a:t>
+              <a:t>98.4%</a:t>
             </a:r>
             <a:endParaRPr lang="en-US" sz="3000" dirty="0"/>
           </a:p>
@@ -8879,7 +8900,7 @@
                 <a:ea typeface="Cambria" pitchFamily="34" charset="-122"/>
                 <a:cs typeface="Cambria" pitchFamily="34" charset="-120"/>
               </a:rPr>
-              <a:t>95.7%</a:t>
+              <a:t>97.8%</a:t>
             </a:r>
             <a:endParaRPr lang="en-US" sz="3000" dirty="0"/>
           </a:p>
@@ -9079,7 +9100,7 @@
         <p:spPr>
           <a:xfrm>
             <a:off x="777240" y="3401568"/>
-            <a:ext cx="5029200" cy="365760"/>
+            <a:ext cx="5212080" cy="365760"/>
           </a:xfrm>
           <a:prstGeom prst="rect">
             <a:avLst/>
@@ -9095,7 +9116,7 @@
               <a:buNone/>
             </a:pPr>
             <a:r>
-              <a:rPr lang="en-US" sz="1400" b="1" dirty="0">
+              <a:rPr lang="en-US" sz="1300" b="1" dirty="0">
                 <a:solidFill>
                   <a:srgbClr val="3EA6FF"/>
                 </a:solidFill>
@@ -9103,9 +9124,9 @@
                 <a:ea typeface="Cambria" pitchFamily="34" charset="-122"/>
                 <a:cs typeface="Cambria" pitchFamily="34" charset="-120"/>
               </a:rPr>
-              <a:t>Confusion matrix (46 messages)</a:t>
-            </a:r>
-            <a:endParaRPr lang="en-US" sz="1400" dirty="0"/>
+              <a:t>Confusion matrix (92 messages · 12 scam categories)</a:t>
+            </a:r>
+            <a:endParaRPr lang="en-US" sz="1300" dirty="0"/>
           </a:p>
         </p:txBody>
       </p:sp>
@@ -9332,7 +9353,7 @@
                 <a:ea typeface="Calibri" pitchFamily="34" charset="-122"/>
                 <a:cs typeface="Calibri" pitchFamily="34" charset="-120"/>
               </a:rPr>
-              <a:t>24  </a:t>
+              <a:t>63  </a:t>
             </a:r>
             <a:pPr algn="ctr" indent="0" marL="0">
               <a:buNone/>
@@ -9593,7 +9614,7 @@
                 <a:ea typeface="Calibri" pitchFamily="34" charset="-122"/>
                 <a:cs typeface="Calibri" pitchFamily="34" charset="-120"/>
               </a:rPr>
-              <a:t>20  </a:t>
+              <a:t>27  </a:t>
             </a:r>
             <a:pPr algn="ctr" indent="0" marL="0">
               <a:buNone/>

</xml_diff>

<commit_message>
Fix OCR spacing bug + add tech-support/remote-access scam family
- OCR re-spacing (camelCase/digit boundaries + wordninja) so merged OCR text
  ('SharetheOTPsent...') no longer breaks word-boundary matching; shield assesses
  raw + re-spaced and keeps the higher risk → screenshot path now HIGH_RISK 76 (was 44)
- New tech-support + remote-access families (Microsoft/AnyDesk/'don't disconnect');
  tech-support scam now HIGH_RISK (was SAFE)
- Extend authority impersonation to income-tax/GST/telecom departments
- Relax OTP/credential matching for merged tokens; keep pin/password bounded (no FP)
- Benchmark now 96 messages / 13 categories: precision 100%, recall 97.1%, FPR 0%
- Deck + README metrics updated; requirements add wordninja
</commit_message>
<xml_diff>
--- a/docs/Prahari_Pitch_Deck.pptx
+++ b/docs/Prahari_Pitch_Deck.pptx
@@ -8676,7 +8676,7 @@
                 <a:ea typeface="Cambria" pitchFamily="34" charset="-122"/>
                 <a:cs typeface="Cambria" pitchFamily="34" charset="-120"/>
               </a:rPr>
-              <a:t>96.9%</a:t>
+              <a:t>97.1%</a:t>
             </a:r>
             <a:endParaRPr lang="en-US" sz="3000" dirty="0"/>
           </a:p>
@@ -8788,7 +8788,7 @@
                 <a:ea typeface="Cambria" pitchFamily="34" charset="-122"/>
                 <a:cs typeface="Cambria" pitchFamily="34" charset="-120"/>
               </a:rPr>
-              <a:t>98.4%</a:t>
+              <a:t>98.5%</a:t>
             </a:r>
             <a:endParaRPr lang="en-US" sz="3000" dirty="0"/>
           </a:p>
@@ -8900,7 +8900,7 @@
                 <a:ea typeface="Cambria" pitchFamily="34" charset="-122"/>
                 <a:cs typeface="Cambria" pitchFamily="34" charset="-120"/>
               </a:rPr>
-              <a:t>97.8%</a:t>
+              <a:t>97.9%</a:t>
             </a:r>
             <a:endParaRPr lang="en-US" sz="3000" dirty="0"/>
           </a:p>
@@ -9124,7 +9124,7 @@
                 <a:ea typeface="Cambria" pitchFamily="34" charset="-122"/>
                 <a:cs typeface="Cambria" pitchFamily="34" charset="-120"/>
               </a:rPr>
-              <a:t>Confusion matrix (92 messages · 12 scam categories)</a:t>
+              <a:t>Confusion matrix (96 messages · 13 scam categories)</a:t>
             </a:r>
             <a:endParaRPr lang="en-US" sz="1300" dirty="0"/>
           </a:p>
@@ -9353,7 +9353,7 @@
                 <a:ea typeface="Calibri" pitchFamily="34" charset="-122"/>
                 <a:cs typeface="Calibri" pitchFamily="34" charset="-120"/>
               </a:rPr>
-              <a:t>63  </a:t>
+              <a:t>67  </a:t>
             </a:r>
             <a:pPr algn="ctr" indent="0" marL="0">
               <a:buNone/>

</xml_diff>

<commit_message>
Add real-data external validation (UCI SMS Spam) — 0.10% FPR
- Validate scam classifier on UCI SMS Spam Collection (5,574 real SMS):
  false-positive rate on 4,827 genuine messages = 0.10% (5 flagged)
- backend/external_eval.py + GET /api/eval/external
- Model Performance page: real-data validation banner
- Dataset committed with attribution (sample_data/sms_spam/SOURCE.md)
- README data-sources + metrics; deck performance slide updated
- Note: recall on UCI is out-of-domain (UK SMS spam); in-domain recall stays 97.1%
</commit_message>
<xml_diff>
--- a/docs/Prahari_Pitch_Deck.pptx
+++ b/docs/Prahari_Pitch_Deck.pptx
@@ -9730,13 +9730,13 @@
           <a:p>
             <a:pPr marL="342900" indent="-342900">
               <a:spcAft>
-                <a:spcPts val="900"/>
+                <a:spcPts val="700"/>
               </a:spcAft>
               <a:buSzPct val="100000"/>
               <a:buChar char="•"/>
             </a:pPr>
             <a:r>
-              <a:rPr lang="en-US" sz="1250" dirty="0">
+              <a:rPr lang="en-US" sz="1200" dirty="0">
                 <a:solidFill>
                   <a:srgbClr val="E6EDF6"/>
                 </a:solidFill>
@@ -9746,18 +9746,18 @@
               </a:rPr>
               <a:t>Zero false positives on benign traffic — the evaluation's hardest bar for a citizen-facing tool.</a:t>
             </a:r>
-            <a:endParaRPr lang="en-US" sz="1250" dirty="0"/>
+            <a:endParaRPr lang="en-US" sz="1200" dirty="0"/>
           </a:p>
           <a:p>
             <a:pPr marL="342900" indent="-342900">
               <a:spcAft>
-                <a:spcPts val="900"/>
+                <a:spcPts val="700"/>
               </a:spcAft>
               <a:buSzPct val="100000"/>
               <a:buChar char="•"/>
             </a:pPr>
             <a:r>
-              <a:rPr lang="en-US" sz="1250" dirty="0">
+              <a:rPr lang="en-US" sz="1200" dirty="0">
                 <a:solidFill>
                   <a:srgbClr val="E6EDF6"/>
                 </a:solidFill>
@@ -9767,18 +9767,18 @@
               </a:rPr>
               <a:t>Covers 7 scam families, not just digital-arrest.</a:t>
             </a:r>
-            <a:endParaRPr lang="en-US" sz="1250" dirty="0"/>
+            <a:endParaRPr lang="en-US" sz="1200" dirty="0"/>
           </a:p>
           <a:p>
             <a:pPr marL="342900" indent="-342900">
               <a:spcAft>
-                <a:spcPts val="900"/>
+                <a:spcPts val="700"/>
               </a:spcAft>
               <a:buSzPct val="100000"/>
               <a:buChar char="•"/>
             </a:pPr>
             <a:r>
-              <a:rPr lang="en-US" sz="1250" dirty="0">
+              <a:rPr lang="en-US" sz="1200" dirty="0">
                 <a:solidFill>
                   <a:srgbClr val="E6EDF6"/>
                 </a:solidFill>
@@ -9788,18 +9788,18 @@
               </a:rPr>
               <a:t>Only misses are deliberately vague messages — shown openly, no cherry-picking.</a:t>
             </a:r>
-            <a:endParaRPr lang="en-US" sz="1250" dirty="0"/>
+            <a:endParaRPr lang="en-US" sz="1200" dirty="0"/>
           </a:p>
           <a:p>
             <a:pPr marL="342900" indent="-342900">
               <a:spcAft>
-                <a:spcPts val="900"/>
+                <a:spcPts val="700"/>
               </a:spcAft>
               <a:buSzPct val="100000"/>
               <a:buChar char="•"/>
             </a:pPr>
             <a:r>
-              <a:rPr lang="en-US" sz="1250" dirty="0">
+              <a:rPr lang="en-US" sz="1200" dirty="0">
                 <a:solidFill>
                   <a:srgbClr val="E6EDF6"/>
                 </a:solidFill>
@@ -9807,9 +9807,30 @@
                 <a:ea typeface="Calibri" pitchFamily="34" charset="-122"/>
                 <a:cs typeface="Calibri" pitchFamily="34" charset="-120"/>
               </a:rPr>
+              <a:t>Validated on real data: 0.10% false-positive rate on 4,827 genuine SMS (UCI corpus).</a:t>
+            </a:r>
+            <a:endParaRPr lang="en-US" sz="1200" dirty="0"/>
+          </a:p>
+          <a:p>
+            <a:pPr marL="342900" indent="-342900">
+              <a:spcAft>
+                <a:spcPts val="700"/>
+              </a:spcAft>
+              <a:buSzPct val="100000"/>
+              <a:buChar char="•"/>
+            </a:pPr>
+            <a:r>
+              <a:rPr lang="en-US" sz="1200" dirty="0">
+                <a:solidFill>
+                  <a:srgbClr val="E6EDF6"/>
+                </a:solidFill>
+                <a:latin typeface="Calibri" pitchFamily="34" charset="0"/>
+                <a:ea typeface="Calibri" pitchFamily="34" charset="-122"/>
+                <a:cs typeface="Calibri" pitchFamily="34" charset="-120"/>
+              </a:rPr>
               <a:t>Glass-box: every score traces to a matched phrase (court-admissible).</a:t>
             </a:r>
-            <a:endParaRPr lang="en-US" sz="1250" dirty="0"/>
+            <a:endParaRPr lang="en-US" sz="1200" dirty="0"/>
           </a:p>
         </p:txBody>
       </p:sp>

</xml_diff>

<commit_message>
Add recent sourced India figures (2024-FY26) to overview, README, deck
- Overview KPIs refreshed: ₹22,845 Cr cybercrime 2024 (22.68 lakh, +42%),
  ₹1,935 Cr digital arrest 2024 (21x since 2022), 1.42 lakh fake ₹500 FY26 (+20.5%)
- 'Recent Intelligence (2024-FY26)' feed with real sourced headlines (I4C, RBI,
  Finance Ministry) incl. I4C 'Pratibimb' hotspot module (16,840 arrests) and
  '97.6% of fake notes caught by banks, not RBI' (validates point-of-contact thesis)
- README 'Why this matters' + deck problem slide updated with cited current figures
</commit_message>
<xml_diff>
--- a/docs/Prahari_Pitch_Deck.pptx
+++ b/docs/Prahari_Pitch_Deck.pptx
@@ -3347,7 +3347,7 @@
                 <a:ea typeface="Cambria" pitchFamily="34" charset="-122"/>
                 <a:cs typeface="Cambria" pitchFamily="34" charset="-120"/>
               </a:rPr>
-              <a:t>1.14M</a:t>
+              <a:t>₹22,845 Cr</a:t>
             </a:r>
             <a:endParaRPr lang="en-US" sz="4000" dirty="0"/>
           </a:p>
@@ -3386,7 +3386,7 @@
                 <a:ea typeface="Calibri" pitchFamily="34" charset="-122"/>
                 <a:cs typeface="Calibri" pitchFamily="34" charset="-120"/>
               </a:rPr>
-              <a:t>cybercrime complaints in India, 2023</a:t>
+              <a:t>lost to cybercrime in 2024 — 22.68 lakh complaints</a:t>
             </a:r>
             <a:endParaRPr lang="en-US" sz="1400" dirty="0"/>
           </a:p>
@@ -3425,7 +3425,7 @@
                 <a:ea typeface="Calibri" pitchFamily="34" charset="-122"/>
                 <a:cs typeface="Calibri" pitchFamily="34" charset="-120"/>
               </a:rPr>
-              <a:t>▲ 60% vs 2022</a:t>
+              <a:t>▲ 42% YoY (I4C / MHA, 2024)</a:t>
             </a:r>
             <a:endParaRPr lang="en-US" sz="1100" dirty="0"/>
           </a:p>
@@ -3498,7 +3498,7 @@
                 <a:ea typeface="Cambria" pitchFamily="34" charset="-122"/>
                 <a:cs typeface="Cambria" pitchFamily="34" charset="-120"/>
               </a:rPr>
-              <a:t>₹1,776 Cr</a:t>
+              <a:t>₹1,935 Cr</a:t>
             </a:r>
             <a:endParaRPr lang="en-US" sz="4000" dirty="0"/>
           </a:p>
@@ -3537,7 +3537,7 @@
                 <a:ea typeface="Calibri" pitchFamily="34" charset="-122"/>
                 <a:cs typeface="Calibri" pitchFamily="34" charset="-120"/>
               </a:rPr>
-              <a:t>lost to 'digital arrest' scams</a:t>
+              <a:t>lost to 'digital arrest' scams in 2024</a:t>
             </a:r>
             <a:endParaRPr lang="en-US" sz="1400" dirty="0"/>
           </a:p>
@@ -3576,7 +3576,7 @@
                 <a:ea typeface="Calibri" pitchFamily="34" charset="-122"/>
                 <a:cs typeface="Calibri" pitchFamily="34" charset="-120"/>
               </a:rPr>
-              <a:t>first 9 months of 2024 (MHA / I4C)</a:t>
+              <a:t>21× the 2022 figure (MHA / I4C)</a:t>
             </a:r>
             <a:endParaRPr lang="en-US" sz="1100" dirty="0"/>
           </a:p>
@@ -3649,7 +3649,7 @@
                 <a:ea typeface="Cambria" pitchFamily="34" charset="-122"/>
                 <a:cs typeface="Cambria" pitchFamily="34" charset="-120"/>
               </a:rPr>
-              <a:t>Record</a:t>
+              <a:t>1.42 lakh</a:t>
             </a:r>
             <a:endParaRPr lang="en-US" sz="4000" dirty="0"/>
           </a:p>
@@ -3688,7 +3688,7 @@
                 <a:ea typeface="Calibri" pitchFamily="34" charset="-122"/>
                 <a:cs typeface="Calibri" pitchFamily="34" charset="-120"/>
               </a:rPr>
-              <a:t>FICN ₹500 fake-note seizures</a:t>
+              <a:t>fake ₹500 notes detected in FY26 (+20.5%)</a:t>
             </a:r>
             <a:endParaRPr lang="en-US" sz="1400" dirty="0"/>
           </a:p>
@@ -3727,7 +3727,7 @@
                 <a:ea typeface="Calibri" pitchFamily="34" charset="-122"/>
                 <a:cs typeface="Calibri" pitchFamily="34" charset="-120"/>
               </a:rPr>
-              <a:t>RBI Annual Report 2025</a:t>
+              <a:t>97.6% caught by banks, not RBI (RBI FY26)</a:t>
             </a:r>
             <a:endParaRPr lang="en-US" sz="1100" dirty="0"/>
           </a:p>
@@ -10254,7 +10254,7 @@
                 <a:ea typeface="Calibri" pitchFamily="34" charset="-122"/>
                 <a:cs typeface="Calibri" pitchFamily="34" charset="-120"/>
               </a:rPr>
-              <a:t>Targets a ₹1,776 Cr/yr loss vector; protects banks, telcos, citizens &amp; courts.</a:t>
+              <a:t>Targets a ₹22,845 Cr/yr cybercrime loss vector; protects banks, telcos, citizens &amp; courts.</a:t>
             </a:r>
             <a:endParaRPr lang="en-US" sz="1300" dirty="0"/>
           </a:p>

</xml_diff>

<commit_message>
Address review: API input validation, ROI metric, production architecture doc, honest 12-lang claim
- API: max_length=5000 on text inputs; image MIME allow-list + 10MB cap + denom check
  (415/413/422 verified) — security awareness on public endpoints
- Deck + README: projected ROI — 10% pre-transfer interception at 1930 scale saves
  ₹2,284 Cr/yr (derived from cited ₹22,845 Cr / 22.68 lakh complaints)
- docs/ARCHITECTURE.md: production scale-out (API gateway+auth+rate-limit, Kafka,
  append-only Postgres/WORM audit ledger, Neo4j/ArangoDB fraud graph, Redis, CNN/ViT+GNN)
- Correct the '12 languages' claim to '12-language interface, verdicts localised in 5'
</commit_message>
<xml_diff>
--- a/docs/Prahari_Pitch_Deck.pptx
+++ b/docs/Prahari_Pitch_Deck.pptx
@@ -10044,12 +10044,12 @@
         </p:nvSpPr>
         <p:spPr>
           <a:xfrm>
-            <a:off x="548640" y="1463040"/>
-            <a:ext cx="11064240" cy="731520"/>
+            <a:off x="548640" y="1417320"/>
+            <a:ext cx="11064240" cy="676656"/>
           </a:xfrm>
           <a:prstGeom prst="roundRect">
             <a:avLst>
-              <a:gd name="adj" fmla="val 10000"/>
+              <a:gd name="adj" fmla="val 10811"/>
             </a:avLst>
           </a:prstGeom>
           <a:solidFill>
@@ -10078,8 +10078,8 @@
         </p:nvSpPr>
         <p:spPr>
           <a:xfrm>
-            <a:off x="777240" y="1463040"/>
-            <a:ext cx="3291840" cy="731520"/>
+            <a:off x="777240" y="1417320"/>
+            <a:ext cx="3291840" cy="676656"/>
           </a:xfrm>
           <a:prstGeom prst="rect">
             <a:avLst/>
@@ -10095,7 +10095,7 @@
               <a:buNone/>
             </a:pPr>
             <a:r>
-              <a:rPr lang="en-US" sz="1450" b="1" dirty="0">
+              <a:rPr lang="en-US" sz="1400" b="1" dirty="0">
                 <a:solidFill>
                   <a:srgbClr val="3EA6FF"/>
                 </a:solidFill>
@@ -10105,7 +10105,7 @@
               </a:rPr>
               <a:t>Innovation (25%)</a:t>
             </a:r>
-            <a:endParaRPr lang="en-US" sz="1450" dirty="0"/>
+            <a:endParaRPr lang="en-US" sz="1400" dirty="0"/>
           </a:p>
         </p:txBody>
       </p:sp>
@@ -10117,8 +10117,8 @@
         </p:nvSpPr>
         <p:spPr>
           <a:xfrm>
-            <a:off x="4114800" y="1463040"/>
-            <a:ext cx="7315200" cy="731520"/>
+            <a:off x="4114800" y="1417320"/>
+            <a:ext cx="7315200" cy="676656"/>
           </a:xfrm>
           <a:prstGeom prst="rect">
             <a:avLst/>
@@ -10134,7 +10134,7 @@
               <a:buNone/>
             </a:pPr>
             <a:r>
-              <a:rPr lang="en-US" sz="1300" dirty="0">
+              <a:rPr lang="en-US" sz="1250" dirty="0">
                 <a:solidFill>
                   <a:srgbClr val="E6EDF6"/>
                 </a:solidFill>
@@ -10144,7 +10144,7 @@
               </a:rPr>
               <a:t>Kill-chain scam modelling + lead-time KPI + cross-domain entity fusion.</a:t>
             </a:r>
-            <a:endParaRPr lang="en-US" sz="1300" dirty="0"/>
+            <a:endParaRPr lang="en-US" sz="1250" dirty="0"/>
           </a:p>
         </p:txBody>
       </p:sp>
@@ -10156,12 +10156,12 @@
         </p:nvSpPr>
         <p:spPr>
           <a:xfrm>
-            <a:off x="548640" y="2304288"/>
-            <a:ext cx="11064240" cy="731520"/>
+            <a:off x="548640" y="2203704"/>
+            <a:ext cx="11064240" cy="676656"/>
           </a:xfrm>
           <a:prstGeom prst="roundRect">
             <a:avLst>
-              <a:gd name="adj" fmla="val 10000"/>
+              <a:gd name="adj" fmla="val 10811"/>
             </a:avLst>
           </a:prstGeom>
           <a:solidFill>
@@ -10190,8 +10190,8 @@
         </p:nvSpPr>
         <p:spPr>
           <a:xfrm>
-            <a:off x="777240" y="2304288"/>
-            <a:ext cx="3291840" cy="731520"/>
+            <a:off x="777240" y="2203704"/>
+            <a:ext cx="3291840" cy="676656"/>
           </a:xfrm>
           <a:prstGeom prst="rect">
             <a:avLst/>
@@ -10207,7 +10207,7 @@
               <a:buNone/>
             </a:pPr>
             <a:r>
-              <a:rPr lang="en-US" sz="1450" b="1" dirty="0">
+              <a:rPr lang="en-US" sz="1400" b="1" dirty="0">
                 <a:solidFill>
                   <a:srgbClr val="3EA6FF"/>
                 </a:solidFill>
@@ -10217,7 +10217,7 @@
               </a:rPr>
               <a:t>Business Impact (25%)</a:t>
             </a:r>
-            <a:endParaRPr lang="en-US" sz="1450" dirty="0"/>
+            <a:endParaRPr lang="en-US" sz="1400" dirty="0"/>
           </a:p>
         </p:txBody>
       </p:sp>
@@ -10229,8 +10229,8 @@
         </p:nvSpPr>
         <p:spPr>
           <a:xfrm>
-            <a:off x="4114800" y="2304288"/>
-            <a:ext cx="7315200" cy="731520"/>
+            <a:off x="4114800" y="2203704"/>
+            <a:ext cx="7315200" cy="676656"/>
           </a:xfrm>
           <a:prstGeom prst="rect">
             <a:avLst/>
@@ -10246,7 +10246,7 @@
               <a:buNone/>
             </a:pPr>
             <a:r>
-              <a:rPr lang="en-US" sz="1300" dirty="0">
+              <a:rPr lang="en-US" sz="1250" dirty="0">
                 <a:solidFill>
                   <a:srgbClr val="E6EDF6"/>
                 </a:solidFill>
@@ -10256,7 +10256,7 @@
               </a:rPr>
               <a:t>Targets a ₹22,845 Cr/yr cybercrime loss vector; protects banks, telcos, citizens &amp; courts.</a:t>
             </a:r>
-            <a:endParaRPr lang="en-US" sz="1300" dirty="0"/>
+            <a:endParaRPr lang="en-US" sz="1250" dirty="0"/>
           </a:p>
         </p:txBody>
       </p:sp>
@@ -10268,12 +10268,12 @@
         </p:nvSpPr>
         <p:spPr>
           <a:xfrm>
-            <a:off x="548640" y="3145536"/>
-            <a:ext cx="11064240" cy="731520"/>
+            <a:off x="548640" y="2990088"/>
+            <a:ext cx="11064240" cy="676656"/>
           </a:xfrm>
           <a:prstGeom prst="roundRect">
             <a:avLst>
-              <a:gd name="adj" fmla="val 10000"/>
+              <a:gd name="adj" fmla="val 10811"/>
             </a:avLst>
           </a:prstGeom>
           <a:solidFill>
@@ -10302,8 +10302,8 @@
         </p:nvSpPr>
         <p:spPr>
           <a:xfrm>
-            <a:off x="777240" y="3145536"/>
-            <a:ext cx="3291840" cy="731520"/>
+            <a:off x="777240" y="2990088"/>
+            <a:ext cx="3291840" cy="676656"/>
           </a:xfrm>
           <a:prstGeom prst="rect">
             <a:avLst/>
@@ -10319,7 +10319,7 @@
               <a:buNone/>
             </a:pPr>
             <a:r>
-              <a:rPr lang="en-US" sz="1450" b="1" dirty="0">
+              <a:rPr lang="en-US" sz="1400" b="1" dirty="0">
                 <a:solidFill>
                   <a:srgbClr val="3EA6FF"/>
                 </a:solidFill>
@@ -10329,7 +10329,7 @@
               </a:rPr>
               <a:t>Technical Excellence (20%)</a:t>
             </a:r>
-            <a:endParaRPr lang="en-US" sz="1450" dirty="0"/>
+            <a:endParaRPr lang="en-US" sz="1400" dirty="0"/>
           </a:p>
         </p:txBody>
       </p:sp>
@@ -10341,8 +10341,8 @@
         </p:nvSpPr>
         <p:spPr>
           <a:xfrm>
-            <a:off x="4114800" y="3145536"/>
-            <a:ext cx="7315200" cy="731520"/>
+            <a:off x="4114800" y="2990088"/>
+            <a:ext cx="7315200" cy="676656"/>
           </a:xfrm>
           <a:prstGeom prst="rect">
             <a:avLst/>
@@ -10358,7 +10358,7 @@
               <a:buNone/>
             </a:pPr>
             <a:r>
-              <a:rPr lang="en-US" sz="1300" dirty="0">
+              <a:rPr lang="en-US" sz="1250" dirty="0">
                 <a:solidFill>
                   <a:srgbClr val="E6EDF6"/>
                 </a:solidFill>
@@ -10368,7 +10368,7 @@
               </a:rPr>
               <a:t>Graph AI, image forensics, explainable NLP, geospatial — in one API.</a:t>
             </a:r>
-            <a:endParaRPr lang="en-US" sz="1300" dirty="0"/>
+            <a:endParaRPr lang="en-US" sz="1250" dirty="0"/>
           </a:p>
         </p:txBody>
       </p:sp>
@@ -10380,12 +10380,12 @@
         </p:nvSpPr>
         <p:spPr>
           <a:xfrm>
-            <a:off x="548640" y="3986784"/>
-            <a:ext cx="11064240" cy="731520"/>
+            <a:off x="548640" y="3776472"/>
+            <a:ext cx="11064240" cy="676656"/>
           </a:xfrm>
           <a:prstGeom prst="roundRect">
             <a:avLst>
-              <a:gd name="adj" fmla="val 10000"/>
+              <a:gd name="adj" fmla="val 10811"/>
             </a:avLst>
           </a:prstGeom>
           <a:solidFill>
@@ -10414,8 +10414,8 @@
         </p:nvSpPr>
         <p:spPr>
           <a:xfrm>
-            <a:off x="777240" y="3986784"/>
-            <a:ext cx="3291840" cy="731520"/>
+            <a:off x="777240" y="3776472"/>
+            <a:ext cx="3291840" cy="676656"/>
           </a:xfrm>
           <a:prstGeom prst="rect">
             <a:avLst/>
@@ -10431,7 +10431,7 @@
               <a:buNone/>
             </a:pPr>
             <a:r>
-              <a:rPr lang="en-US" sz="1450" b="1" dirty="0">
+              <a:rPr lang="en-US" sz="1400" b="1" dirty="0">
                 <a:solidFill>
                   <a:srgbClr val="3EA6FF"/>
                 </a:solidFill>
@@ -10441,7 +10441,7 @@
               </a:rPr>
               <a:t>Scalability (15%)</a:t>
             </a:r>
-            <a:endParaRPr lang="en-US" sz="1450" dirty="0"/>
+            <a:endParaRPr lang="en-US" sz="1400" dirty="0"/>
           </a:p>
         </p:txBody>
       </p:sp>
@@ -10453,8 +10453,8 @@
         </p:nvSpPr>
         <p:spPr>
           <a:xfrm>
-            <a:off x="4114800" y="3986784"/>
-            <a:ext cx="7315200" cy="731520"/>
+            <a:off x="4114800" y="3776472"/>
+            <a:ext cx="7315200" cy="676656"/>
           </a:xfrm>
           <a:prstGeom prst="rect">
             <a:avLst/>
@@ -10470,7 +10470,7 @@
               <a:buNone/>
             </a:pPr>
             <a:r>
-              <a:rPr lang="en-US" sz="1300" dirty="0">
+              <a:rPr lang="en-US" sz="1250" dirty="0">
                 <a:solidFill>
                   <a:srgbClr val="E6EDF6"/>
                 </a:solidFill>
@@ -10480,7 +10480,7 @@
               </a:rPr>
               <a:t>Stateless services; add scam templates without retraining; per-module scale-out.</a:t>
             </a:r>
-            <a:endParaRPr lang="en-US" sz="1300" dirty="0"/>
+            <a:endParaRPr lang="en-US" sz="1250" dirty="0"/>
           </a:p>
         </p:txBody>
       </p:sp>
@@ -10492,12 +10492,12 @@
         </p:nvSpPr>
         <p:spPr>
           <a:xfrm>
-            <a:off x="548640" y="4828032"/>
-            <a:ext cx="11064240" cy="731520"/>
+            <a:off x="548640" y="4562856"/>
+            <a:ext cx="11064240" cy="676656"/>
           </a:xfrm>
           <a:prstGeom prst="roundRect">
             <a:avLst>
-              <a:gd name="adj" fmla="val 10000"/>
+              <a:gd name="adj" fmla="val 10811"/>
             </a:avLst>
           </a:prstGeom>
           <a:solidFill>
@@ -10526,8 +10526,8 @@
         </p:nvSpPr>
         <p:spPr>
           <a:xfrm>
-            <a:off x="777240" y="4828032"/>
-            <a:ext cx="3291840" cy="731520"/>
+            <a:off x="777240" y="4562856"/>
+            <a:ext cx="3291840" cy="676656"/>
           </a:xfrm>
           <a:prstGeom prst="rect">
             <a:avLst/>
@@ -10543,7 +10543,7 @@
               <a:buNone/>
             </a:pPr>
             <a:r>
-              <a:rPr lang="en-US" sz="1450" b="1" dirty="0">
+              <a:rPr lang="en-US" sz="1400" b="1" dirty="0">
                 <a:solidFill>
                   <a:srgbClr val="3EA6FF"/>
                 </a:solidFill>
@@ -10553,7 +10553,7 @@
               </a:rPr>
               <a:t>User Experience (15%)</a:t>
             </a:r>
-            <a:endParaRPr lang="en-US" sz="1450" dirty="0"/>
+            <a:endParaRPr lang="en-US" sz="1400" dirty="0"/>
           </a:p>
         </p:txBody>
       </p:sp>
@@ -10565,8 +10565,8 @@
         </p:nvSpPr>
         <p:spPr>
           <a:xfrm>
-            <a:off x="4114800" y="4828032"/>
-            <a:ext cx="7315200" cy="731520"/>
+            <a:off x="4114800" y="4562856"/>
+            <a:ext cx="7315200" cy="676656"/>
           </a:xfrm>
           <a:prstGeom prst="rect">
             <a:avLst/>
@@ -10582,7 +10582,7 @@
               <a:buNone/>
             </a:pPr>
             <a:r>
-              <a:rPr lang="en-US" sz="1300" dirty="0">
+              <a:rPr lang="en-US" sz="1250" dirty="0">
                 <a:solidFill>
                   <a:srgbClr val="E6EDF6"/>
                 </a:solidFill>
@@ -10590,15 +10590,123 @@
                 <a:ea typeface="Calibri" pitchFamily="34" charset="-122"/>
                 <a:cs typeface="Calibri" pitchFamily="34" charset="-120"/>
               </a:rPr>
-              <a:t>Command-centre dashboard + 12-language citizen chatbot on WhatsApp/IVR/app.</a:t>
-            </a:r>
-            <a:endParaRPr lang="en-US" sz="1300" dirty="0"/>
-          </a:p>
-        </p:txBody>
-      </p:sp>
-      <p:sp>
-        <p:nvSpPr>
-          <p:cNvPr id="18" name="Text 16"/>
+              <a:t>Command-centre dashboard + citizen chatbot (12-language interface, verdicts localised in 5 today).</a:t>
+            </a:r>
+            <a:endParaRPr lang="en-US" sz="1250" dirty="0"/>
+          </a:p>
+        </p:txBody>
+      </p:sp>
+      <p:sp>
+        <p:nvSpPr>
+          <p:cNvPr id="18" name="Shape 16"/>
+          <p:cNvSpPr/>
+          <p:nvPr/>
+        </p:nvSpPr>
+        <p:spPr>
+          <a:xfrm>
+            <a:off x="548640" y="5532120"/>
+            <a:ext cx="11064240" cy="749808"/>
+          </a:xfrm>
+          <a:prstGeom prst="roundRect">
+            <a:avLst>
+              <a:gd name="adj" fmla="val 10976"/>
+            </a:avLst>
+          </a:prstGeom>
+          <a:solidFill>
+            <a:srgbClr val="0F2A1C"/>
+          </a:solidFill>
+          <a:ln w="12700">
+            <a:solidFill>
+              <a:srgbClr val="1F3A2A"/>
+            </a:solidFill>
+            <a:prstDash val="solid"/>
+          </a:ln>
+        </p:spPr>
+      </p:sp>
+      <p:sp>
+        <p:nvSpPr>
+          <p:cNvPr id="19" name="Text 17"/>
+          <p:cNvSpPr/>
+          <p:nvPr/>
+        </p:nvSpPr>
+        <p:spPr>
+          <a:xfrm>
+            <a:off x="868680" y="5532120"/>
+            <a:ext cx="10424160" cy="749808"/>
+          </a:xfrm>
+          <a:prstGeom prst="rect">
+            <a:avLst/>
+          </a:prstGeom>
+          <a:noFill/>
+          <a:ln/>
+        </p:spPr>
+        <p:txBody>
+          <a:bodyPr wrap="square" rtlCol="0" anchor="ctr"/>
+          <a:lstStyle/>
+          <a:p>
+            <a:pPr indent="0" marL="0">
+              <a:buNone/>
+            </a:pPr>
+            <a:r>
+              <a:rPr lang="en-US" sz="1400" b="1" dirty="0">
+                <a:solidFill>
+                  <a:srgbClr val="2ECC71"/>
+                </a:solidFill>
+                <a:latin typeface="Calibri" pitchFamily="34" charset="0"/>
+                <a:ea typeface="Calibri" pitchFamily="34" charset="-122"/>
+                <a:cs typeface="Calibri" pitchFamily="34" charset="-120"/>
+              </a:rPr>
+              <a:t>Projected ROI:  </a:t>
+            </a:r>
+            <a:pPr indent="0" marL="0">
+              <a:buNone/>
+            </a:pPr>
+            <a:r>
+              <a:rPr lang="en-US" sz="1400" dirty="0">
+                <a:solidFill>
+                  <a:srgbClr val="E6EDF6"/>
+                </a:solidFill>
+                <a:latin typeface="Calibri" pitchFamily="34" charset="0"/>
+                <a:ea typeface="Calibri" pitchFamily="34" charset="-122"/>
+                <a:cs typeface="Calibri" pitchFamily="34" charset="-120"/>
+              </a:rPr>
+              <a:t>at 1930-helpline scale (22.68 lakh complaints/yr), a 10% pre-transfer interception rate saves </a:t>
+            </a:r>
+            <a:pPr indent="0" marL="0">
+              <a:buNone/>
+            </a:pPr>
+            <a:r>
+              <a:rPr lang="en-US" sz="1400" b="1" dirty="0">
+                <a:solidFill>
+                  <a:srgbClr val="2ECC71"/>
+                </a:solidFill>
+                <a:latin typeface="Calibri" pitchFamily="34" charset="0"/>
+                <a:ea typeface="Calibri" pitchFamily="34" charset="-122"/>
+                <a:cs typeface="Calibri" pitchFamily="34" charset="-120"/>
+              </a:rPr>
+              <a:t>₹2,284 Cr every year</a:t>
+            </a:r>
+            <a:pPr indent="0" marL="0">
+              <a:buNone/>
+            </a:pPr>
+            <a:r>
+              <a:rPr lang="en-US" sz="1400" dirty="0">
+                <a:solidFill>
+                  <a:srgbClr val="E6EDF6"/>
+                </a:solidFill>
+                <a:latin typeface="Calibri" pitchFamily="34" charset="0"/>
+                <a:ea typeface="Calibri" pitchFamily="34" charset="-122"/>
+                <a:cs typeface="Calibri" pitchFamily="34" charset="-120"/>
+              </a:rPr>
+              <a:t>.</a:t>
+            </a:r>
+            <a:endParaRPr lang="en-US" sz="1400" dirty="0"/>
+          </a:p>
+        </p:txBody>
+      </p:sp>
+      <p:sp>
+        <p:nvSpPr>
+          <p:cNvPr id="20" name="Text 18"/>
           <p:cNvSpPr/>
           <p:nvPr/>
         </p:nvSpPr>
@@ -10637,7 +10745,7 @@
       </p:sp>
       <p:sp>
         <p:nvSpPr>
-          <p:cNvPr id="19" name="Text 17"/>
+          <p:cNvPr id="21" name="Text 19"/>
           <p:cNvSpPr/>
           <p:nvPr/>
         </p:nvSpPr>

</xml_diff>

<commit_message>
Deck: fix denomination bar order (PowerPoint was re-sorting labels)
The per-denomination chart showed ₹10,₹100,₹20,₹200,₹2000,₹50,₹500 —
PowerPoint re-sorts numeric-looking category labels alphabetically at
render time even though the data XML was correct (₹10→₹2000).

Fix: draw the denomination bars NATIVELY (positioned shapes) instead of a
chart, so each bar's x-coordinate fixes its order — ₹10 leftmost →
₹2000 rightmost, guaranteed, with value labels on top. Also reversed the
NCRB states bar chart so the highest state renders at the top (horizontal
bars draw the first category at the bottom in PowerPoint). App's own
per-denomination table was already correct — this was deck-only.
</commit_message>
<xml_diff>
--- a/docs/Prahari_Pitch_Deck.pptx
+++ b/docs/Prahari_Pitch_Deck.pptx
@@ -217,22 +217,22 @@
                 <c:ptCount val="6"/>
                 <c:lvl>
                   <c:pt idx="0">
-                    <c:v>Telangana</c:v>
+                    <c:v>Tamil Nadu</c:v>
                   </c:pt>
                   <c:pt idx="1">
+                    <c:v>Andhra Pr.</c:v>
+                  </c:pt>
+                  <c:pt idx="2">
+                    <c:v>Maharashtra</c:v>
+                  </c:pt>
+                  <c:pt idx="3">
+                    <c:v>Uttar Pradesh</c:v>
+                  </c:pt>
+                  <c:pt idx="4">
                     <c:v>Karnataka</c:v>
                   </c:pt>
-                  <c:pt idx="2">
-                    <c:v>Uttar Pradesh</c:v>
-                  </c:pt>
-                  <c:pt idx="3">
-                    <c:v>Maharashtra</c:v>
-                  </c:pt>
-                  <c:pt idx="4">
-                    <c:v>Andhra Pr.</c:v>
-                  </c:pt>
                   <c:pt idx="5">
-                    <c:v>Tamil Nadu</c:v>
+                    <c:v>Telangana</c:v>
                   </c:pt>
                 </c:lvl>
               </c:multiLvlStrCache>
@@ -245,22 +245,22 @@
                 <c:formatCode>General</c:formatCode>
                 <c:ptCount val="6"/>
                 <c:pt idx="0">
-                  <c:v>15297</c:v>
+                  <c:v>2082</c:v>
                 </c:pt>
                 <c:pt idx="1">
+                  <c:v>2341</c:v>
+                </c:pt>
+                <c:pt idx="2">
+                  <c:v>8249</c:v>
+                </c:pt>
+                <c:pt idx="3">
+                  <c:v>10117</c:v>
+                </c:pt>
+                <c:pt idx="4">
                   <c:v>12556</c:v>
                 </c:pt>
-                <c:pt idx="2">
-                  <c:v>10117</c:v>
-                </c:pt>
-                <c:pt idx="3">
-                  <c:v>8249</c:v>
-                </c:pt>
-                <c:pt idx="4">
-                  <c:v>2341</c:v>
-                </c:pt>
                 <c:pt idx="5">
-                  <c:v>2082</c:v>
+                  <c:v>15297</c:v>
                 </c:pt>
               </c:numCache>
             </c:numRef>
@@ -729,289 +729,6 @@
         </a:p>
       </c:txPr>
     </c:legend>
-    <c:plotVisOnly val="1"/>
-    <c:dispBlanksAs val="span"/>
-  </c:chart>
-  <c:spPr>
-    <a:noFill/>
-    <a:ln>
-      <a:noFill/>
-    </a:ln>
-    <a:effectLst/>
-  </c:spPr>
-  <c:externalData r:id="rId1">
-    <c:autoUpdate val="0"/>
-  </c:externalData>
-</c:chartSpace>
-</file>
-
-<file path=ppt/charts/chart3.xml><?xml version="1.0" encoding="utf-8"?>
-<c:chartSpace xmlns:c="http://schemas.openxmlformats.org/drawingml/2006/chart" xmlns:a="http://schemas.openxmlformats.org/drawingml/2006/main" xmlns:r="http://schemas.openxmlformats.org/officeDocument/2006/relationships">
-  <c:date1904 val="0"/>
-  <c:roundedCorners val="1"/>
-  <c:chart>
-    <c:title>
-      <c:tx>
-        <c:rich>
-          <a:bodyPr/>
-          <a:lstStyle/>
-          <a:p>
-            <a:pPr>
-              <a:defRPr sz="1200" b="0" i="0" u="none" strike="noStrike">
-                <a:solidFill>
-                  <a:srgbClr val="E9EEF7"/>
-                </a:solidFill>
-                <a:latin typeface="Segoe UI"/>
-              </a:defRPr>
-            </a:pPr>
-            <a:r>
-              <a:rPr sz="1200" b="0" i="0" u="none" strike="noStrike">
-                <a:solidFill>
-                  <a:srgbClr val="E9EEF7"/>
-                </a:solidFill>
-                <a:latin typeface="Segoe UI"/>
-              </a:rPr>
-              <a:t>Mean authenticity score per denomination (genuine RBI notes)</a:t>
-            </a:r>
-          </a:p>
-        </c:rich>
-      </c:tx>
-      <c:layout/>
-      <c:overlay val="0"/>
-    </c:title>
-    <c:autoTitleDeleted val="0"/>
-    <c:plotArea>
-      <c:layout/>
-      <c:barChart>
-        <c:barDir val="col"/>
-        <c:grouping val="clustered"/>
-        <c:varyColors val="0"/>
-        <c:ser>
-          <c:idx val="0"/>
-          <c:order val="0"/>
-          <c:tx>
-            <c:strRef>
-              <c:f>Sheet1!$B$1</c:f>
-              <c:strCache>
-                <c:ptCount val="1"/>
-                <c:pt idx="0">
-                  <c:v>Mean authenticity</c:v>
-                </c:pt>
-              </c:strCache>
-            </c:strRef>
-          </c:tx>
-          <c:spPr>
-            <a:solidFill>
-              <a:srgbClr val="2ECC71"/>
-            </a:solidFill>
-            <a:effectLst/>
-          </c:spPr>
-          <c:invertIfNegative val="0"/>
-          <c:dLbls>
-            <c:numFmt formatCode="#,##0" sourceLinked="0"/>
-            <c:txPr>
-              <a:bodyPr/>
-              <a:lstStyle/>
-              <a:p>
-                <a:pPr>
-                  <a:defRPr b="0" i="0" strike="noStrike" sz="1000" u="none">
-                    <a:solidFill>
-                      <a:srgbClr val="E9EEF7"/>
-                    </a:solidFill>
-                    <a:latin typeface="Segoe UI"/>
-                  </a:defRPr>
-                </a:pPr>
-              </a:p>
-            </c:txPr>
-            <c:showLegendKey val="0"/>
-            <c:showVal val="1"/>
-            <c:showCatName val="0"/>
-            <c:showSerName val="0"/>
-            <c:showPercent val="0"/>
-            <c:showBubbleSize val="0"/>
-            <c:showLeaderLines val="0"/>
-          </c:dLbls>
-          <c:cat>
-            <c:multiLvlStrRef>
-              <c:f>Sheet1!$A$2:$A$8</c:f>
-              <c:multiLvlStrCache>
-                <c:ptCount val="7"/>
-                <c:lvl>
-                  <c:pt idx="0">
-                    <c:v>₹10</c:v>
-                  </c:pt>
-                  <c:pt idx="1">
-                    <c:v>₹20</c:v>
-                  </c:pt>
-                  <c:pt idx="2">
-                    <c:v>₹50</c:v>
-                  </c:pt>
-                  <c:pt idx="3">
-                    <c:v>₹100</c:v>
-                  </c:pt>
-                  <c:pt idx="4">
-                    <c:v>₹200</c:v>
-                  </c:pt>
-                  <c:pt idx="5">
-                    <c:v>₹500</c:v>
-                  </c:pt>
-                  <c:pt idx="6">
-                    <c:v>₹2000</c:v>
-                  </c:pt>
-                </c:lvl>
-              </c:multiLvlStrCache>
-            </c:multiLvlStrRef>
-          </c:cat>
-          <c:val>
-            <c:numRef>
-              <c:f>Sheet1!$B$2:$B$8</c:f>
-              <c:numCache>
-                <c:formatCode>General</c:formatCode>
-                <c:ptCount val="7"/>
-                <c:pt idx="0">
-                  <c:v>87</c:v>
-                </c:pt>
-                <c:pt idx="1">
-                  <c:v>94</c:v>
-                </c:pt>
-                <c:pt idx="2">
-                  <c:v>94.5</c:v>
-                </c:pt>
-                <c:pt idx="3">
-                  <c:v>90.5</c:v>
-                </c:pt>
-                <c:pt idx="4">
-                  <c:v>95</c:v>
-                </c:pt>
-                <c:pt idx="5">
-                  <c:v>94.5</c:v>
-                </c:pt>
-                <c:pt idx="6">
-                  <c:v>96</c:v>
-                </c:pt>
-              </c:numCache>
-            </c:numRef>
-          </c:val>
-        </c:ser>
-        <c:dLbls>
-          <c:numFmt formatCode="#,##0" sourceLinked="0"/>
-          <c:txPr>
-            <a:bodyPr/>
-            <a:lstStyle/>
-            <a:p>
-              <a:pPr>
-                <a:defRPr b="0" i="0" strike="noStrike" sz="1000" u="none">
-                  <a:solidFill>
-                    <a:srgbClr val="E9EEF7"/>
-                  </a:solidFill>
-                  <a:latin typeface="Segoe UI"/>
-                </a:defRPr>
-              </a:pPr>
-            </a:p>
-          </c:txPr>
-          <c:showLegendKey val="0"/>
-          <c:showVal val="1"/>
-          <c:showCatName val="0"/>
-          <c:showSerName val="0"/>
-          <c:showPercent val="0"/>
-          <c:showBubbleSize val="0"/>
-          <c:showLeaderLines val="0"/>
-        </c:dLbls>
-        <c:gapWidth val="45"/>
-        <c:overlap val="0"/>
-        <c:axId val="2094734554"/>
-        <c:axId val="2094734552"/>
-        <c:axId val="2094734556"/>
-      </c:barChart>
-      <c:catAx>
-        <c:axId val="2094734554"/>
-        <c:scaling>
-          <c:orientation val="minMax"/>
-        </c:scaling>
-        <c:delete val="0"/>
-        <c:axPos val="b"/>
-        <c:numFmt formatCode="General" sourceLinked="1"/>
-        <c:majorTickMark val="out"/>
-        <c:minorTickMark val="none"/>
-        <c:tickLblPos val="low"/>
-        <c:spPr>
-          <a:ln w="12700" cap="flat">
-            <a:noFill/>
-            <a:prstDash val="solid"/>
-            <a:round/>
-          </a:ln>
-        </c:spPr>
-        <c:txPr>
-          <a:bodyPr/>
-          <a:lstStyle/>
-          <a:p>
-            <a:pPr>
-              <a:defRPr sz="1100" b="0" i="0" u="none" strike="noStrike">
-                <a:solidFill>
-                  <a:srgbClr val="93A1BA"/>
-                </a:solidFill>
-                <a:latin typeface="Arial"/>
-              </a:defRPr>
-            </a:pPr>
-            <a:endParaRPr lang="en-US"/>
-          </a:p>
-        </c:txPr>
-        <c:crossAx val="2094734552"/>
-        <c:crosses val="autoZero"/>
-        <c:auto val="1"/>
-        <c:lblAlgn val="ctr"/>
-        <c:noMultiLvlLbl val="1"/>
-      </c:catAx>
-      <c:valAx>
-        <c:axId val="2094734552"/>
-        <c:scaling>
-          <c:orientation val="minMax"/>
-          <c:max val="110"/>
-        </c:scaling>
-        <c:delete val="1"/>
-        <c:axPos val="l"/>
-        <c:numFmt formatCode="General" sourceLinked="0"/>
-        <c:majorTickMark val="out"/>
-        <c:minorTickMark val="none"/>
-        <c:tickLblPos val="nextTo"/>
-        <c:spPr>
-          <a:ln w="12700" cap="flat">
-            <a:solidFill>
-              <a:srgbClr val="888888"/>
-            </a:solidFill>
-            <a:prstDash val="solid"/>
-            <a:round/>
-          </a:ln>
-        </c:spPr>
-        <c:txPr>
-          <a:bodyPr/>
-          <a:lstStyle/>
-          <a:p>
-            <a:pPr>
-              <a:defRPr sz="1200" b="0" i="0" u="none" strike="noStrike">
-                <a:solidFill>
-                  <a:srgbClr val="000000"/>
-                </a:solidFill>
-                <a:latin typeface="Arial"/>
-              </a:defRPr>
-            </a:pPr>
-            <a:endParaRPr lang="en-US"/>
-          </a:p>
-        </c:txPr>
-        <c:crossAx val="2094734554"/>
-        <c:crosses val="autoZero"/>
-        <c:crossBetween val="between"/>
-      </c:valAx>
-      <c:spPr>
-        <a:solidFill>
-          <a:srgbClr val="0A0F1B"/>
-        </a:solidFill>
-        <a:ln>
-          <a:noFill/>
-        </a:ln>
-        <a:effectLst/>
-      </c:spPr>
-    </c:plotArea>
     <c:plotVisOnly val="1"/>
     <c:dispBlanksAs val="span"/>
   </c:chart>
@@ -7787,36 +7504,20 @@
           </a:p>
         </p:txBody>
       </p:sp>
-      <p:graphicFrame>
-        <p:nvGraphicFramePr>
-          <p:cNvPr id="5" name="Chart 0" descr=""/>
-          <p:cNvGraphicFramePr/>
-          <p:nvPr/>
-        </p:nvGraphicFramePr>
-        <p:xfrm>
-          <a:off x="502920" y="1280160"/>
-          <a:ext cx="6583680" cy="4572000"/>
-        </p:xfrm>
-        <a:graphic xmlns:a="http://schemas.openxmlformats.org/drawingml/2006/main">
-          <a:graphicData uri="http://schemas.openxmlformats.org/drawingml/2006/chart">
-            <c:chart xmlns:c="http://schemas.openxmlformats.org/drawingml/2006/chart" r:id="rId1"/>
-          </a:graphicData>
-        </a:graphic>
-      </p:graphicFrame>
-      <p:sp>
-        <p:nvSpPr>
-          <p:cNvPr id="6" name="Shape 3"/>
-          <p:cNvSpPr/>
-          <p:nvPr/>
-        </p:nvSpPr>
-        <p:spPr>
-          <a:xfrm>
-            <a:off x="7360920" y="1463040"/>
-            <a:ext cx="2057400" cy="1234440"/>
+      <p:sp>
+        <p:nvSpPr>
+          <p:cNvPr id="5" name="Shape 3"/>
+          <p:cNvSpPr/>
+          <p:nvPr/>
+        </p:nvSpPr>
+        <p:spPr>
+          <a:xfrm>
+            <a:off x="502920" y="1280160"/>
+            <a:ext cx="6583680" cy="4572000"/>
           </a:xfrm>
           <a:prstGeom prst="roundRect">
             <a:avLst>
-              <a:gd name="adj" fmla="val 7407"/>
+              <a:gd name="adj" fmla="val 2000"/>
             </a:avLst>
           </a:prstGeom>
           <a:solidFill>
@@ -7832,14 +7533,78 @@
       </p:sp>
       <p:sp>
         <p:nvSpPr>
-          <p:cNvPr id="7" name="Text 4"/>
-          <p:cNvSpPr/>
-          <p:nvPr/>
-        </p:nvSpPr>
-        <p:spPr>
-          <a:xfrm>
-            <a:off x="7360920" y="1609344"/>
-            <a:ext cx="2057400" cy="640080"/>
+          <p:cNvPr id="6" name="Text 4"/>
+          <p:cNvSpPr/>
+          <p:nvPr/>
+        </p:nvSpPr>
+        <p:spPr>
+          <a:xfrm>
+            <a:off x="731520" y="1463040"/>
+            <a:ext cx="6126480" cy="365760"/>
+          </a:xfrm>
+          <a:prstGeom prst="rect">
+            <a:avLst/>
+          </a:prstGeom>
+          <a:noFill/>
+          <a:ln/>
+        </p:spPr>
+        <p:txBody>
+          <a:bodyPr wrap="square" rtlCol="0" anchor="t"/>
+          <a:lstStyle/>
+          <a:p>
+            <a:pPr algn="l" indent="0" marL="0">
+              <a:lnSpc>
+                <a:spcPct val="100000"/>
+              </a:lnSpc>
+              <a:buNone/>
+            </a:pPr>
+            <a:r>
+              <a:rPr lang="en-US" sz="1200" b="1" dirty="0">
+                <a:solidFill>
+                  <a:srgbClr val="E9EEF7"/>
+                </a:solidFill>
+                <a:latin typeface="Segoe UI" pitchFamily="34" charset="0"/>
+                <a:ea typeface="Segoe UI" pitchFamily="34" charset="-122"/>
+                <a:cs typeface="Segoe UI" pitchFamily="34" charset="-120"/>
+              </a:rPr>
+              <a:t>Mean authenticity score per denomination (genuine RBI notes)</a:t>
+            </a:r>
+            <a:endParaRPr lang="en-US" sz="1200" dirty="0"/>
+          </a:p>
+        </p:txBody>
+      </p:sp>
+      <p:sp>
+        <p:nvSpPr>
+          <p:cNvPr id="7" name="Shape 5"/>
+          <p:cNvSpPr/>
+          <p:nvPr/>
+        </p:nvSpPr>
+        <p:spPr>
+          <a:xfrm>
+            <a:off x="868680" y="2723998"/>
+            <a:ext cx="658368" cy="2625242"/>
+          </a:xfrm>
+          <a:prstGeom prst="roundRect">
+            <a:avLst>
+              <a:gd name="adj" fmla="val 5556"/>
+            </a:avLst>
+          </a:prstGeom>
+          <a:solidFill>
+            <a:srgbClr val="2ECC71"/>
+          </a:solidFill>
+          <a:ln/>
+        </p:spPr>
+      </p:sp>
+      <p:sp>
+        <p:nvSpPr>
+          <p:cNvPr id="8" name="Text 6"/>
+          <p:cNvSpPr/>
+          <p:nvPr/>
+        </p:nvSpPr>
+        <p:spPr>
+          <a:xfrm>
+            <a:off x="777240" y="2431390"/>
+            <a:ext cx="841248" cy="274320"/>
           </a:xfrm>
           <a:prstGeom prst="rect">
             <a:avLst/>
@@ -7858,30 +7623,30 @@
               <a:buNone/>
             </a:pPr>
             <a:r>
-              <a:rPr lang="en-US" sz="3000" b="1" dirty="0">
-                <a:solidFill>
-                  <a:srgbClr val="2ECC71"/>
-                </a:solidFill>
-                <a:latin typeface="Segoe UI Semibold" pitchFamily="34" charset="0"/>
-                <a:ea typeface="Segoe UI Semibold" pitchFamily="34" charset="-122"/>
-                <a:cs typeface="Segoe UI Semibold" pitchFamily="34" charset="-120"/>
-              </a:rPr>
-              <a:t>100%</a:t>
-            </a:r>
-            <a:endParaRPr lang="en-US" sz="3000" dirty="0"/>
-          </a:p>
-        </p:txBody>
-      </p:sp>
-      <p:sp>
-        <p:nvSpPr>
-          <p:cNvPr id="8" name="Text 5"/>
-          <p:cNvSpPr/>
-          <p:nvPr/>
-        </p:nvSpPr>
-        <p:spPr>
-          <a:xfrm>
-            <a:off x="7360920" y="2304288"/>
-            <a:ext cx="2057400" cy="365760"/>
+              <a:rPr lang="en-US" sz="950" b="1" dirty="0">
+                <a:solidFill>
+                  <a:srgbClr val="E9EEF7"/>
+                </a:solidFill>
+                <a:latin typeface="Segoe UI" pitchFamily="34" charset="0"/>
+                <a:ea typeface="Segoe UI" pitchFamily="34" charset="-122"/>
+                <a:cs typeface="Segoe UI" pitchFamily="34" charset="-120"/>
+              </a:rPr>
+              <a:t>87</a:t>
+            </a:r>
+            <a:endParaRPr lang="en-US" sz="950" dirty="0"/>
+          </a:p>
+        </p:txBody>
+      </p:sp>
+      <p:sp>
+        <p:nvSpPr>
+          <p:cNvPr id="9" name="Text 7"/>
+          <p:cNvSpPr/>
+          <p:nvPr/>
+        </p:nvSpPr>
+        <p:spPr>
+          <a:xfrm>
+            <a:off x="731520" y="5422392"/>
+            <a:ext cx="932688" cy="274320"/>
           </a:xfrm>
           <a:prstGeom prst="rect">
             <a:avLst/>
@@ -7908,7 +7673,7 @@
                 <a:ea typeface="Segoe UI" pitchFamily="34" charset="-122"/>
                 <a:cs typeface="Segoe UI" pitchFamily="34" charset="-120"/>
               </a:rPr>
-              <a:t>Genuine accepted</a:t>
+              <a:t>₹10</a:t>
             </a:r>
             <a:endParaRPr lang="en-US" sz="1000" dirty="0"/>
           </a:p>
@@ -7916,14 +7681,675 @@
       </p:sp>
       <p:sp>
         <p:nvSpPr>
-          <p:cNvPr id="9" name="Shape 6"/>
-          <p:cNvSpPr/>
-          <p:nvPr/>
-        </p:nvSpPr>
-        <p:spPr>
-          <a:xfrm>
-            <a:off x="9601200" y="1463040"/>
-            <a:ext cx="2103120" cy="1234440"/>
+          <p:cNvPr id="10" name="Shape 8"/>
+          <p:cNvSpPr/>
+          <p:nvPr/>
+        </p:nvSpPr>
+        <p:spPr>
+          <a:xfrm>
+            <a:off x="1700784" y="2512771"/>
+            <a:ext cx="658368" cy="2836469"/>
+          </a:xfrm>
+          <a:prstGeom prst="roundRect">
+            <a:avLst>
+              <a:gd name="adj" fmla="val 5556"/>
+            </a:avLst>
+          </a:prstGeom>
+          <a:solidFill>
+            <a:srgbClr val="2ECC71"/>
+          </a:solidFill>
+          <a:ln/>
+        </p:spPr>
+      </p:sp>
+      <p:sp>
+        <p:nvSpPr>
+          <p:cNvPr id="11" name="Text 9"/>
+          <p:cNvSpPr/>
+          <p:nvPr/>
+        </p:nvSpPr>
+        <p:spPr>
+          <a:xfrm>
+            <a:off x="1609344" y="2220163"/>
+            <a:ext cx="841248" cy="274320"/>
+          </a:xfrm>
+          <a:prstGeom prst="rect">
+            <a:avLst/>
+          </a:prstGeom>
+          <a:noFill/>
+          <a:ln/>
+        </p:spPr>
+        <p:txBody>
+          <a:bodyPr wrap="square" rtlCol="0" anchor="t"/>
+          <a:lstStyle/>
+          <a:p>
+            <a:pPr algn="ctr" indent="0" marL="0">
+              <a:lnSpc>
+                <a:spcPct val="100000"/>
+              </a:lnSpc>
+              <a:buNone/>
+            </a:pPr>
+            <a:r>
+              <a:rPr lang="en-US" sz="950" b="1" dirty="0">
+                <a:solidFill>
+                  <a:srgbClr val="E9EEF7"/>
+                </a:solidFill>
+                <a:latin typeface="Segoe UI" pitchFamily="34" charset="0"/>
+                <a:ea typeface="Segoe UI" pitchFamily="34" charset="-122"/>
+                <a:cs typeface="Segoe UI" pitchFamily="34" charset="-120"/>
+              </a:rPr>
+              <a:t>94</a:t>
+            </a:r>
+            <a:endParaRPr lang="en-US" sz="950" dirty="0"/>
+          </a:p>
+        </p:txBody>
+      </p:sp>
+      <p:sp>
+        <p:nvSpPr>
+          <p:cNvPr id="12" name="Text 10"/>
+          <p:cNvSpPr/>
+          <p:nvPr/>
+        </p:nvSpPr>
+        <p:spPr>
+          <a:xfrm>
+            <a:off x="1563624" y="5422392"/>
+            <a:ext cx="932688" cy="274320"/>
+          </a:xfrm>
+          <a:prstGeom prst="rect">
+            <a:avLst/>
+          </a:prstGeom>
+          <a:noFill/>
+          <a:ln/>
+        </p:spPr>
+        <p:txBody>
+          <a:bodyPr wrap="square" rtlCol="0" anchor="t"/>
+          <a:lstStyle/>
+          <a:p>
+            <a:pPr algn="ctr" indent="0" marL="0">
+              <a:lnSpc>
+                <a:spcPct val="100000"/>
+              </a:lnSpc>
+              <a:buNone/>
+            </a:pPr>
+            <a:r>
+              <a:rPr lang="en-US" sz="1000" dirty="0">
+                <a:solidFill>
+                  <a:srgbClr val="93A1BA"/>
+                </a:solidFill>
+                <a:latin typeface="Segoe UI" pitchFamily="34" charset="0"/>
+                <a:ea typeface="Segoe UI" pitchFamily="34" charset="-122"/>
+                <a:cs typeface="Segoe UI" pitchFamily="34" charset="-120"/>
+              </a:rPr>
+              <a:t>₹20</a:t>
+            </a:r>
+            <a:endParaRPr lang="en-US" sz="1000" dirty="0"/>
+          </a:p>
+        </p:txBody>
+      </p:sp>
+      <p:sp>
+        <p:nvSpPr>
+          <p:cNvPr id="13" name="Shape 11"/>
+          <p:cNvSpPr/>
+          <p:nvPr/>
+        </p:nvSpPr>
+        <p:spPr>
+          <a:xfrm>
+            <a:off x="2532888" y="2497684"/>
+            <a:ext cx="658368" cy="2851556"/>
+          </a:xfrm>
+          <a:prstGeom prst="roundRect">
+            <a:avLst>
+              <a:gd name="adj" fmla="val 5556"/>
+            </a:avLst>
+          </a:prstGeom>
+          <a:solidFill>
+            <a:srgbClr val="2ECC71"/>
+          </a:solidFill>
+          <a:ln/>
+        </p:spPr>
+      </p:sp>
+      <p:sp>
+        <p:nvSpPr>
+          <p:cNvPr id="14" name="Text 12"/>
+          <p:cNvSpPr/>
+          <p:nvPr/>
+        </p:nvSpPr>
+        <p:spPr>
+          <a:xfrm>
+            <a:off x="2441448" y="2205076"/>
+            <a:ext cx="841248" cy="274320"/>
+          </a:xfrm>
+          <a:prstGeom prst="rect">
+            <a:avLst/>
+          </a:prstGeom>
+          <a:noFill/>
+          <a:ln/>
+        </p:spPr>
+        <p:txBody>
+          <a:bodyPr wrap="square" rtlCol="0" anchor="t"/>
+          <a:lstStyle/>
+          <a:p>
+            <a:pPr algn="ctr" indent="0" marL="0">
+              <a:lnSpc>
+                <a:spcPct val="100000"/>
+              </a:lnSpc>
+              <a:buNone/>
+            </a:pPr>
+            <a:r>
+              <a:rPr lang="en-US" sz="950" b="1" dirty="0">
+                <a:solidFill>
+                  <a:srgbClr val="E9EEF7"/>
+                </a:solidFill>
+                <a:latin typeface="Segoe UI" pitchFamily="34" charset="0"/>
+                <a:ea typeface="Segoe UI" pitchFamily="34" charset="-122"/>
+                <a:cs typeface="Segoe UI" pitchFamily="34" charset="-120"/>
+              </a:rPr>
+              <a:t>94.5</a:t>
+            </a:r>
+            <a:endParaRPr lang="en-US" sz="950" dirty="0"/>
+          </a:p>
+        </p:txBody>
+      </p:sp>
+      <p:sp>
+        <p:nvSpPr>
+          <p:cNvPr id="15" name="Text 13"/>
+          <p:cNvSpPr/>
+          <p:nvPr/>
+        </p:nvSpPr>
+        <p:spPr>
+          <a:xfrm>
+            <a:off x="2395728" y="5422392"/>
+            <a:ext cx="932688" cy="274320"/>
+          </a:xfrm>
+          <a:prstGeom prst="rect">
+            <a:avLst/>
+          </a:prstGeom>
+          <a:noFill/>
+          <a:ln/>
+        </p:spPr>
+        <p:txBody>
+          <a:bodyPr wrap="square" rtlCol="0" anchor="t"/>
+          <a:lstStyle/>
+          <a:p>
+            <a:pPr algn="ctr" indent="0" marL="0">
+              <a:lnSpc>
+                <a:spcPct val="100000"/>
+              </a:lnSpc>
+              <a:buNone/>
+            </a:pPr>
+            <a:r>
+              <a:rPr lang="en-US" sz="1000" dirty="0">
+                <a:solidFill>
+                  <a:srgbClr val="93A1BA"/>
+                </a:solidFill>
+                <a:latin typeface="Segoe UI" pitchFamily="34" charset="0"/>
+                <a:ea typeface="Segoe UI" pitchFamily="34" charset="-122"/>
+                <a:cs typeface="Segoe UI" pitchFamily="34" charset="-120"/>
+              </a:rPr>
+              <a:t>₹50</a:t>
+            </a:r>
+            <a:endParaRPr lang="en-US" sz="1000" dirty="0"/>
+          </a:p>
+        </p:txBody>
+      </p:sp>
+      <p:sp>
+        <p:nvSpPr>
+          <p:cNvPr id="16" name="Shape 14"/>
+          <p:cNvSpPr/>
+          <p:nvPr/>
+        </p:nvSpPr>
+        <p:spPr>
+          <a:xfrm>
+            <a:off x="3364992" y="2618384"/>
+            <a:ext cx="658368" cy="2730856"/>
+          </a:xfrm>
+          <a:prstGeom prst="roundRect">
+            <a:avLst>
+              <a:gd name="adj" fmla="val 5556"/>
+            </a:avLst>
+          </a:prstGeom>
+          <a:solidFill>
+            <a:srgbClr val="2ECC71"/>
+          </a:solidFill>
+          <a:ln/>
+        </p:spPr>
+      </p:sp>
+      <p:sp>
+        <p:nvSpPr>
+          <p:cNvPr id="17" name="Text 15"/>
+          <p:cNvSpPr/>
+          <p:nvPr/>
+        </p:nvSpPr>
+        <p:spPr>
+          <a:xfrm>
+            <a:off x="3273552" y="2325776"/>
+            <a:ext cx="841248" cy="274320"/>
+          </a:xfrm>
+          <a:prstGeom prst="rect">
+            <a:avLst/>
+          </a:prstGeom>
+          <a:noFill/>
+          <a:ln/>
+        </p:spPr>
+        <p:txBody>
+          <a:bodyPr wrap="square" rtlCol="0" anchor="t"/>
+          <a:lstStyle/>
+          <a:p>
+            <a:pPr algn="ctr" indent="0" marL="0">
+              <a:lnSpc>
+                <a:spcPct val="100000"/>
+              </a:lnSpc>
+              <a:buNone/>
+            </a:pPr>
+            <a:r>
+              <a:rPr lang="en-US" sz="950" b="1" dirty="0">
+                <a:solidFill>
+                  <a:srgbClr val="E9EEF7"/>
+                </a:solidFill>
+                <a:latin typeface="Segoe UI" pitchFamily="34" charset="0"/>
+                <a:ea typeface="Segoe UI" pitchFamily="34" charset="-122"/>
+                <a:cs typeface="Segoe UI" pitchFamily="34" charset="-120"/>
+              </a:rPr>
+              <a:t>90.5</a:t>
+            </a:r>
+            <a:endParaRPr lang="en-US" sz="950" dirty="0"/>
+          </a:p>
+        </p:txBody>
+      </p:sp>
+      <p:sp>
+        <p:nvSpPr>
+          <p:cNvPr id="18" name="Text 16"/>
+          <p:cNvSpPr/>
+          <p:nvPr/>
+        </p:nvSpPr>
+        <p:spPr>
+          <a:xfrm>
+            <a:off x="3227832" y="5422392"/>
+            <a:ext cx="932688" cy="274320"/>
+          </a:xfrm>
+          <a:prstGeom prst="rect">
+            <a:avLst/>
+          </a:prstGeom>
+          <a:noFill/>
+          <a:ln/>
+        </p:spPr>
+        <p:txBody>
+          <a:bodyPr wrap="square" rtlCol="0" anchor="t"/>
+          <a:lstStyle/>
+          <a:p>
+            <a:pPr algn="ctr" indent="0" marL="0">
+              <a:lnSpc>
+                <a:spcPct val="100000"/>
+              </a:lnSpc>
+              <a:buNone/>
+            </a:pPr>
+            <a:r>
+              <a:rPr lang="en-US" sz="1000" dirty="0">
+                <a:solidFill>
+                  <a:srgbClr val="93A1BA"/>
+                </a:solidFill>
+                <a:latin typeface="Segoe UI" pitchFamily="34" charset="0"/>
+                <a:ea typeface="Segoe UI" pitchFamily="34" charset="-122"/>
+                <a:cs typeface="Segoe UI" pitchFamily="34" charset="-120"/>
+              </a:rPr>
+              <a:t>₹100</a:t>
+            </a:r>
+            <a:endParaRPr lang="en-US" sz="1000" dirty="0"/>
+          </a:p>
+        </p:txBody>
+      </p:sp>
+      <p:sp>
+        <p:nvSpPr>
+          <p:cNvPr id="19" name="Shape 17"/>
+          <p:cNvSpPr/>
+          <p:nvPr/>
+        </p:nvSpPr>
+        <p:spPr>
+          <a:xfrm>
+            <a:off x="4197096" y="2482596"/>
+            <a:ext cx="658368" cy="2866644"/>
+          </a:xfrm>
+          <a:prstGeom prst="roundRect">
+            <a:avLst>
+              <a:gd name="adj" fmla="val 5556"/>
+            </a:avLst>
+          </a:prstGeom>
+          <a:solidFill>
+            <a:srgbClr val="2ECC71"/>
+          </a:solidFill>
+          <a:ln/>
+        </p:spPr>
+      </p:sp>
+      <p:sp>
+        <p:nvSpPr>
+          <p:cNvPr id="20" name="Text 18"/>
+          <p:cNvSpPr/>
+          <p:nvPr/>
+        </p:nvSpPr>
+        <p:spPr>
+          <a:xfrm>
+            <a:off x="4105656" y="2189988"/>
+            <a:ext cx="841248" cy="274320"/>
+          </a:xfrm>
+          <a:prstGeom prst="rect">
+            <a:avLst/>
+          </a:prstGeom>
+          <a:noFill/>
+          <a:ln/>
+        </p:spPr>
+        <p:txBody>
+          <a:bodyPr wrap="square" rtlCol="0" anchor="t"/>
+          <a:lstStyle/>
+          <a:p>
+            <a:pPr algn="ctr" indent="0" marL="0">
+              <a:lnSpc>
+                <a:spcPct val="100000"/>
+              </a:lnSpc>
+              <a:buNone/>
+            </a:pPr>
+            <a:r>
+              <a:rPr lang="en-US" sz="950" b="1" dirty="0">
+                <a:solidFill>
+                  <a:srgbClr val="E9EEF7"/>
+                </a:solidFill>
+                <a:latin typeface="Segoe UI" pitchFamily="34" charset="0"/>
+                <a:ea typeface="Segoe UI" pitchFamily="34" charset="-122"/>
+                <a:cs typeface="Segoe UI" pitchFamily="34" charset="-120"/>
+              </a:rPr>
+              <a:t>95</a:t>
+            </a:r>
+            <a:endParaRPr lang="en-US" sz="950" dirty="0"/>
+          </a:p>
+        </p:txBody>
+      </p:sp>
+      <p:sp>
+        <p:nvSpPr>
+          <p:cNvPr id="21" name="Text 19"/>
+          <p:cNvSpPr/>
+          <p:nvPr/>
+        </p:nvSpPr>
+        <p:spPr>
+          <a:xfrm>
+            <a:off x="4059936" y="5422392"/>
+            <a:ext cx="932688" cy="274320"/>
+          </a:xfrm>
+          <a:prstGeom prst="rect">
+            <a:avLst/>
+          </a:prstGeom>
+          <a:noFill/>
+          <a:ln/>
+        </p:spPr>
+        <p:txBody>
+          <a:bodyPr wrap="square" rtlCol="0" anchor="t"/>
+          <a:lstStyle/>
+          <a:p>
+            <a:pPr algn="ctr" indent="0" marL="0">
+              <a:lnSpc>
+                <a:spcPct val="100000"/>
+              </a:lnSpc>
+              <a:buNone/>
+            </a:pPr>
+            <a:r>
+              <a:rPr lang="en-US" sz="1000" dirty="0">
+                <a:solidFill>
+                  <a:srgbClr val="93A1BA"/>
+                </a:solidFill>
+                <a:latin typeface="Segoe UI" pitchFamily="34" charset="0"/>
+                <a:ea typeface="Segoe UI" pitchFamily="34" charset="-122"/>
+                <a:cs typeface="Segoe UI" pitchFamily="34" charset="-120"/>
+              </a:rPr>
+              <a:t>₹200</a:t>
+            </a:r>
+            <a:endParaRPr lang="en-US" sz="1000" dirty="0"/>
+          </a:p>
+        </p:txBody>
+      </p:sp>
+      <p:sp>
+        <p:nvSpPr>
+          <p:cNvPr id="22" name="Shape 20"/>
+          <p:cNvSpPr/>
+          <p:nvPr/>
+        </p:nvSpPr>
+        <p:spPr>
+          <a:xfrm>
+            <a:off x="5029200" y="2497684"/>
+            <a:ext cx="658368" cy="2851556"/>
+          </a:xfrm>
+          <a:prstGeom prst="roundRect">
+            <a:avLst>
+              <a:gd name="adj" fmla="val 5556"/>
+            </a:avLst>
+          </a:prstGeom>
+          <a:solidFill>
+            <a:srgbClr val="2ECC71"/>
+          </a:solidFill>
+          <a:ln/>
+        </p:spPr>
+      </p:sp>
+      <p:sp>
+        <p:nvSpPr>
+          <p:cNvPr id="23" name="Text 21"/>
+          <p:cNvSpPr/>
+          <p:nvPr/>
+        </p:nvSpPr>
+        <p:spPr>
+          <a:xfrm>
+            <a:off x="4937760" y="2205076"/>
+            <a:ext cx="841248" cy="274320"/>
+          </a:xfrm>
+          <a:prstGeom prst="rect">
+            <a:avLst/>
+          </a:prstGeom>
+          <a:noFill/>
+          <a:ln/>
+        </p:spPr>
+        <p:txBody>
+          <a:bodyPr wrap="square" rtlCol="0" anchor="t"/>
+          <a:lstStyle/>
+          <a:p>
+            <a:pPr algn="ctr" indent="0" marL="0">
+              <a:lnSpc>
+                <a:spcPct val="100000"/>
+              </a:lnSpc>
+              <a:buNone/>
+            </a:pPr>
+            <a:r>
+              <a:rPr lang="en-US" sz="950" b="1" dirty="0">
+                <a:solidFill>
+                  <a:srgbClr val="E9EEF7"/>
+                </a:solidFill>
+                <a:latin typeface="Segoe UI" pitchFamily="34" charset="0"/>
+                <a:ea typeface="Segoe UI" pitchFamily="34" charset="-122"/>
+                <a:cs typeface="Segoe UI" pitchFamily="34" charset="-120"/>
+              </a:rPr>
+              <a:t>94.5</a:t>
+            </a:r>
+            <a:endParaRPr lang="en-US" sz="950" dirty="0"/>
+          </a:p>
+        </p:txBody>
+      </p:sp>
+      <p:sp>
+        <p:nvSpPr>
+          <p:cNvPr id="24" name="Text 22"/>
+          <p:cNvSpPr/>
+          <p:nvPr/>
+        </p:nvSpPr>
+        <p:spPr>
+          <a:xfrm>
+            <a:off x="4892040" y="5422392"/>
+            <a:ext cx="932688" cy="274320"/>
+          </a:xfrm>
+          <a:prstGeom prst="rect">
+            <a:avLst/>
+          </a:prstGeom>
+          <a:noFill/>
+          <a:ln/>
+        </p:spPr>
+        <p:txBody>
+          <a:bodyPr wrap="square" rtlCol="0" anchor="t"/>
+          <a:lstStyle/>
+          <a:p>
+            <a:pPr algn="ctr" indent="0" marL="0">
+              <a:lnSpc>
+                <a:spcPct val="100000"/>
+              </a:lnSpc>
+              <a:buNone/>
+            </a:pPr>
+            <a:r>
+              <a:rPr lang="en-US" sz="1000" dirty="0">
+                <a:solidFill>
+                  <a:srgbClr val="93A1BA"/>
+                </a:solidFill>
+                <a:latin typeface="Segoe UI" pitchFamily="34" charset="0"/>
+                <a:ea typeface="Segoe UI" pitchFamily="34" charset="-122"/>
+                <a:cs typeface="Segoe UI" pitchFamily="34" charset="-120"/>
+              </a:rPr>
+              <a:t>₹500</a:t>
+            </a:r>
+            <a:endParaRPr lang="en-US" sz="1000" dirty="0"/>
+          </a:p>
+        </p:txBody>
+      </p:sp>
+      <p:sp>
+        <p:nvSpPr>
+          <p:cNvPr id="25" name="Shape 23"/>
+          <p:cNvSpPr/>
+          <p:nvPr/>
+        </p:nvSpPr>
+        <p:spPr>
+          <a:xfrm>
+            <a:off x="5861304" y="2452421"/>
+            <a:ext cx="658368" cy="2896819"/>
+          </a:xfrm>
+          <a:prstGeom prst="roundRect">
+            <a:avLst>
+              <a:gd name="adj" fmla="val 5556"/>
+            </a:avLst>
+          </a:prstGeom>
+          <a:solidFill>
+            <a:srgbClr val="2ECC71"/>
+          </a:solidFill>
+          <a:ln/>
+        </p:spPr>
+      </p:sp>
+      <p:sp>
+        <p:nvSpPr>
+          <p:cNvPr id="26" name="Text 24"/>
+          <p:cNvSpPr/>
+          <p:nvPr/>
+        </p:nvSpPr>
+        <p:spPr>
+          <a:xfrm>
+            <a:off x="5769864" y="2159813"/>
+            <a:ext cx="841248" cy="274320"/>
+          </a:xfrm>
+          <a:prstGeom prst="rect">
+            <a:avLst/>
+          </a:prstGeom>
+          <a:noFill/>
+          <a:ln/>
+        </p:spPr>
+        <p:txBody>
+          <a:bodyPr wrap="square" rtlCol="0" anchor="t"/>
+          <a:lstStyle/>
+          <a:p>
+            <a:pPr algn="ctr" indent="0" marL="0">
+              <a:lnSpc>
+                <a:spcPct val="100000"/>
+              </a:lnSpc>
+              <a:buNone/>
+            </a:pPr>
+            <a:r>
+              <a:rPr lang="en-US" sz="950" b="1" dirty="0">
+                <a:solidFill>
+                  <a:srgbClr val="E9EEF7"/>
+                </a:solidFill>
+                <a:latin typeface="Segoe UI" pitchFamily="34" charset="0"/>
+                <a:ea typeface="Segoe UI" pitchFamily="34" charset="-122"/>
+                <a:cs typeface="Segoe UI" pitchFamily="34" charset="-120"/>
+              </a:rPr>
+              <a:t>96</a:t>
+            </a:r>
+            <a:endParaRPr lang="en-US" sz="950" dirty="0"/>
+          </a:p>
+        </p:txBody>
+      </p:sp>
+      <p:sp>
+        <p:nvSpPr>
+          <p:cNvPr id="27" name="Text 25"/>
+          <p:cNvSpPr/>
+          <p:nvPr/>
+        </p:nvSpPr>
+        <p:spPr>
+          <a:xfrm>
+            <a:off x="5724144" y="5422392"/>
+            <a:ext cx="932688" cy="274320"/>
+          </a:xfrm>
+          <a:prstGeom prst="rect">
+            <a:avLst/>
+          </a:prstGeom>
+          <a:noFill/>
+          <a:ln/>
+        </p:spPr>
+        <p:txBody>
+          <a:bodyPr wrap="square" rtlCol="0" anchor="t"/>
+          <a:lstStyle/>
+          <a:p>
+            <a:pPr algn="ctr" indent="0" marL="0">
+              <a:lnSpc>
+                <a:spcPct val="100000"/>
+              </a:lnSpc>
+              <a:buNone/>
+            </a:pPr>
+            <a:r>
+              <a:rPr lang="en-US" sz="1000" dirty="0">
+                <a:solidFill>
+                  <a:srgbClr val="93A1BA"/>
+                </a:solidFill>
+                <a:latin typeface="Segoe UI" pitchFamily="34" charset="0"/>
+                <a:ea typeface="Segoe UI" pitchFamily="34" charset="-122"/>
+                <a:cs typeface="Segoe UI" pitchFamily="34" charset="-120"/>
+              </a:rPr>
+              <a:t>₹2000</a:t>
+            </a:r>
+            <a:endParaRPr lang="en-US" sz="1000" dirty="0"/>
+          </a:p>
+        </p:txBody>
+      </p:sp>
+      <p:sp>
+        <p:nvSpPr>
+          <p:cNvPr id="28" name="Shape 26"/>
+          <p:cNvSpPr/>
+          <p:nvPr/>
+        </p:nvSpPr>
+        <p:spPr>
+          <a:xfrm>
+            <a:off x="777240" y="5349240"/>
+            <a:ext cx="5916168" cy="0"/>
+          </a:xfrm>
+          <a:prstGeom prst="line">
+            <a:avLst/>
+          </a:prstGeom>
+          <a:noFill/>
+          <a:ln w="12700">
+            <a:solidFill>
+              <a:srgbClr val="24304A"/>
+            </a:solidFill>
+            <a:prstDash val="solid"/>
+            <a:headEnd type="none"/>
+            <a:tailEnd type="none"/>
+          </a:ln>
+        </p:spPr>
+      </p:sp>
+      <p:sp>
+        <p:nvSpPr>
+          <p:cNvPr id="29" name="Shape 27"/>
+          <p:cNvSpPr/>
+          <p:nvPr/>
+        </p:nvSpPr>
+        <p:spPr>
+          <a:xfrm>
+            <a:off x="7360920" y="1463040"/>
+            <a:ext cx="2057400" cy="1234440"/>
           </a:xfrm>
           <a:prstGeom prst="roundRect">
             <a:avLst>
@@ -7943,14 +8369,14 @@
       </p:sp>
       <p:sp>
         <p:nvSpPr>
-          <p:cNvPr id="10" name="Text 7"/>
-          <p:cNvSpPr/>
-          <p:nvPr/>
-        </p:nvSpPr>
-        <p:spPr>
-          <a:xfrm>
-            <a:off x="9601200" y="1609344"/>
-            <a:ext cx="2103120" cy="640080"/>
+          <p:cNvPr id="30" name="Text 28"/>
+          <p:cNvSpPr/>
+          <p:nvPr/>
+        </p:nvSpPr>
+        <p:spPr>
+          <a:xfrm>
+            <a:off x="7360920" y="1609344"/>
+            <a:ext cx="2057400" cy="640080"/>
           </a:xfrm>
           <a:prstGeom prst="rect">
             <a:avLst/>
@@ -7977,6 +8403,117 @@
                 <a:ea typeface="Segoe UI Semibold" pitchFamily="34" charset="-122"/>
                 <a:cs typeface="Segoe UI Semibold" pitchFamily="34" charset="-120"/>
               </a:rPr>
+              <a:t>100%</a:t>
+            </a:r>
+            <a:endParaRPr lang="en-US" sz="3000" dirty="0"/>
+          </a:p>
+        </p:txBody>
+      </p:sp>
+      <p:sp>
+        <p:nvSpPr>
+          <p:cNvPr id="31" name="Text 29"/>
+          <p:cNvSpPr/>
+          <p:nvPr/>
+        </p:nvSpPr>
+        <p:spPr>
+          <a:xfrm>
+            <a:off x="7360920" y="2304288"/>
+            <a:ext cx="2057400" cy="365760"/>
+          </a:xfrm>
+          <a:prstGeom prst="rect">
+            <a:avLst/>
+          </a:prstGeom>
+          <a:noFill/>
+          <a:ln/>
+        </p:spPr>
+        <p:txBody>
+          <a:bodyPr wrap="square" rtlCol="0" anchor="t"/>
+          <a:lstStyle/>
+          <a:p>
+            <a:pPr algn="ctr" indent="0" marL="0">
+              <a:lnSpc>
+                <a:spcPct val="100000"/>
+              </a:lnSpc>
+              <a:buNone/>
+            </a:pPr>
+            <a:r>
+              <a:rPr lang="en-US" sz="1000" dirty="0">
+                <a:solidFill>
+                  <a:srgbClr val="93A1BA"/>
+                </a:solidFill>
+                <a:latin typeface="Segoe UI" pitchFamily="34" charset="0"/>
+                <a:ea typeface="Segoe UI" pitchFamily="34" charset="-122"/>
+                <a:cs typeface="Segoe UI" pitchFamily="34" charset="-120"/>
+              </a:rPr>
+              <a:t>Genuine accepted</a:t>
+            </a:r>
+            <a:endParaRPr lang="en-US" sz="1000" dirty="0"/>
+          </a:p>
+        </p:txBody>
+      </p:sp>
+      <p:sp>
+        <p:nvSpPr>
+          <p:cNvPr id="32" name="Shape 30"/>
+          <p:cNvSpPr/>
+          <p:nvPr/>
+        </p:nvSpPr>
+        <p:spPr>
+          <a:xfrm>
+            <a:off x="9601200" y="1463040"/>
+            <a:ext cx="2103120" cy="1234440"/>
+          </a:xfrm>
+          <a:prstGeom prst="roundRect">
+            <a:avLst>
+              <a:gd name="adj" fmla="val 7407"/>
+            </a:avLst>
+          </a:prstGeom>
+          <a:solidFill>
+            <a:srgbClr val="141C2E"/>
+          </a:solidFill>
+          <a:ln w="12700">
+            <a:solidFill>
+              <a:srgbClr val="24304A"/>
+            </a:solidFill>
+            <a:prstDash val="solid"/>
+          </a:ln>
+        </p:spPr>
+      </p:sp>
+      <p:sp>
+        <p:nvSpPr>
+          <p:cNvPr id="33" name="Text 31"/>
+          <p:cNvSpPr/>
+          <p:nvPr/>
+        </p:nvSpPr>
+        <p:spPr>
+          <a:xfrm>
+            <a:off x="9601200" y="1609344"/>
+            <a:ext cx="2103120" cy="640080"/>
+          </a:xfrm>
+          <a:prstGeom prst="rect">
+            <a:avLst/>
+          </a:prstGeom>
+          <a:noFill/>
+          <a:ln/>
+        </p:spPr>
+        <p:txBody>
+          <a:bodyPr wrap="square" rtlCol="0" anchor="t"/>
+          <a:lstStyle/>
+          <a:p>
+            <a:pPr algn="ctr" indent="0" marL="0">
+              <a:lnSpc>
+                <a:spcPct val="100000"/>
+              </a:lnSpc>
+              <a:buNone/>
+            </a:pPr>
+            <a:r>
+              <a:rPr lang="en-US" sz="3000" b="1" dirty="0">
+                <a:solidFill>
+                  <a:srgbClr val="2ECC71"/>
+                </a:solidFill>
+                <a:latin typeface="Segoe UI Semibold" pitchFamily="34" charset="0"/>
+                <a:ea typeface="Segoe UI Semibold" pitchFamily="34" charset="-122"/>
+                <a:cs typeface="Segoe UI Semibold" pitchFamily="34" charset="-120"/>
+              </a:rPr>
               <a:t>0%</a:t>
             </a:r>
             <a:endParaRPr lang="en-US" sz="3000" dirty="0"/>
@@ -7985,7 +8522,7 @@
       </p:sp>
       <p:sp>
         <p:nvSpPr>
-          <p:cNvPr id="11" name="Text 8"/>
+          <p:cNvPr id="34" name="Text 32"/>
           <p:cNvSpPr/>
           <p:nvPr/>
         </p:nvSpPr>
@@ -8027,7 +8564,7 @@
       </p:sp>
       <p:sp>
         <p:nvSpPr>
-          <p:cNvPr id="12" name="Shape 9"/>
+          <p:cNvPr id="35" name="Shape 33"/>
           <p:cNvSpPr/>
           <p:nvPr/>
         </p:nvSpPr>
@@ -8054,7 +8591,7 @@
       </p:sp>
       <p:sp>
         <p:nvSpPr>
-          <p:cNvPr id="13" name="Text 10"/>
+          <p:cNvPr id="36" name="Text 34"/>
           <p:cNvSpPr/>
           <p:nvPr/>
         </p:nvSpPr>
@@ -8096,7 +8633,7 @@
       </p:sp>
       <p:sp>
         <p:nvSpPr>
-          <p:cNvPr id="14" name="Text 11"/>
+          <p:cNvPr id="37" name="Text 35"/>
           <p:cNvSpPr/>
           <p:nvPr/>
         </p:nvSpPr>
@@ -8158,7 +8695,7 @@
       </p:sp>
       <p:sp>
         <p:nvSpPr>
-          <p:cNvPr id="15" name="Text 12"/>
+          <p:cNvPr id="38" name="Text 36"/>
           <p:cNvSpPr/>
           <p:nvPr/>
         </p:nvSpPr>
@@ -8200,7 +8737,7 @@
       </p:sp>
       <p:sp>
         <p:nvSpPr>
-          <p:cNvPr id="16" name="Text 13"/>
+          <p:cNvPr id="39" name="Text 37"/>
           <p:cNvSpPr/>
           <p:nvPr/>
         </p:nvSpPr>
@@ -8242,7 +8779,7 @@
       </p:sp>
       <p:sp>
         <p:nvSpPr>
-          <p:cNvPr id="17" name="Text 14"/>
+          <p:cNvPr id="40" name="Text 38"/>
           <p:cNvSpPr/>
           <p:nvPr/>
         </p:nvSpPr>

</xml_diff>

<commit_message>
Deck slide 7: fix counterfeit feature bars (fit % column, clearer failed bar)
</commit_message>
<xml_diff>
--- a/docs/Prahari_Pitch_Deck.pptx
+++ b/docs/Prahari_Pitch_Deck.pptx
@@ -18642,27 +18642,27 @@
         </p:nvSpPr>
         <p:spPr>
           <a:xfrm>
-            <a:off x="6583680" y="3383280"/>
-            <a:ext cx="3061411" cy="256032"/>
-          </a:xfrm>
-          <a:prstGeom prst="rect">
-            <a:avLst/>
-          </a:prstGeom>
-          <a:noFill/>
-          <a:ln/>
-        </p:spPr>
-        <p:txBody>
-          <a:bodyPr wrap="square" rtlCol="0" anchor="t"/>
-          <a:lstStyle/>
-          <a:p>
-            <a:pPr algn="l" indent="0" marL="0">
-              <a:lnSpc>
-                <a:spcPct val="100000"/>
-              </a:lnSpc>
-              <a:buNone/>
-            </a:pPr>
-            <a:r>
-              <a:rPr lang="en-US" sz="1050" dirty="0">
+            <a:off x="6537960" y="3401568"/>
+            <a:ext cx="2689708" cy="256032"/>
+          </a:xfrm>
+          <a:prstGeom prst="rect">
+            <a:avLst/>
+          </a:prstGeom>
+          <a:noFill/>
+          <a:ln/>
+        </p:spPr>
+        <p:txBody>
+          <a:bodyPr wrap="square" rtlCol="0" anchor="t"/>
+          <a:lstStyle/>
+          <a:p>
+            <a:pPr algn="l" indent="0" marL="0">
+              <a:lnSpc>
+                <a:spcPct val="100000"/>
+              </a:lnSpc>
+              <a:buNone/>
+            </a:pPr>
+            <a:r>
+              <a:rPr lang="en-US" sz="1000" dirty="0">
                 <a:solidFill>
                   <a:srgbClr val="E9EEF7"/>
                 </a:solidFill>
@@ -18672,7 +18672,7 @@
               </a:rPr>
               <a:t>✓  Aspect ratio / dimensions</a:t>
             </a:r>
-            <a:endParaRPr lang="en-US" sz="1050" dirty="0"/>
+            <a:endParaRPr lang="en-US" sz="1000" dirty="0"/>
           </a:p>
         </p:txBody>
       </p:sp>
@@ -18684,12 +18684,12 @@
         </p:nvSpPr>
         <p:spPr>
           <a:xfrm>
-            <a:off x="9743846" y="3438144"/>
-            <a:ext cx="1481328" cy="128016"/>
+            <a:off x="9319108" y="3465576"/>
+            <a:ext cx="1370228" cy="118872"/>
           </a:xfrm>
           <a:prstGeom prst="roundRect">
             <a:avLst>
-              <a:gd name="adj" fmla="val 50000"/>
+              <a:gd name="adj" fmla="val 46154"/>
             </a:avLst>
           </a:prstGeom>
           <a:solidFill>
@@ -18706,12 +18706,12 @@
         </p:nvSpPr>
         <p:spPr>
           <a:xfrm>
-            <a:off x="9743846" y="3438144"/>
-            <a:ext cx="1155436" cy="128016"/>
+            <a:off x="9319108" y="3465576"/>
+            <a:ext cx="1068778" cy="118872"/>
           </a:xfrm>
           <a:prstGeom prst="roundRect">
             <a:avLst>
-              <a:gd name="adj" fmla="val 50000"/>
+              <a:gd name="adj" fmla="val 46154"/>
             </a:avLst>
           </a:prstGeom>
           <a:solidFill>
@@ -18728,8 +18728,8 @@
         </p:nvSpPr>
         <p:spPr>
           <a:xfrm>
-            <a:off x="11280038" y="3383280"/>
-            <a:ext cx="296266" cy="256032"/>
+            <a:off x="10780776" y="3401568"/>
+            <a:ext cx="566928" cy="256032"/>
           </a:xfrm>
           <a:prstGeom prst="rect">
             <a:avLst/>
@@ -18770,27 +18770,27 @@
         </p:nvSpPr>
         <p:spPr>
           <a:xfrm>
-            <a:off x="6583680" y="3721608"/>
-            <a:ext cx="3061411" cy="256032"/>
-          </a:xfrm>
-          <a:prstGeom prst="rect">
-            <a:avLst/>
-          </a:prstGeom>
-          <a:noFill/>
-          <a:ln/>
-        </p:spPr>
-        <p:txBody>
-          <a:bodyPr wrap="square" rtlCol="0" anchor="t"/>
-          <a:lstStyle/>
-          <a:p>
-            <a:pPr algn="l" indent="0" marL="0">
-              <a:lnSpc>
-                <a:spcPct val="100000"/>
-              </a:lnSpc>
-              <a:buNone/>
-            </a:pPr>
-            <a:r>
-              <a:rPr lang="en-US" sz="1050" dirty="0">
+            <a:off x="6537960" y="3739896"/>
+            <a:ext cx="2689708" cy="256032"/>
+          </a:xfrm>
+          <a:prstGeom prst="rect">
+            <a:avLst/>
+          </a:prstGeom>
+          <a:noFill/>
+          <a:ln/>
+        </p:spPr>
+        <p:txBody>
+          <a:bodyPr wrap="square" rtlCol="0" anchor="t"/>
+          <a:lstStyle/>
+          <a:p>
+            <a:pPr algn="l" indent="0" marL="0">
+              <a:lnSpc>
+                <a:spcPct val="100000"/>
+              </a:lnSpc>
+              <a:buNone/>
+            </a:pPr>
+            <a:r>
+              <a:rPr lang="en-US" sz="1000" dirty="0">
                 <a:solidFill>
                   <a:srgbClr val="E9EEF7"/>
                 </a:solidFill>
@@ -18800,7 +18800,7 @@
               </a:rPr>
               <a:t>✓  Base colour match</a:t>
             </a:r>
-            <a:endParaRPr lang="en-US" sz="1050" dirty="0"/>
+            <a:endParaRPr lang="en-US" sz="1000" dirty="0"/>
           </a:p>
         </p:txBody>
       </p:sp>
@@ -18812,12 +18812,12 @@
         </p:nvSpPr>
         <p:spPr>
           <a:xfrm>
-            <a:off x="9743846" y="3776472"/>
-            <a:ext cx="1481328" cy="128016"/>
+            <a:off x="9319108" y="3803904"/>
+            <a:ext cx="1370228" cy="118872"/>
           </a:xfrm>
           <a:prstGeom prst="roundRect">
             <a:avLst>
-              <a:gd name="adj" fmla="val 50000"/>
+              <a:gd name="adj" fmla="val 46154"/>
             </a:avLst>
           </a:prstGeom>
           <a:solidFill>
@@ -18834,12 +18834,12 @@
         </p:nvSpPr>
         <p:spPr>
           <a:xfrm>
-            <a:off x="9743846" y="3776472"/>
-            <a:ext cx="1318382" cy="128016"/>
+            <a:off x="9319108" y="3803904"/>
+            <a:ext cx="1219503" cy="118872"/>
           </a:xfrm>
           <a:prstGeom prst="roundRect">
             <a:avLst>
-              <a:gd name="adj" fmla="val 50000"/>
+              <a:gd name="adj" fmla="val 46154"/>
             </a:avLst>
           </a:prstGeom>
           <a:solidFill>
@@ -18856,8 +18856,8 @@
         </p:nvSpPr>
         <p:spPr>
           <a:xfrm>
-            <a:off x="11280038" y="3721608"/>
-            <a:ext cx="296266" cy="256032"/>
+            <a:off x="10780776" y="3739896"/>
+            <a:ext cx="566928" cy="256032"/>
           </a:xfrm>
           <a:prstGeom prst="rect">
             <a:avLst/>
@@ -18898,27 +18898,27 @@
         </p:nvSpPr>
         <p:spPr>
           <a:xfrm>
-            <a:off x="6583680" y="4059936"/>
-            <a:ext cx="3061411" cy="256032"/>
-          </a:xfrm>
-          <a:prstGeom prst="rect">
-            <a:avLst/>
-          </a:prstGeom>
-          <a:noFill/>
-          <a:ln/>
-        </p:spPr>
-        <p:txBody>
-          <a:bodyPr wrap="square" rtlCol="0" anchor="t"/>
-          <a:lstStyle/>
-          <a:p>
-            <a:pPr algn="l" indent="0" marL="0">
-              <a:lnSpc>
-                <a:spcPct val="100000"/>
-              </a:lnSpc>
-              <a:buNone/>
-            </a:pPr>
-            <a:r>
-              <a:rPr lang="en-US" sz="1050" dirty="0">
+            <a:off x="6537960" y="4078224"/>
+            <a:ext cx="2689708" cy="256032"/>
+          </a:xfrm>
+          <a:prstGeom prst="rect">
+            <a:avLst/>
+          </a:prstGeom>
+          <a:noFill/>
+          <a:ln/>
+        </p:spPr>
+        <p:txBody>
+          <a:bodyPr wrap="square" rtlCol="0" anchor="t"/>
+          <a:lstStyle/>
+          <a:p>
+            <a:pPr algn="l" indent="0" marL="0">
+              <a:lnSpc>
+                <a:spcPct val="100000"/>
+              </a:lnSpc>
+              <a:buNone/>
+            </a:pPr>
+            <a:r>
+              <a:rPr lang="en-US" sz="1000" dirty="0">
                 <a:solidFill>
                   <a:srgbClr val="E9EEF7"/>
                 </a:solidFill>
@@ -18928,7 +18928,7 @@
               </a:rPr>
               <a:t>✓  Microprint sharpness</a:t>
             </a:r>
-            <a:endParaRPr lang="en-US" sz="1050" dirty="0"/>
+            <a:endParaRPr lang="en-US" sz="1000" dirty="0"/>
           </a:p>
         </p:txBody>
       </p:sp>
@@ -18940,12 +18940,12 @@
         </p:nvSpPr>
         <p:spPr>
           <a:xfrm>
-            <a:off x="9743846" y="4114800"/>
-            <a:ext cx="1481328" cy="128016"/>
+            <a:off x="9319108" y="4142232"/>
+            <a:ext cx="1370228" cy="118872"/>
           </a:xfrm>
           <a:prstGeom prst="roundRect">
             <a:avLst>
-              <a:gd name="adj" fmla="val 50000"/>
+              <a:gd name="adj" fmla="val 46154"/>
             </a:avLst>
           </a:prstGeom>
           <a:solidFill>
@@ -18962,12 +18962,12 @@
         </p:nvSpPr>
         <p:spPr>
           <a:xfrm>
-            <a:off x="9743846" y="4114800"/>
-            <a:ext cx="1481328" cy="128016"/>
+            <a:off x="9319108" y="4142232"/>
+            <a:ext cx="1370228" cy="118872"/>
           </a:xfrm>
           <a:prstGeom prst="roundRect">
             <a:avLst>
-              <a:gd name="adj" fmla="val 50000"/>
+              <a:gd name="adj" fmla="val 46154"/>
             </a:avLst>
           </a:prstGeom>
           <a:solidFill>
@@ -18984,8 +18984,8 @@
         </p:nvSpPr>
         <p:spPr>
           <a:xfrm>
-            <a:off x="11280038" y="4059936"/>
-            <a:ext cx="296266" cy="256032"/>
+            <a:off x="10780776" y="4078224"/>
+            <a:ext cx="566928" cy="256032"/>
           </a:xfrm>
           <a:prstGeom prst="rect">
             <a:avLst/>
@@ -19026,27 +19026,27 @@
         </p:nvSpPr>
         <p:spPr>
           <a:xfrm>
-            <a:off x="6583680" y="4398264"/>
-            <a:ext cx="3061411" cy="256032"/>
-          </a:xfrm>
-          <a:prstGeom prst="rect">
-            <a:avLst/>
-          </a:prstGeom>
-          <a:noFill/>
-          <a:ln/>
-        </p:spPr>
-        <p:txBody>
-          <a:bodyPr wrap="square" rtlCol="0" anchor="t"/>
-          <a:lstStyle/>
-          <a:p>
-            <a:pPr algn="l" indent="0" marL="0">
-              <a:lnSpc>
-                <a:spcPct val="100000"/>
-              </a:lnSpc>
-              <a:buNone/>
-            </a:pPr>
-            <a:r>
-              <a:rPr lang="en-US" sz="1050" dirty="0">
+            <a:off x="6537960" y="4416552"/>
+            <a:ext cx="2689708" cy="256032"/>
+          </a:xfrm>
+          <a:prstGeom prst="rect">
+            <a:avLst/>
+          </a:prstGeom>
+          <a:noFill/>
+          <a:ln/>
+        </p:spPr>
+        <p:txBody>
+          <a:bodyPr wrap="square" rtlCol="0" anchor="t"/>
+          <a:lstStyle/>
+          <a:p>
+            <a:pPr algn="l" indent="0" marL="0">
+              <a:lnSpc>
+                <a:spcPct val="100000"/>
+              </a:lnSpc>
+              <a:buNone/>
+            </a:pPr>
+            <a:r>
+              <a:rPr lang="en-US" sz="1000" dirty="0">
                 <a:solidFill>
                   <a:srgbClr val="E9EEF7"/>
                 </a:solidFill>
@@ -19056,7 +19056,7 @@
               </a:rPr>
               <a:t>✓  Security thread signature</a:t>
             </a:r>
-            <a:endParaRPr lang="en-US" sz="1050" dirty="0"/>
+            <a:endParaRPr lang="en-US" sz="1000" dirty="0"/>
           </a:p>
         </p:txBody>
       </p:sp>
@@ -19068,12 +19068,12 @@
         </p:nvSpPr>
         <p:spPr>
           <a:xfrm>
-            <a:off x="9743846" y="4453128"/>
-            <a:ext cx="1481328" cy="128016"/>
+            <a:off x="9319108" y="4480560"/>
+            <a:ext cx="1370228" cy="118872"/>
           </a:xfrm>
           <a:prstGeom prst="roundRect">
             <a:avLst>
-              <a:gd name="adj" fmla="val 50000"/>
+              <a:gd name="adj" fmla="val 46154"/>
             </a:avLst>
           </a:prstGeom>
           <a:solidFill>
@@ -19090,12 +19090,12 @@
         </p:nvSpPr>
         <p:spPr>
           <a:xfrm>
-            <a:off x="9743846" y="4453128"/>
-            <a:ext cx="1481328" cy="128016"/>
+            <a:off x="9319108" y="4480560"/>
+            <a:ext cx="1315419" cy="118872"/>
           </a:xfrm>
           <a:prstGeom prst="roundRect">
             <a:avLst>
-              <a:gd name="adj" fmla="val 50000"/>
+              <a:gd name="adj" fmla="val 46154"/>
             </a:avLst>
           </a:prstGeom>
           <a:solidFill>
@@ -19112,8 +19112,8 @@
         </p:nvSpPr>
         <p:spPr>
           <a:xfrm>
-            <a:off x="11280038" y="4398264"/>
-            <a:ext cx="296266" cy="256032"/>
+            <a:off x="10780776" y="4416552"/>
+            <a:ext cx="566928" cy="256032"/>
           </a:xfrm>
           <a:prstGeom prst="rect">
             <a:avLst/>
@@ -19140,7 +19140,7 @@
                 <a:ea typeface="Segoe UI" pitchFamily="34" charset="-122"/>
                 <a:cs typeface="Segoe UI" pitchFamily="34" charset="-120"/>
               </a:rPr>
-              <a:t>100%</a:t>
+              <a:t>96%</a:t>
             </a:r>
             <a:endParaRPr lang="en-US" sz="950" dirty="0"/>
           </a:p>
@@ -19154,27 +19154,27 @@
         </p:nvSpPr>
         <p:spPr>
           <a:xfrm>
-            <a:off x="6583680" y="4736592"/>
-            <a:ext cx="3061411" cy="256032"/>
-          </a:xfrm>
-          <a:prstGeom prst="rect">
-            <a:avLst/>
-          </a:prstGeom>
-          <a:noFill/>
-          <a:ln/>
-        </p:spPr>
-        <p:txBody>
-          <a:bodyPr wrap="square" rtlCol="0" anchor="t"/>
-          <a:lstStyle/>
-          <a:p>
-            <a:pPr algn="l" indent="0" marL="0">
-              <a:lnSpc>
-                <a:spcPct val="100000"/>
-              </a:lnSpc>
-              <a:buNone/>
-            </a:pPr>
-            <a:r>
-              <a:rPr lang="en-US" sz="1050" dirty="0">
+            <a:off x="6537960" y="4754880"/>
+            <a:ext cx="2689708" cy="256032"/>
+          </a:xfrm>
+          <a:prstGeom prst="rect">
+            <a:avLst/>
+          </a:prstGeom>
+          <a:noFill/>
+          <a:ln/>
+        </p:spPr>
+        <p:txBody>
+          <a:bodyPr wrap="square" rtlCol="0" anchor="t"/>
+          <a:lstStyle/>
+          <a:p>
+            <a:pPr algn="l" indent="0" marL="0">
+              <a:lnSpc>
+                <a:spcPct val="100000"/>
+              </a:lnSpc>
+              <a:buNone/>
+            </a:pPr>
+            <a:r>
+              <a:rPr lang="en-US" sz="1000" dirty="0">
                 <a:solidFill>
                   <a:srgbClr val="E9EEF7"/>
                 </a:solidFill>
@@ -19184,7 +19184,7 @@
               </a:rPr>
               <a:t>✓  Intaglio print texture</a:t>
             </a:r>
-            <a:endParaRPr lang="en-US" sz="1050" dirty="0"/>
+            <a:endParaRPr lang="en-US" sz="1000" dirty="0"/>
           </a:p>
         </p:txBody>
       </p:sp>
@@ -19196,12 +19196,12 @@
         </p:nvSpPr>
         <p:spPr>
           <a:xfrm>
-            <a:off x="9743846" y="4791456"/>
-            <a:ext cx="1481328" cy="128016"/>
+            <a:off x="9319108" y="4818888"/>
+            <a:ext cx="1370228" cy="118872"/>
           </a:xfrm>
           <a:prstGeom prst="roundRect">
             <a:avLst>
-              <a:gd name="adj" fmla="val 50000"/>
+              <a:gd name="adj" fmla="val 46154"/>
             </a:avLst>
           </a:prstGeom>
           <a:solidFill>
@@ -19218,12 +19218,12 @@
         </p:nvSpPr>
         <p:spPr>
           <a:xfrm>
-            <a:off x="9743846" y="4791456"/>
-            <a:ext cx="1481328" cy="128016"/>
+            <a:off x="9319108" y="4818888"/>
+            <a:ext cx="1370228" cy="118872"/>
           </a:xfrm>
           <a:prstGeom prst="roundRect">
             <a:avLst>
-              <a:gd name="adj" fmla="val 50000"/>
+              <a:gd name="adj" fmla="val 46154"/>
             </a:avLst>
           </a:prstGeom>
           <a:solidFill>
@@ -19240,8 +19240,8 @@
         </p:nvSpPr>
         <p:spPr>
           <a:xfrm>
-            <a:off x="11280038" y="4736592"/>
-            <a:ext cx="296266" cy="256032"/>
+            <a:off x="10780776" y="4754880"/>
+            <a:ext cx="566928" cy="256032"/>
           </a:xfrm>
           <a:prstGeom prst="rect">
             <a:avLst/>
@@ -19282,27 +19282,27 @@
         </p:nvSpPr>
         <p:spPr>
           <a:xfrm>
-            <a:off x="6583680" y="5074920"/>
-            <a:ext cx="3061411" cy="256032"/>
-          </a:xfrm>
-          <a:prstGeom prst="rect">
-            <a:avLst/>
-          </a:prstGeom>
-          <a:noFill/>
-          <a:ln/>
-        </p:spPr>
-        <p:txBody>
-          <a:bodyPr wrap="square" rtlCol="0" anchor="t"/>
-          <a:lstStyle/>
-          <a:p>
-            <a:pPr algn="l" indent="0" marL="0">
-              <a:lnSpc>
-                <a:spcPct val="100000"/>
-              </a:lnSpc>
-              <a:buNone/>
-            </a:pPr>
-            <a:r>
-              <a:rPr lang="en-US" sz="1050" dirty="0">
+            <a:off x="6537960" y="5093208"/>
+            <a:ext cx="2689708" cy="256032"/>
+          </a:xfrm>
+          <a:prstGeom prst="rect">
+            <a:avLst/>
+          </a:prstGeom>
+          <a:noFill/>
+          <a:ln/>
+        </p:spPr>
+        <p:txBody>
+          <a:bodyPr wrap="square" rtlCol="0" anchor="t"/>
+          <a:lstStyle/>
+          <a:p>
+            <a:pPr algn="l" indent="0" marL="0">
+              <a:lnSpc>
+                <a:spcPct val="100000"/>
+              </a:lnSpc>
+              <a:buNone/>
+            </a:pPr>
+            <a:r>
+              <a:rPr lang="en-US" sz="1000" dirty="0">
                 <a:solidFill>
                   <a:srgbClr val="E9EEF7"/>
                 </a:solidFill>
@@ -19312,7 +19312,7 @@
               </a:rPr>
               <a:t>✓  RBI serial grammar</a:t>
             </a:r>
-            <a:endParaRPr lang="en-US" sz="1050" dirty="0"/>
+            <a:endParaRPr lang="en-US" sz="1000" dirty="0"/>
           </a:p>
         </p:txBody>
       </p:sp>
@@ -19324,12 +19324,12 @@
         </p:nvSpPr>
         <p:spPr>
           <a:xfrm>
-            <a:off x="9743846" y="5129784"/>
-            <a:ext cx="1481328" cy="128016"/>
+            <a:off x="9319108" y="5157216"/>
+            <a:ext cx="1370228" cy="118872"/>
           </a:xfrm>
           <a:prstGeom prst="roundRect">
             <a:avLst>
-              <a:gd name="adj" fmla="val 50000"/>
+              <a:gd name="adj" fmla="val 46154"/>
             </a:avLst>
           </a:prstGeom>
           <a:solidFill>
@@ -19346,12 +19346,12 @@
         </p:nvSpPr>
         <p:spPr>
           <a:xfrm>
-            <a:off x="9743846" y="5129784"/>
-            <a:ext cx="1481328" cy="128016"/>
+            <a:off x="9319108" y="5157216"/>
+            <a:ext cx="1370228" cy="118872"/>
           </a:xfrm>
           <a:prstGeom prst="roundRect">
             <a:avLst>
-              <a:gd name="adj" fmla="val 50000"/>
+              <a:gd name="adj" fmla="val 46154"/>
             </a:avLst>
           </a:prstGeom>
           <a:solidFill>
@@ -19368,8 +19368,8 @@
         </p:nvSpPr>
         <p:spPr>
           <a:xfrm>
-            <a:off x="11280038" y="5074920"/>
-            <a:ext cx="296266" cy="256032"/>
+            <a:off x="10780776" y="5093208"/>
+            <a:ext cx="566928" cy="256032"/>
           </a:xfrm>
           <a:prstGeom prst="rect">
             <a:avLst/>
@@ -19410,29 +19410,29 @@
         </p:nvSpPr>
         <p:spPr>
           <a:xfrm>
-            <a:off x="6583680" y="5413248"/>
-            <a:ext cx="3061411" cy="256032"/>
-          </a:xfrm>
-          <a:prstGeom prst="rect">
-            <a:avLst/>
-          </a:prstGeom>
-          <a:noFill/>
-          <a:ln/>
-        </p:spPr>
-        <p:txBody>
-          <a:bodyPr wrap="square" rtlCol="0" anchor="t"/>
-          <a:lstStyle/>
-          <a:p>
-            <a:pPr algn="l" indent="0" marL="0">
-              <a:lnSpc>
-                <a:spcPct val="100000"/>
-              </a:lnSpc>
-              <a:buNone/>
-            </a:pPr>
-            <a:r>
-              <a:rPr lang="en-US" sz="1050" dirty="0">
-                <a:solidFill>
-                  <a:srgbClr val="FF4D57"/>
+            <a:off x="6537960" y="5431536"/>
+            <a:ext cx="2689708" cy="256032"/>
+          </a:xfrm>
+          <a:prstGeom prst="rect">
+            <a:avLst/>
+          </a:prstGeom>
+          <a:noFill/>
+          <a:ln/>
+        </p:spPr>
+        <p:txBody>
+          <a:bodyPr wrap="square" rtlCol="0" anchor="t"/>
+          <a:lstStyle/>
+          <a:p>
+            <a:pPr algn="l" indent="0" marL="0">
+              <a:lnSpc>
+                <a:spcPct val="100000"/>
+              </a:lnSpc>
+              <a:buNone/>
+            </a:pPr>
+            <a:r>
+              <a:rPr lang="en-US" sz="1000" dirty="0">
+                <a:solidFill>
+                  <a:srgbClr val="F3B6BB"/>
                 </a:solidFill>
                 <a:latin typeface="Segoe UI" pitchFamily="34" charset="0"/>
                 <a:ea typeface="Segoe UI" pitchFamily="34" charset="-122"/>
@@ -19440,7 +19440,7 @@
               </a:rPr>
               <a:t>✗  Watermark window</a:t>
             </a:r>
-            <a:endParaRPr lang="en-US" sz="1050" dirty="0"/>
+            <a:endParaRPr lang="en-US" sz="1000" dirty="0"/>
           </a:p>
         </p:txBody>
       </p:sp>
@@ -19452,12 +19452,12 @@
         </p:nvSpPr>
         <p:spPr>
           <a:xfrm>
-            <a:off x="9743846" y="5468112"/>
-            <a:ext cx="1481328" cy="128016"/>
+            <a:off x="9319108" y="5495544"/>
+            <a:ext cx="1370228" cy="118872"/>
           </a:xfrm>
           <a:prstGeom prst="roundRect">
             <a:avLst>
-              <a:gd name="adj" fmla="val 50000"/>
+              <a:gd name="adj" fmla="val 46154"/>
             </a:avLst>
           </a:prstGeom>
           <a:solidFill>
@@ -19474,12 +19474,12 @@
         </p:nvSpPr>
         <p:spPr>
           <a:xfrm>
-            <a:off x="9743846" y="5468112"/>
-            <a:ext cx="1259129" cy="128016"/>
+            <a:off x="9319108" y="5495544"/>
+            <a:ext cx="575496" cy="118872"/>
           </a:xfrm>
           <a:prstGeom prst="roundRect">
             <a:avLst>
-              <a:gd name="adj" fmla="val 50000"/>
+              <a:gd name="adj" fmla="val 46154"/>
             </a:avLst>
           </a:prstGeom>
           <a:solidFill>
@@ -19496,8 +19496,8 @@
         </p:nvSpPr>
         <p:spPr>
           <a:xfrm>
-            <a:off x="11280038" y="5413248"/>
-            <a:ext cx="296266" cy="256032"/>
+            <a:off x="10780776" y="5431536"/>
+            <a:ext cx="566928" cy="256032"/>
           </a:xfrm>
           <a:prstGeom prst="rect">
             <a:avLst/>
@@ -19524,7 +19524,7 @@
                 <a:ea typeface="Segoe UI" pitchFamily="34" charset="-122"/>
                 <a:cs typeface="Segoe UI" pitchFamily="34" charset="-120"/>
               </a:rPr>
-              <a:t>85%</a:t>
+              <a:t>42%</a:t>
             </a:r>
             <a:endParaRPr lang="en-US" sz="950" dirty="0"/>
           </a:p>
@@ -19538,27 +19538,27 @@
         </p:nvSpPr>
         <p:spPr>
           <a:xfrm>
-            <a:off x="6583680" y="5751576"/>
-            <a:ext cx="3061411" cy="256032"/>
-          </a:xfrm>
-          <a:prstGeom prst="rect">
-            <a:avLst/>
-          </a:prstGeom>
-          <a:noFill/>
-          <a:ln/>
-        </p:spPr>
-        <p:txBody>
-          <a:bodyPr wrap="square" rtlCol="0" anchor="t"/>
-          <a:lstStyle/>
-          <a:p>
-            <a:pPr algn="l" indent="0" marL="0">
-              <a:lnSpc>
-                <a:spcPct val="100000"/>
-              </a:lnSpc>
-              <a:buNone/>
-            </a:pPr>
-            <a:r>
-              <a:rPr lang="en-US" sz="1050" dirty="0">
+            <a:off x="6537960" y="5769864"/>
+            <a:ext cx="2689708" cy="256032"/>
+          </a:xfrm>
+          <a:prstGeom prst="rect">
+            <a:avLst/>
+          </a:prstGeom>
+          <a:noFill/>
+          <a:ln/>
+        </p:spPr>
+        <p:txBody>
+          <a:bodyPr wrap="square" rtlCol="0" anchor="t"/>
+          <a:lstStyle/>
+          <a:p>
+            <a:pPr algn="l" indent="0" marL="0">
+              <a:lnSpc>
+                <a:spcPct val="100000"/>
+              </a:lnSpc>
+              <a:buNone/>
+            </a:pPr>
+            <a:r>
+              <a:rPr lang="en-US" sz="1000" dirty="0">
                 <a:solidFill>
                   <a:srgbClr val="E9EEF7"/>
                 </a:solidFill>
@@ -19568,7 +19568,7 @@
               </a:rPr>
               <a:t>✓  Colour-shift ink numeral</a:t>
             </a:r>
-            <a:endParaRPr lang="en-US" sz="1050" dirty="0"/>
+            <a:endParaRPr lang="en-US" sz="1000" dirty="0"/>
           </a:p>
         </p:txBody>
       </p:sp>
@@ -19580,12 +19580,12 @@
         </p:nvSpPr>
         <p:spPr>
           <a:xfrm>
-            <a:off x="9743846" y="5806440"/>
-            <a:ext cx="1481328" cy="128016"/>
+            <a:off x="9319108" y="5833872"/>
+            <a:ext cx="1370228" cy="118872"/>
           </a:xfrm>
           <a:prstGeom prst="roundRect">
             <a:avLst>
-              <a:gd name="adj" fmla="val 50000"/>
+              <a:gd name="adj" fmla="val 46154"/>
             </a:avLst>
           </a:prstGeom>
           <a:solidFill>
@@ -19602,12 +19602,12 @@
         </p:nvSpPr>
         <p:spPr>
           <a:xfrm>
-            <a:off x="9743846" y="5806440"/>
-            <a:ext cx="1481328" cy="128016"/>
+            <a:off x="9319108" y="5833872"/>
+            <a:ext cx="1370228" cy="118872"/>
           </a:xfrm>
           <a:prstGeom prst="roundRect">
             <a:avLst>
-              <a:gd name="adj" fmla="val 50000"/>
+              <a:gd name="adj" fmla="val 46154"/>
             </a:avLst>
           </a:prstGeom>
           <a:solidFill>
@@ -19624,8 +19624,8 @@
         </p:nvSpPr>
         <p:spPr>
           <a:xfrm>
-            <a:off x="11280038" y="5751576"/>
-            <a:ext cx="296266" cy="256032"/>
+            <a:off x="10780776" y="5769864"/>
+            <a:ext cx="566928" cy="256032"/>
           </a:xfrm>
           <a:prstGeom prst="rect">
             <a:avLst/>

</xml_diff>